<commit_message>
Aggiunge slide prototipo->produzione e distingue runtime nello stack
Pilastro 1 (Architettura): nuova slide finale "Dal banco di lavoro al
prodotto" — Claude Code prototipa, l'Agent SDK spedisce. Messaggio chiave:
il passaggio all'IA agentica non e' un problema di modello, e' ingegneristico
(scaffold, harness, permessi, modello via API).

Nota leggera nello Stack: distinte le righe Runtime prototipo (Claude Code)
e Runtime produzione (Agent SDK + API).

Deck 19 slide + 2 backup (27 slide PPTX, 12 SVG). MD/HTML/PPTX riallineati.

Co-Authored-By: Claude Opus 4.8 <noreply@anthropic.com>
</commit_message>
<xml_diff>
--- a/output/presentazione_ia_produttiva.pptx
+++ b/output/presentazione_ia_produttiva.pptx
@@ -31,6 +31,7 @@
     <p:sldId id="291" r:id="rId42"/>
     <p:sldId id="292" r:id="rId43"/>
     <p:sldId id="293" r:id="rId44"/>
+    <p:sldId id="294" r:id="rId45"/>
   </p:sldIdLst>
   <p:notesMasterIdLst>
     <p:notesMasterId r:id="rId14"/>
@@ -2507,7 +2508,7 @@
                 <a:gridCol w="3566160"/>
                 <a:gridCol w="2743200"/>
               </a:tblGrid>
-              <a:tr h="396240">
+              <a:tr h="356616">
                 <a:tc>
                   <a:txBody>
                     <a:bodyPr wrap="square"/>
@@ -2578,7 +2579,7 @@
                   </a:tcPr>
                 </a:tc>
               </a:tr>
-              <a:tr h="396240">
+              <a:tr h="356616">
                 <a:tc>
                   <a:txBody>
                     <a:bodyPr wrap="square"/>
@@ -2649,7 +2650,7 @@
                   </a:tcPr>
                 </a:tc>
               </a:tr>
-              <a:tr h="396240">
+              <a:tr h="356616">
                 <a:tc>
                   <a:txBody>
                     <a:bodyPr wrap="square"/>
@@ -2663,7 +2664,7 @@
                           </a:solidFill>
                           <a:latin typeface="Montserrat"/>
                         </a:rPr>
-                        <a:t>Runtime</a:t>
+                        <a:t>Runtime · prototipo</a:t>
                       </a:r>
                     </a:p>
                   </a:txBody>
@@ -2709,7 +2710,7 @@
                           </a:solidFill>
                           <a:latin typeface="Montserrat"/>
                         </a:rPr>
-                        <a:t>Esecuzione agenti, tool use, integrazioni</a:t>
+                        <a:t>Esplorazione, tool use, sviluppo agenti</a:t>
                       </a:r>
                     </a:p>
                   </a:txBody>
@@ -2720,7 +2721,7 @@
                   </a:tcPr>
                 </a:tc>
               </a:tr>
-              <a:tr h="396240">
+              <a:tr h="356616">
                 <a:tc>
                   <a:txBody>
                     <a:bodyPr wrap="square"/>
@@ -2734,12 +2735,154 @@
                           </a:solidFill>
                           <a:latin typeface="Montserrat"/>
                         </a:rPr>
+                        <a:t>Runtime · produzione</a:t>
+                      </a:r>
+                    </a:p>
+                  </a:txBody>
+                  <a:tcPr marL="128016" marR="91440" marT="27432" marB="27432" anchor="ctr">
+                    <a:solidFill>
+                      <a:srgbClr val="FFFFFF"/>
+                    </a:solidFill>
+                  </a:tcPr>
+                </a:tc>
+                <a:tc>
+                  <a:txBody>
+                    <a:bodyPr wrap="square"/>
+                    <a:lstStyle/>
+                    <a:p>
+                      <a:pPr algn="l"/>
+                      <a:r>
+                        <a:rPr sz="1050" b="0">
+                          <a:solidFill>
+                            <a:srgbClr val="1A1A2E"/>
+                          </a:solidFill>
+                          <a:latin typeface="Montserrat"/>
+                        </a:rPr>
+                        <a:t>Agent SDK · API</a:t>
+                      </a:r>
+                    </a:p>
+                  </a:txBody>
+                  <a:tcPr marL="128016" marR="91440" marT="27432" marB="27432" anchor="ctr">
+                    <a:solidFill>
+                      <a:srgbClr val="FFFFFF"/>
+                    </a:solidFill>
+                  </a:tcPr>
+                </a:tc>
+                <a:tc>
+                  <a:txBody>
+                    <a:bodyPr wrap="square"/>
+                    <a:lstStyle/>
+                    <a:p>
+                      <a:pPr algn="l"/>
+                      <a:r>
+                        <a:rPr sz="1050" b="0">
+                          <a:solidFill>
+                            <a:srgbClr val="1A1A2E"/>
+                          </a:solidFill>
+                          <a:latin typeface="Montserrat"/>
+                        </a:rPr>
+                        <a:t>Agenti in scope ristretto, modello via API</a:t>
+                      </a:r>
+                    </a:p>
+                  </a:txBody>
+                  <a:tcPr marL="128016" marR="91440" marT="27432" marB="27432" anchor="ctr">
+                    <a:solidFill>
+                      <a:srgbClr val="FFFFFF"/>
+                    </a:solidFill>
+                  </a:tcPr>
+                </a:tc>
+              </a:tr>
+              <a:tr h="356616">
+                <a:tc>
+                  <a:txBody>
+                    <a:bodyPr wrap="square"/>
+                    <a:lstStyle/>
+                    <a:p>
+                      <a:pPr algn="l"/>
+                      <a:r>
+                        <a:rPr sz="1050" b="1">
+                          <a:solidFill>
+                            <a:srgbClr val="003BA3"/>
+                          </a:solidFill>
+                          <a:latin typeface="Montserrat"/>
+                        </a:rPr>
                         <a:t>Calcolo</a:t>
                       </a:r>
                     </a:p>
                   </a:txBody>
                   <a:tcPr marL="128016" marR="91440" marT="27432" marB="27432" anchor="ctr">
                     <a:solidFill>
+                      <a:srgbClr val="F5F7FA"/>
+                    </a:solidFill>
+                  </a:tcPr>
+                </a:tc>
+                <a:tc>
+                  <a:txBody>
+                    <a:bodyPr wrap="square"/>
+                    <a:lstStyle/>
+                    <a:p>
+                      <a:pPr algn="l"/>
+                      <a:r>
+                        <a:rPr sz="1050" b="0">
+                          <a:solidFill>
+                            <a:srgbClr val="1A1A2E"/>
+                          </a:solidFill>
+                          <a:latin typeface="Montserrat"/>
+                        </a:rPr>
+                        <a:t>Python 3.11+</a:t>
+                      </a:r>
+                    </a:p>
+                  </a:txBody>
+                  <a:tcPr marL="128016" marR="91440" marT="27432" marB="27432" anchor="ctr">
+                    <a:solidFill>
+                      <a:srgbClr val="F5F7FA"/>
+                    </a:solidFill>
+                  </a:tcPr>
+                </a:tc>
+                <a:tc>
+                  <a:txBody>
+                    <a:bodyPr wrap="square"/>
+                    <a:lstStyle/>
+                    <a:p>
+                      <a:pPr algn="l"/>
+                      <a:r>
+                        <a:rPr sz="1050" b="0">
+                          <a:solidFill>
+                            <a:srgbClr val="1A1A2E"/>
+                          </a:solidFill>
+                          <a:latin typeface="Montserrat"/>
+                        </a:rPr>
+                        <a:t>Modelli finanziari · 348 test automatizzati</a:t>
+                      </a:r>
+                    </a:p>
+                  </a:txBody>
+                  <a:tcPr marL="128016" marR="91440" marT="27432" marB="27432" anchor="ctr">
+                    <a:solidFill>
+                      <a:srgbClr val="F5F7FA"/>
+                    </a:solidFill>
+                  </a:tcPr>
+                </a:tc>
+              </a:tr>
+              <a:tr h="356616">
+                <a:tc>
+                  <a:txBody>
+                    <a:bodyPr wrap="square"/>
+                    <a:lstStyle/>
+                    <a:p>
+                      <a:pPr algn="l"/>
+                      <a:r>
+                        <a:rPr sz="1050" b="1">
+                          <a:solidFill>
+                            <a:srgbClr val="003BA3"/>
+                          </a:solidFill>
+                          <a:latin typeface="Montserrat"/>
+                        </a:rPr>
+                        <a:t>Skill layer</a:t>
+                      </a:r>
+                    </a:p>
+                  </a:txBody>
+                  <a:tcPr marL="128016" marR="91440" marT="27432" marB="27432" anchor="ctr">
+                    <a:solidFill>
                       <a:srgbClr val="FFFFFF"/>
                     </a:solidFill>
                   </a:tcPr>
@@ -2757,7 +2900,7 @@
                           </a:solidFill>
                           <a:latin typeface="Montserrat"/>
                         </a:rPr>
-                        <a:t>Python 3.11+</a:t>
+                        <a:t>Markdown strutturato</a:t>
                       </a:r>
                     </a:p>
                   </a:txBody>
@@ -2780,7 +2923,7 @@
                           </a:solidFill>
                           <a:latin typeface="Montserrat"/>
                         </a:rPr>
-                        <a:t>Modelli finanziari · 348 test automatizzati</a:t>
+                        <a:t>Workflow, vincoli, checkpoint</a:t>
                       </a:r>
                     </a:p>
                   </a:txBody>
@@ -2791,7 +2934,7 @@
                   </a:tcPr>
                 </a:tc>
               </a:tr>
-              <a:tr h="396240">
+              <a:tr h="356616">
                 <a:tc>
                   <a:txBody>
                     <a:bodyPr wrap="square"/>
@@ -2805,7 +2948,7 @@
                           </a:solidFill>
                           <a:latin typeface="Montserrat"/>
                         </a:rPr>
-                        <a:t>Skill layer</a:t>
+                        <a:t>Dati di mercato</a:t>
                       </a:r>
                     </a:p>
                   </a:txBody>
@@ -2828,7 +2971,7 @@
                           </a:solidFill>
                           <a:latin typeface="Montserrat"/>
                         </a:rPr>
-                        <a:t>Markdown strutturato</a:t>
+                        <a:t>Massive · FactSet · Capital IQ · Refinitiv</a:t>
                       </a:r>
                     </a:p>
                   </a:txBody>
@@ -2851,7 +2994,7 @@
                           </a:solidFill>
                           <a:latin typeface="Montserrat"/>
                         </a:rPr>
-                        <a:t>Workflow, vincoli, checkpoint</a:t>
+                        <a:t>Prezzi, fondamentali, consensus</a:t>
                       </a:r>
                     </a:p>
                   </a:txBody>
@@ -2862,7 +3005,7 @@
                   </a:tcPr>
                 </a:tc>
               </a:tr>
-              <a:tr h="396240">
+              <a:tr h="356616">
                 <a:tc>
                   <a:txBody>
                     <a:bodyPr wrap="square"/>
@@ -2876,7 +3019,7 @@
                           </a:solidFill>
                           <a:latin typeface="Montserrat"/>
                         </a:rPr>
-                        <a:t>Dati di mercato</a:t>
+                        <a:t>Parametri settore</a:t>
                       </a:r>
                     </a:p>
                   </a:txBody>
@@ -2899,7 +3042,7 @@
                           </a:solidFill>
                           <a:latin typeface="Montserrat"/>
                         </a:rPr>
-                        <a:t>Massive · FactSet · Capital IQ · Refinitiv</a:t>
+                        <a:t>Damodaran NYU Stern</a:t>
                       </a:r>
                     </a:p>
                   </a:txBody>
@@ -2922,7 +3065,7 @@
                           </a:solidFill>
                           <a:latin typeface="Montserrat"/>
                         </a:rPr>
-                        <a:t>Prezzi, fondamentali, consensus</a:t>
+                        <a:t>Beta, ERP, multipli, WACC settoriali</a:t>
                       </a:r>
                     </a:p>
                   </a:txBody>
@@ -2933,7 +3076,7 @@
                   </a:tcPr>
                 </a:tc>
               </a:tr>
-              <a:tr h="396240">
+              <a:tr h="356616">
                 <a:tc>
                   <a:txBody>
                     <a:bodyPr wrap="square"/>
@@ -2947,7 +3090,7 @@
                           </a:solidFill>
                           <a:latin typeface="Montserrat"/>
                         </a:rPr>
-                        <a:t>Parametri settore</a:t>
+                        <a:t>Società italiane</a:t>
                       </a:r>
                     </a:p>
                   </a:txBody>
@@ -2970,7 +3113,7 @@
                           </a:solidFill>
                           <a:latin typeface="Montserrat"/>
                         </a:rPr>
-                        <a:t>Damodaran NYU Stern</a:t>
+                        <a:t>Bureau van Dijk (AIDA) · CONSOB · Borsa Italiana</a:t>
                       </a:r>
                     </a:p>
                   </a:txBody>
@@ -2993,7 +3136,7 @@
                           </a:solidFill>
                           <a:latin typeface="Montserrat"/>
                         </a:rPr>
-                        <a:t>Beta, ERP, multipli, WACC settoriali</a:t>
+                        <a:t>Bilanci, dati societari, depositi</a:t>
                       </a:r>
                     </a:p>
                   </a:txBody>
@@ -3004,7 +3147,7 @@
                   </a:tcPr>
                 </a:tc>
               </a:tr>
-              <a:tr h="396240">
+              <a:tr h="356616">
                 <a:tc>
                   <a:txBody>
                     <a:bodyPr wrap="square"/>
@@ -3018,7 +3161,7 @@
                           </a:solidFill>
                           <a:latin typeface="Montserrat"/>
                         </a:rPr>
-                        <a:t>Società italiane</a:t>
+                        <a:t>Versionamento</a:t>
                       </a:r>
                     </a:p>
                   </a:txBody>
@@ -3041,7 +3184,7 @@
                           </a:solidFill>
                           <a:latin typeface="Montserrat"/>
                         </a:rPr>
-                        <a:t>Bureau van Dijk (AIDA) · CONSOB · Borsa Italiana</a:t>
+                        <a:t>Git + GitHub</a:t>
                       </a:r>
                     </a:p>
                   </a:txBody>
@@ -3064,84 +3207,13 @@
                           </a:solidFill>
                           <a:latin typeface="Montserrat"/>
                         </a:rPr>
-                        <a:t>Bilanci, dati societari, depositi</a:t>
+                        <a:t>Audit trail, collaborazione</a:t>
                       </a:r>
                     </a:p>
                   </a:txBody>
                   <a:tcPr marL="128016" marR="91440" marT="27432" marB="27432" anchor="ctr">
                     <a:solidFill>
                       <a:srgbClr val="FFFFFF"/>
-                    </a:solidFill>
-                  </a:tcPr>
-                </a:tc>
-              </a:tr>
-              <a:tr h="396240">
-                <a:tc>
-                  <a:txBody>
-                    <a:bodyPr wrap="square"/>
-                    <a:lstStyle/>
-                    <a:p>
-                      <a:pPr algn="l"/>
-                      <a:r>
-                        <a:rPr sz="1050" b="1">
-                          <a:solidFill>
-                            <a:srgbClr val="003BA3"/>
-                          </a:solidFill>
-                          <a:latin typeface="Montserrat"/>
-                        </a:rPr>
-                        <a:t>Versionamento</a:t>
-                      </a:r>
-                    </a:p>
-                  </a:txBody>
-                  <a:tcPr marL="128016" marR="91440" marT="27432" marB="27432" anchor="ctr">
-                    <a:solidFill>
-                      <a:srgbClr val="F5F7FA"/>
-                    </a:solidFill>
-                  </a:tcPr>
-                </a:tc>
-                <a:tc>
-                  <a:txBody>
-                    <a:bodyPr wrap="square"/>
-                    <a:lstStyle/>
-                    <a:p>
-                      <a:pPr algn="l"/>
-                      <a:r>
-                        <a:rPr sz="1050" b="0">
-                          <a:solidFill>
-                            <a:srgbClr val="1A1A2E"/>
-                          </a:solidFill>
-                          <a:latin typeface="Montserrat"/>
-                        </a:rPr>
-                        <a:t>Git + GitHub</a:t>
-                      </a:r>
-                    </a:p>
-                  </a:txBody>
-                  <a:tcPr marL="128016" marR="91440" marT="27432" marB="27432" anchor="ctr">
-                    <a:solidFill>
-                      <a:srgbClr val="F5F7FA"/>
-                    </a:solidFill>
-                  </a:tcPr>
-                </a:tc>
-                <a:tc>
-                  <a:txBody>
-                    <a:bodyPr wrap="square"/>
-                    <a:lstStyle/>
-                    <a:p>
-                      <a:pPr algn="l"/>
-                      <a:r>
-                        <a:rPr sz="1050" b="0">
-                          <a:solidFill>
-                            <a:srgbClr val="1A1A2E"/>
-                          </a:solidFill>
-                          <a:latin typeface="Montserrat"/>
-                        </a:rPr>
-                        <a:t>Audit trail, collaborazione</a:t>
-                      </a:r>
-                    </a:p>
-                  </a:txBody>
-                  <a:tcPr marL="128016" marR="91440" marT="27432" marB="27432" anchor="ctr">
-                    <a:solidFill>
-                      <a:srgbClr val="F5F7FA"/>
                     </a:solidFill>
                   </a:tcPr>
                 </a:tc>
@@ -3170,54 +3242,14 @@
       <p:grpSpPr/>
       <p:sp>
         <p:nvSpPr>
-          <p:cNvPr id="2" name="Shape 0"/>
-          <p:cNvSpPr/>
-          <p:nvPr/>
-        </p:nvSpPr>
-        <p:spPr>
-          <a:xfrm>
-            <a:off x="2560320" y="-274320"/>
-            <a:ext cx="1645920" cy="2926080"/>
-          </a:xfrm>
-          <a:prstGeom prst="rect">
-            <a:avLst/>
-          </a:prstGeom>
-          <a:solidFill>
-            <a:srgbClr val="4A8CFF"/>
-          </a:solidFill>
-          <a:ln/>
-        </p:spPr>
-      </p:sp>
-      <p:sp>
-        <p:nvSpPr>
-          <p:cNvPr id="3" name="Shape 1"/>
-          <p:cNvSpPr/>
-          <p:nvPr/>
-        </p:nvSpPr>
-        <p:spPr>
-          <a:xfrm>
-            <a:off x="1371600" y="2377440"/>
-            <a:ext cx="1645920" cy="1828800"/>
-          </a:xfrm>
-          <a:prstGeom prst="rect">
-            <a:avLst/>
-          </a:prstGeom>
-          <a:solidFill>
-            <a:srgbClr val="F5F7FA"/>
-          </a:solidFill>
-          <a:ln/>
-        </p:spPr>
-      </p:sp>
-      <p:sp>
-        <p:nvSpPr>
-          <p:cNvPr id="4" name="Text 2"/>
-          <p:cNvSpPr/>
-          <p:nvPr/>
-        </p:nvSpPr>
-        <p:spPr>
-          <a:xfrm>
-            <a:off x="4572000" y="914400"/>
-            <a:ext cx="4114800" cy="1097280"/>
+          <p:cNvPr id="2" name="Text 0"/>
+          <p:cNvSpPr/>
+          <p:nvPr/>
+        </p:nvSpPr>
+        <p:spPr>
+          <a:xfrm>
+            <a:off x="548640" y="228600"/>
+            <a:ext cx="8046720" cy="594360"/>
           </a:xfrm>
           <a:prstGeom prst="rect">
             <a:avLst/>
@@ -3229,50 +3261,11 @@
           <a:bodyPr wrap="square" lIns="0" tIns="0" rIns="0" bIns="0" rtlCol="0" anchor="ctr"/>
           <a:lstStyle/>
           <a:p>
-            <a:pPr algn="ctr" indent="0" marL="0">
+            <a:pPr indent="0" marL="0">
               <a:buNone/>
             </a:pPr>
             <a:r>
-              <a:rPr lang="en-US" sz="7200" b="1" dirty="0">
-                <a:solidFill>
-                  <a:srgbClr val="4A8CFF"/>
-                </a:solidFill>
-                <a:latin typeface="Montserrat" pitchFamily="34" charset="0"/>
-                <a:ea typeface="Montserrat" pitchFamily="34" charset="-122"/>
-                <a:cs typeface="Montserrat" pitchFamily="34" charset="-120"/>
-              </a:rPr>
-              <a:t>02</a:t>
-            </a:r>
-            <a:endParaRPr lang="en-US" sz="7200" dirty="0"/>
-          </a:p>
-        </p:txBody>
-      </p:sp>
-      <p:sp>
-        <p:nvSpPr>
-          <p:cNvPr id="5" name="Text 3"/>
-          <p:cNvSpPr/>
-          <p:nvPr/>
-        </p:nvSpPr>
-        <p:spPr>
-          <a:xfrm>
-            <a:off x="4572000" y="2011680"/>
-            <a:ext cx="4114800" cy="731520"/>
-          </a:xfrm>
-          <a:prstGeom prst="rect">
-            <a:avLst/>
-          </a:prstGeom>
-          <a:noFill/>
-          <a:ln/>
-        </p:spPr>
-        <p:txBody>
-          <a:bodyPr wrap="square" lIns="0" tIns="0" rIns="0" bIns="0" rtlCol="0" anchor="ctr"/>
-          <a:lstStyle/>
-          <a:p>
-            <a:pPr algn="ctr" indent="0" marL="0">
-              <a:buNone/>
-            </a:pPr>
-            <a:r>
-              <a:rPr lang="en-US" sz="3600" b="1" dirty="0">
+              <a:rPr lang="en-US" sz="2400" b="1" dirty="0">
                 <a:solidFill>
                   <a:srgbClr val="003BA3"/>
                 </a:solidFill>
@@ -3280,51 +3273,82 @@
                 <a:ea typeface="Montserrat" pitchFamily="34" charset="-122"/>
                 <a:cs typeface="Montserrat" pitchFamily="34" charset="-120"/>
               </a:rPr>
-              <a:t>Dominio</a:t>
+              <a:t>Dal banco di lavoro al prodotto: prototipo → produzione</a:t>
             </a:r>
-            <a:endParaRPr lang="en-US" sz="3600" dirty="0"/>
+            <a:endParaRPr lang="en-US" sz="2800" dirty="0"/>
           </a:p>
         </p:txBody>
       </p:sp>
       <p:sp>
         <p:nvSpPr>
-          <p:cNvPr id="6" name="Text 4"/>
-          <p:cNvSpPr/>
-          <p:nvPr/>
-        </p:nvSpPr>
-        <p:spPr>
-          <a:xfrm>
-            <a:off x="4572000" y="2743200"/>
-            <a:ext cx="4114800" cy="457200"/>
-          </a:xfrm>
-          <a:prstGeom prst="rect">
-            <a:avLst/>
-          </a:prstGeom>
-          <a:noFill/>
-          <a:ln/>
-        </p:spPr>
-        <p:txBody>
-          <a:bodyPr wrap="square" lIns="0" tIns="0" rIns="0" bIns="0" rtlCol="0" anchor="ctr"/>
-          <a:lstStyle/>
-          <a:p>
-            <a:pPr algn="ctr" indent="0" marL="0">
-              <a:buNone/>
-            </a:pPr>
-            <a:r>
-              <a:rPr lang="en-US" sz="1400" dirty="0">
-                <a:solidFill>
-                  <a:srgbClr val="4A4A5A"/>
-                </a:solidFill>
-                <a:latin typeface="Montserrat" pitchFamily="34" charset="0"/>
-                <a:ea typeface="Montserrat" pitchFamily="34" charset="-122"/>
-                <a:cs typeface="Montserrat" pitchFamily="34" charset="-120"/>
-              </a:rPr>
-              <a:t>La conoscenza che rende l'IA competente</a:t>
-            </a:r>
-            <a:endParaRPr lang="en-US" sz="1400" dirty="0"/>
-          </a:p>
-        </p:txBody>
-      </p:sp>
+          <p:cNvPr id="3" name="Shape 1"/>
+          <p:cNvSpPr/>
+          <p:nvPr/>
+        </p:nvSpPr>
+        <p:spPr>
+          <a:xfrm>
+            <a:off x="0" y="4942332"/>
+            <a:ext cx="5029200" cy="201168"/>
+          </a:xfrm>
+          <a:prstGeom prst="rect">
+            <a:avLst/>
+          </a:prstGeom>
+          <a:solidFill>
+            <a:srgbClr val="003BA3"/>
+          </a:solidFill>
+          <a:ln/>
+        </p:spPr>
+      </p:sp>
+      <p:sp>
+        <p:nvSpPr>
+          <p:cNvPr id="4" name="Shape 2"/>
+          <p:cNvSpPr/>
+          <p:nvPr/>
+        </p:nvSpPr>
+        <p:spPr>
+          <a:xfrm>
+            <a:off x="5029200" y="4942332"/>
+            <a:ext cx="4114800" cy="201168"/>
+          </a:xfrm>
+          <a:prstGeom prst="rect">
+            <a:avLst/>
+          </a:prstGeom>
+          <a:solidFill>
+            <a:srgbClr val="4A8CFF"/>
+          </a:solidFill>
+          <a:ln/>
+        </p:spPr>
+      </p:sp>
+      <p:pic>
+        <p:nvPicPr>
+          <p:cNvPr id="5" name="Picture 4" descr="image.png"/>
+          <p:cNvPicPr>
+            <a:picLocks noChangeAspect="1"/>
+          </p:cNvPicPr>
+          <p:nvPr/>
+        </p:nvPicPr>
+        <p:blipFill>
+          <a:blip r:embed="rId2">
+            <a:extLst>
+              <a:ext uri="{96DAC541-7B7A-43D3-8B79-37D633B846F1}">
+                <ns0:svgBlip xmlns:ns0="http://schemas.microsoft.com/office/drawing/2016/SVG/main" r:embed="rId3"/>
+              </a:ext>
+            </a:extLst>
+          </a:blip>
+          <a:stretch>
+            <a:fillRect/>
+          </a:stretch>
+        </p:blipFill>
+        <p:spPr>
+          <a:xfrm>
+            <a:off x="411480" y="1078992"/>
+            <a:ext cx="8321040" cy="3703320"/>
+          </a:xfrm>
+          <a:prstGeom prst="rect">
+            <a:avLst/>
+          </a:prstGeom>
+        </p:spPr>
+      </p:pic>
     </p:spTree>
   </p:cSld>
   <p:clrMapOvr>
@@ -3345,14 +3369,54 @@
       <p:grpSpPr/>
       <p:sp>
         <p:nvSpPr>
-          <p:cNvPr id="2" name="Text 0"/>
-          <p:cNvSpPr/>
-          <p:nvPr/>
-        </p:nvSpPr>
-        <p:spPr>
-          <a:xfrm>
-            <a:off x="548640" y="228600"/>
-            <a:ext cx="8046720" cy="594360"/>
+          <p:cNvPr id="2" name="Shape 0"/>
+          <p:cNvSpPr/>
+          <p:nvPr/>
+        </p:nvSpPr>
+        <p:spPr>
+          <a:xfrm>
+            <a:off x="2560320" y="-274320"/>
+            <a:ext cx="1645920" cy="2926080"/>
+          </a:xfrm>
+          <a:prstGeom prst="rect">
+            <a:avLst/>
+          </a:prstGeom>
+          <a:solidFill>
+            <a:srgbClr val="4A8CFF"/>
+          </a:solidFill>
+          <a:ln/>
+        </p:spPr>
+      </p:sp>
+      <p:sp>
+        <p:nvSpPr>
+          <p:cNvPr id="3" name="Shape 1"/>
+          <p:cNvSpPr/>
+          <p:nvPr/>
+        </p:nvSpPr>
+        <p:spPr>
+          <a:xfrm>
+            <a:off x="1371600" y="2377440"/>
+            <a:ext cx="1645920" cy="1828800"/>
+          </a:xfrm>
+          <a:prstGeom prst="rect">
+            <a:avLst/>
+          </a:prstGeom>
+          <a:solidFill>
+            <a:srgbClr val="F5F7FA"/>
+          </a:solidFill>
+          <a:ln/>
+        </p:spPr>
+      </p:sp>
+      <p:sp>
+        <p:nvSpPr>
+          <p:cNvPr id="4" name="Text 2"/>
+          <p:cNvSpPr/>
+          <p:nvPr/>
+        </p:nvSpPr>
+        <p:spPr>
+          <a:xfrm>
+            <a:off x="4572000" y="914400"/>
+            <a:ext cx="4114800" cy="1097280"/>
           </a:xfrm>
           <a:prstGeom prst="rect">
             <a:avLst/>
@@ -3364,11 +3428,50 @@
           <a:bodyPr wrap="square" lIns="0" tIns="0" rIns="0" bIns="0" rtlCol="0" anchor="ctr"/>
           <a:lstStyle/>
           <a:p>
-            <a:pPr indent="0" marL="0">
+            <a:pPr algn="ctr" indent="0" marL="0">
               <a:buNone/>
             </a:pPr>
             <a:r>
-              <a:rPr lang="en-US" sz="2400" b="1" dirty="0">
+              <a:rPr lang="en-US" sz="7200" b="1" dirty="0">
+                <a:solidFill>
+                  <a:srgbClr val="4A8CFF"/>
+                </a:solidFill>
+                <a:latin typeface="Montserrat" pitchFamily="34" charset="0"/>
+                <a:ea typeface="Montserrat" pitchFamily="34" charset="-122"/>
+                <a:cs typeface="Montserrat" pitchFamily="34" charset="-120"/>
+              </a:rPr>
+              <a:t>02</a:t>
+            </a:r>
+            <a:endParaRPr lang="en-US" sz="7200" dirty="0"/>
+          </a:p>
+        </p:txBody>
+      </p:sp>
+      <p:sp>
+        <p:nvSpPr>
+          <p:cNvPr id="5" name="Text 3"/>
+          <p:cNvSpPr/>
+          <p:nvPr/>
+        </p:nvSpPr>
+        <p:spPr>
+          <a:xfrm>
+            <a:off x="4572000" y="2011680"/>
+            <a:ext cx="4114800" cy="731520"/>
+          </a:xfrm>
+          <a:prstGeom prst="rect">
+            <a:avLst/>
+          </a:prstGeom>
+          <a:noFill/>
+          <a:ln/>
+        </p:spPr>
+        <p:txBody>
+          <a:bodyPr wrap="square" lIns="0" tIns="0" rIns="0" bIns="0" rtlCol="0" anchor="ctr"/>
+          <a:lstStyle/>
+          <a:p>
+            <a:pPr algn="ctr" indent="0" marL="0">
+              <a:buNone/>
+            </a:pPr>
+            <a:r>
+              <a:rPr lang="en-US" sz="3600" b="1" dirty="0">
                 <a:solidFill>
                   <a:srgbClr val="003BA3"/>
                 </a:solidFill>
@@ -3376,82 +3479,51 @@
                 <a:ea typeface="Montserrat" pitchFamily="34" charset="-122"/>
                 <a:cs typeface="Montserrat" pitchFamily="34" charset="-120"/>
               </a:rPr>
-              <a:t>Il brillante incompetente: senza dominio sbaglia</a:t>
+              <a:t>Dominio</a:t>
             </a:r>
-            <a:endParaRPr lang="en-US" sz="2800" dirty="0"/>
+            <a:endParaRPr lang="en-US" sz="3600" dirty="0"/>
           </a:p>
         </p:txBody>
       </p:sp>
       <p:sp>
         <p:nvSpPr>
-          <p:cNvPr id="3" name="Shape 1"/>
-          <p:cNvSpPr/>
-          <p:nvPr/>
-        </p:nvSpPr>
-        <p:spPr>
-          <a:xfrm>
-            <a:off x="0" y="4942332"/>
-            <a:ext cx="5029200" cy="201168"/>
-          </a:xfrm>
-          <a:prstGeom prst="rect">
-            <a:avLst/>
-          </a:prstGeom>
-          <a:solidFill>
-            <a:srgbClr val="003BA3"/>
-          </a:solidFill>
-          <a:ln/>
-        </p:spPr>
-      </p:sp>
-      <p:sp>
-        <p:nvSpPr>
-          <p:cNvPr id="4" name="Shape 2"/>
-          <p:cNvSpPr/>
-          <p:nvPr/>
-        </p:nvSpPr>
-        <p:spPr>
-          <a:xfrm>
-            <a:off x="5029200" y="4942332"/>
-            <a:ext cx="4114800" cy="201168"/>
-          </a:xfrm>
-          <a:prstGeom prst="rect">
-            <a:avLst/>
-          </a:prstGeom>
-          <a:solidFill>
-            <a:srgbClr val="4A8CFF"/>
-          </a:solidFill>
-          <a:ln/>
-        </p:spPr>
-      </p:sp>
-      <p:pic>
-        <p:nvPicPr>
-          <p:cNvPr id="5" name="Picture 4" descr="image.png"/>
-          <p:cNvPicPr>
-            <a:picLocks noChangeAspect="1"/>
-          </p:cNvPicPr>
-          <p:nvPr/>
-        </p:nvPicPr>
-        <p:blipFill>
-          <a:blip r:embed="rId2">
-            <a:extLst>
-              <a:ext uri="{96DAC541-7B7A-43D3-8B79-37D633B846F1}">
-                <ns0:svgBlip xmlns:ns0="http://schemas.microsoft.com/office/drawing/2016/SVG/main" r:embed="rId3"/>
-              </a:ext>
-            </a:extLst>
-          </a:blip>
-          <a:stretch>
-            <a:fillRect/>
-          </a:stretch>
-        </p:blipFill>
-        <p:spPr>
-          <a:xfrm>
-            <a:off x="411480" y="1078992"/>
-            <a:ext cx="8321040" cy="3703320"/>
-          </a:xfrm>
-          <a:prstGeom prst="rect">
-            <a:avLst/>
-          </a:prstGeom>
-        </p:spPr>
-      </p:pic>
+          <p:cNvPr id="6" name="Text 4"/>
+          <p:cNvSpPr/>
+          <p:nvPr/>
+        </p:nvSpPr>
+        <p:spPr>
+          <a:xfrm>
+            <a:off x="4572000" y="2743200"/>
+            <a:ext cx="4114800" cy="457200"/>
+          </a:xfrm>
+          <a:prstGeom prst="rect">
+            <a:avLst/>
+          </a:prstGeom>
+          <a:noFill/>
+          <a:ln/>
+        </p:spPr>
+        <p:txBody>
+          <a:bodyPr wrap="square" lIns="0" tIns="0" rIns="0" bIns="0" rtlCol="0" anchor="ctr"/>
+          <a:lstStyle/>
+          <a:p>
+            <a:pPr algn="ctr" indent="0" marL="0">
+              <a:buNone/>
+            </a:pPr>
+            <a:r>
+              <a:rPr lang="en-US" sz="1400" dirty="0">
+                <a:solidFill>
+                  <a:srgbClr val="4A4A5A"/>
+                </a:solidFill>
+                <a:latin typeface="Montserrat" pitchFamily="34" charset="0"/>
+                <a:ea typeface="Montserrat" pitchFamily="34" charset="-122"/>
+                <a:cs typeface="Montserrat" pitchFamily="34" charset="-120"/>
+              </a:rPr>
+              <a:t>La conoscenza che rende l'IA competente</a:t>
+            </a:r>
+            <a:endParaRPr lang="en-US" sz="1400" dirty="0"/>
+          </a:p>
+        </p:txBody>
+      </p:sp>
     </p:spTree>
   </p:cSld>
   <p:clrMapOvr>
@@ -3503,7 +3575,7 @@
                 <a:ea typeface="Montserrat" pitchFamily="34" charset="-122"/>
                 <a:cs typeface="Montserrat" pitchFamily="34" charset="-120"/>
               </a:rPr>
-              <a:t>Il dominio si codifica: paper → codice → skill</a:t>
+              <a:t>Il brillante incompetente: senza dominio sbaglia</a:t>
             </a:r>
             <a:endParaRPr lang="en-US" sz="2800" dirty="0"/>
           </a:p>
@@ -3622,7 +3694,7 @@
               <a:buNone/>
             </a:pPr>
             <a:r>
-              <a:rPr lang="en-US" sz="2100" b="1" dirty="0">
+              <a:rPr lang="en-US" sz="2400" b="1" dirty="0">
                 <a:solidFill>
                   <a:srgbClr val="003BA3"/>
                 </a:solidFill>
@@ -3630,7 +3702,7 @@
                 <a:ea typeface="Montserrat" pitchFamily="34" charset="-122"/>
                 <a:cs typeface="Montserrat" pitchFamily="34" charset="-120"/>
               </a:rPr>
-              <a:t>La compliance come dominio: il porting al framework europeo</a:t>
+              <a:t>Il dominio si codifica: paper → codice → skill</a:t>
             </a:r>
             <a:endParaRPr lang="en-US" sz="2800" dirty="0"/>
           </a:p>
@@ -3676,672 +3748,36 @@
           <a:ln/>
         </p:spPr>
       </p:sp>
-      <p:graphicFrame>
-        <p:nvGraphicFramePr>
-          <p:cNvPr id="5" name="Table 4"/>
-          <p:cNvGraphicFramePr>
-            <a:graphicFrameLocks noGrp="1"/>
-          </p:cNvGraphicFramePr>
-          <p:nvPr/>
-        </p:nvGraphicFramePr>
-        <p:xfrm>
-          <a:off x="548640" y="1097280"/>
-          <a:ext cx="8046720" cy="3566160"/>
-        </p:xfrm>
-        <a:graphic>
-          <a:graphicData uri="http://schemas.openxmlformats.org/drawingml/2006/table">
-            <a:tbl>
-              <a:tblPr>
-                <a:tableStyleId>{5C22544A-7EE6-4342-B048-85BDC9FD1C3A}</a:tableStyleId>
-              </a:tblPr>
-              <a:tblGrid>
-                <a:gridCol w="1828800"/>
-                <a:gridCol w="2194560"/>
-                <a:gridCol w="4023360"/>
-              </a:tblGrid>
-              <a:tr h="396240">
-                <a:tc>
-                  <a:txBody>
-                    <a:bodyPr wrap="square"/>
-                    <a:lstStyle/>
-                    <a:p>
-                      <a:pPr algn="l"/>
-                      <a:r>
-                        <a:rPr sz="1200" b="1">
-                          <a:solidFill>
-                            <a:srgbClr val="FFFFFF"/>
-                          </a:solidFill>
-                          <a:latin typeface="Montserrat"/>
-                        </a:rPr>
-                        <a:t>Ambito</a:t>
-                      </a:r>
-                    </a:p>
-                  </a:txBody>
-                  <a:tcPr marL="128016" marR="91440" marT="27432" marB="27432" anchor="ctr">
-                    <a:solidFill>
-                      <a:srgbClr val="003BA3"/>
-                    </a:solidFill>
-                  </a:tcPr>
-                </a:tc>
-                <a:tc>
-                  <a:txBody>
-                    <a:bodyPr wrap="square"/>
-                    <a:lstStyle/>
-                    <a:p>
-                      <a:pPr algn="l"/>
-                      <a:r>
-                        <a:rPr sz="1200" b="1">
-                          <a:solidFill>
-                            <a:srgbClr val="FFFFFF"/>
-                          </a:solidFill>
-                          <a:latin typeface="Montserrat"/>
-                        </a:rPr>
-                        <a:t>Normativa</a:t>
-                      </a:r>
-                    </a:p>
-                  </a:txBody>
-                  <a:tcPr marL="128016" marR="91440" marT="27432" marB="27432" anchor="ctr">
-                    <a:solidFill>
-                      <a:srgbClr val="003BA3"/>
-                    </a:solidFill>
-                  </a:tcPr>
-                </a:tc>
-                <a:tc>
-                  <a:txBody>
-                    <a:bodyPr wrap="square"/>
-                    <a:lstStyle/>
-                    <a:p>
-                      <a:pPr algn="l"/>
-                      <a:r>
-                        <a:rPr sz="1200" b="1">
-                          <a:solidFill>
-                            <a:srgbClr val="FFFFFF"/>
-                          </a:solidFill>
-                          <a:latin typeface="Montserrat"/>
-                        </a:rPr>
-                        <a:t>Cosa fa l'IA</a:t>
-                      </a:r>
-                    </a:p>
-                  </a:txBody>
-                  <a:tcPr marL="128016" marR="91440" marT="27432" marB="27432" anchor="ctr">
-                    <a:solidFill>
-                      <a:srgbClr val="003BA3"/>
-                    </a:solidFill>
-                  </a:tcPr>
-                </a:tc>
-              </a:tr>
-              <a:tr h="396240">
-                <a:tc>
-                  <a:txBody>
-                    <a:bodyPr wrap="square"/>
-                    <a:lstStyle/>
-                    <a:p>
-                      <a:pPr algn="l"/>
-                      <a:r>
-                        <a:rPr sz="1100" b="1">
-                          <a:solidFill>
-                            <a:srgbClr val="003BA3"/>
-                          </a:solidFill>
-                          <a:latin typeface="Montserrat"/>
-                        </a:rPr>
-                        <a:t>Antitrust</a:t>
-                      </a:r>
-                    </a:p>
-                  </a:txBody>
-                  <a:tcPr marL="128016" marR="91440" marT="27432" marB="27432" anchor="ctr">
-                    <a:solidFill>
-                      <a:srgbClr val="FFFFFF"/>
-                    </a:solidFill>
-                  </a:tcPr>
-                </a:tc>
-                <a:tc>
-                  <a:txBody>
-                    <a:bodyPr wrap="square"/>
-                    <a:lstStyle/>
-                    <a:p>
-                      <a:pPr algn="l"/>
-                      <a:r>
-                        <a:rPr sz="1100" b="0">
-                          <a:solidFill>
-                            <a:srgbClr val="1A1A2E"/>
-                          </a:solidFill>
-                          <a:latin typeface="Montserrat"/>
-                        </a:rPr>
-                        <a:t>AGCM</a:t>
-                      </a:r>
-                    </a:p>
-                  </a:txBody>
-                  <a:tcPr marL="128016" marR="91440" marT="27432" marB="27432" anchor="ctr">
-                    <a:solidFill>
-                      <a:srgbClr val="FFFFFF"/>
-                    </a:solidFill>
-                  </a:tcPr>
-                </a:tc>
-                <a:tc>
-                  <a:txBody>
-                    <a:bodyPr wrap="square"/>
-                    <a:lstStyle/>
-                    <a:p>
-                      <a:pPr algn="l"/>
-                      <a:r>
-                        <a:rPr sz="1100" b="0">
-                          <a:solidFill>
-                            <a:srgbClr val="1A1A2E"/>
-                          </a:solidFill>
-                          <a:latin typeface="Montserrat"/>
-                        </a:rPr>
-                        <a:t>Verifica soglie fatturato (532M/32M €)</a:t>
-                      </a:r>
-                    </a:p>
-                  </a:txBody>
-                  <a:tcPr marL="128016" marR="91440" marT="27432" marB="27432" anchor="ctr">
-                    <a:solidFill>
-                      <a:srgbClr val="FFFFFF"/>
-                    </a:solidFill>
-                  </a:tcPr>
-                </a:tc>
-              </a:tr>
-              <a:tr h="396240">
-                <a:tc>
-                  <a:txBody>
-                    <a:bodyPr wrap="square"/>
-                    <a:lstStyle/>
-                    <a:p>
-                      <a:pPr algn="l"/>
-                      <a:r>
-                        <a:rPr sz="1100" b="1">
-                          <a:solidFill>
-                            <a:srgbClr val="003BA3"/>
-                          </a:solidFill>
-                          <a:latin typeface="Montserrat"/>
-                        </a:rPr>
-                        <a:t>Settori strategici</a:t>
-                      </a:r>
-                    </a:p>
-                  </a:txBody>
-                  <a:tcPr marL="128016" marR="91440" marT="27432" marB="27432" anchor="ctr">
-                    <a:solidFill>
-                      <a:srgbClr val="F5F7FA"/>
-                    </a:solidFill>
-                  </a:tcPr>
-                </a:tc>
-                <a:tc>
-                  <a:txBody>
-                    <a:bodyPr wrap="square"/>
-                    <a:lstStyle/>
-                    <a:p>
-                      <a:pPr algn="l"/>
-                      <a:r>
-                        <a:rPr sz="1100" b="0">
-                          <a:solidFill>
-                            <a:srgbClr val="1A1A2E"/>
-                          </a:solidFill>
-                          <a:latin typeface="Montserrat"/>
-                        </a:rPr>
-                        <a:t>Golden Power</a:t>
-                      </a:r>
-                    </a:p>
-                  </a:txBody>
-                  <a:tcPr marL="128016" marR="91440" marT="27432" marB="27432" anchor="ctr">
-                    <a:solidFill>
-                      <a:srgbClr val="F5F7FA"/>
-                    </a:solidFill>
-                  </a:tcPr>
-                </a:tc>
-                <a:tc>
-                  <a:txBody>
-                    <a:bodyPr wrap="square"/>
-                    <a:lstStyle/>
-                    <a:p>
-                      <a:pPr algn="l"/>
-                      <a:r>
-                        <a:rPr sz="1100" b="0">
-                          <a:solidFill>
-                            <a:srgbClr val="1A1A2E"/>
-                          </a:solidFill>
-                          <a:latin typeface="Montserrat"/>
-                        </a:rPr>
-                        <a:t>Flag settori D.L. 21/2012</a:t>
-                      </a:r>
-                    </a:p>
-                  </a:txBody>
-                  <a:tcPr marL="128016" marR="91440" marT="27432" marB="27432" anchor="ctr">
-                    <a:solidFill>
-                      <a:srgbClr val="F5F7FA"/>
-                    </a:solidFill>
-                  </a:tcPr>
-                </a:tc>
-              </a:tr>
-              <a:tr h="396240">
-                <a:tc>
-                  <a:txBody>
-                    <a:bodyPr wrap="square"/>
-                    <a:lstStyle/>
-                    <a:p>
-                      <a:pPr algn="l"/>
-                      <a:r>
-                        <a:rPr sz="1100" b="1">
-                          <a:solidFill>
-                            <a:srgbClr val="003BA3"/>
-                          </a:solidFill>
-                          <a:latin typeface="Montserrat"/>
-                        </a:rPr>
-                        <a:t>Mercati</a:t>
-                      </a:r>
-                    </a:p>
-                  </a:txBody>
-                  <a:tcPr marL="128016" marR="91440" marT="27432" marB="27432" anchor="ctr">
-                    <a:solidFill>
-                      <a:srgbClr val="FFFFFF"/>
-                    </a:solidFill>
-                  </a:tcPr>
-                </a:tc>
-                <a:tc>
-                  <a:txBody>
-                    <a:bodyPr wrap="square"/>
-                    <a:lstStyle/>
-                    <a:p>
-                      <a:pPr algn="l"/>
-                      <a:r>
-                        <a:rPr sz="1100" b="0">
-                          <a:solidFill>
-                            <a:srgbClr val="1A1A2E"/>
-                          </a:solidFill>
-                          <a:latin typeface="Montserrat"/>
-                        </a:rPr>
-                        <a:t>CONSOB</a:t>
-                      </a:r>
-                    </a:p>
-                  </a:txBody>
-                  <a:tcPr marL="128016" marR="91440" marT="27432" marB="27432" anchor="ctr">
-                    <a:solidFill>
-                      <a:srgbClr val="FFFFFF"/>
-                    </a:solidFill>
-                  </a:tcPr>
-                </a:tc>
-                <a:tc>
-                  <a:txBody>
-                    <a:bodyPr wrap="square"/>
-                    <a:lstStyle/>
-                    <a:p>
-                      <a:pPr algn="l"/>
-                      <a:r>
-                        <a:rPr sz="1100" b="0">
-                          <a:solidFill>
-                            <a:srgbClr val="1A1A2E"/>
-                          </a:solidFill>
-                          <a:latin typeface="Montserrat"/>
-                        </a:rPr>
-                        <a:t>Conformità Regolamento Emittenti</a:t>
-                      </a:r>
-                    </a:p>
-                  </a:txBody>
-                  <a:tcPr marL="128016" marR="91440" marT="27432" marB="27432" anchor="ctr">
-                    <a:solidFill>
-                      <a:srgbClr val="FFFFFF"/>
-                    </a:solidFill>
-                  </a:tcPr>
-                </a:tc>
-              </a:tr>
-              <a:tr h="396240">
-                <a:tc>
-                  <a:txBody>
-                    <a:bodyPr wrap="square"/>
-                    <a:lstStyle/>
-                    <a:p>
-                      <a:pPr algn="l"/>
-                      <a:r>
-                        <a:rPr sz="1100" b="1">
-                          <a:solidFill>
-                            <a:srgbClr val="003BA3"/>
-                          </a:solidFill>
-                          <a:latin typeface="Montserrat"/>
-                        </a:rPr>
-                        <a:t>Adeguatezza</a:t>
-                      </a:r>
-                    </a:p>
-                  </a:txBody>
-                  <a:tcPr marL="128016" marR="91440" marT="27432" marB="27432" anchor="ctr">
-                    <a:solidFill>
-                      <a:srgbClr val="F5F7FA"/>
-                    </a:solidFill>
-                  </a:tcPr>
-                </a:tc>
-                <a:tc>
-                  <a:txBody>
-                    <a:bodyPr wrap="square"/>
-                    <a:lstStyle/>
-                    <a:p>
-                      <a:pPr algn="l"/>
-                      <a:r>
-                        <a:rPr sz="1100" b="0">
-                          <a:solidFill>
-                            <a:srgbClr val="1A1A2E"/>
-                          </a:solidFill>
-                          <a:latin typeface="Montserrat"/>
-                        </a:rPr>
-                        <a:t>MiFID II</a:t>
-                      </a:r>
-                    </a:p>
-                  </a:txBody>
-                  <a:tcPr marL="128016" marR="91440" marT="27432" marB="27432" anchor="ctr">
-                    <a:solidFill>
-                      <a:srgbClr val="F5F7FA"/>
-                    </a:solidFill>
-                  </a:tcPr>
-                </a:tc>
-                <a:tc>
-                  <a:txBody>
-                    <a:bodyPr wrap="square"/>
-                    <a:lstStyle/>
-                    <a:p>
-                      <a:pPr algn="l"/>
-                      <a:r>
-                        <a:rPr sz="1100" b="0">
-                          <a:solidFill>
-                            <a:srgbClr val="1A1A2E"/>
-                          </a:solidFill>
-                          <a:latin typeface="Montserrat"/>
-                        </a:rPr>
-                        <a:t>Profiling, target market, ESG</a:t>
-                      </a:r>
-                    </a:p>
-                  </a:txBody>
-                  <a:tcPr marL="128016" marR="91440" marT="27432" marB="27432" anchor="ctr">
-                    <a:solidFill>
-                      <a:srgbClr val="F5F7FA"/>
-                    </a:solidFill>
-                  </a:tcPr>
-                </a:tc>
-              </a:tr>
-              <a:tr h="396240">
-                <a:tc>
-                  <a:txBody>
-                    <a:bodyPr wrap="square"/>
-                    <a:lstStyle/>
-                    <a:p>
-                      <a:pPr algn="l"/>
-                      <a:r>
-                        <a:rPr sz="1100" b="1">
-                          <a:solidFill>
-                            <a:srgbClr val="003BA3"/>
-                          </a:solidFill>
-                          <a:latin typeface="Montserrat"/>
-                        </a:rPr>
-                        <a:t>Antiriciclaggio</a:t>
-                      </a:r>
-                    </a:p>
-                  </a:txBody>
-                  <a:tcPr marL="128016" marR="91440" marT="27432" marB="27432" anchor="ctr">
-                    <a:solidFill>
-                      <a:srgbClr val="FFFFFF"/>
-                    </a:solidFill>
-                  </a:tcPr>
-                </a:tc>
-                <a:tc>
-                  <a:txBody>
-                    <a:bodyPr wrap="square"/>
-                    <a:lstStyle/>
-                    <a:p>
-                      <a:pPr algn="l"/>
-                      <a:r>
-                        <a:rPr sz="1100" b="0">
-                          <a:solidFill>
-                            <a:srgbClr val="1A1A2E"/>
-                          </a:solidFill>
-                          <a:latin typeface="Montserrat"/>
-                        </a:rPr>
-                        <a:t>D.Lgs. 231/2007</a:t>
-                      </a:r>
-                    </a:p>
-                  </a:txBody>
-                  <a:tcPr marL="128016" marR="91440" marT="27432" marB="27432" anchor="ctr">
-                    <a:solidFill>
-                      <a:srgbClr val="FFFFFF"/>
-                    </a:solidFill>
-                  </a:tcPr>
-                </a:tc>
-                <a:tc>
-                  <a:txBody>
-                    <a:bodyPr wrap="square"/>
-                    <a:lstStyle/>
-                    <a:p>
-                      <a:pPr algn="l"/>
-                      <a:r>
-                        <a:rPr sz="1100" b="0">
-                          <a:solidFill>
-                            <a:srgbClr val="1A1A2E"/>
-                          </a:solidFill>
-                          <a:latin typeface="Montserrat"/>
-                        </a:rPr>
-                        <a:t>3 livelli di adeguata verifica</a:t>
-                      </a:r>
-                    </a:p>
-                  </a:txBody>
-                  <a:tcPr marL="128016" marR="91440" marT="27432" marB="27432" anchor="ctr">
-                    <a:solidFill>
-                      <a:srgbClr val="FFFFFF"/>
-                    </a:solidFill>
-                  </a:tcPr>
-                </a:tc>
-              </a:tr>
-              <a:tr h="396240">
-                <a:tc>
-                  <a:txBody>
-                    <a:bodyPr wrap="square"/>
-                    <a:lstStyle/>
-                    <a:p>
-                      <a:pPr algn="l"/>
-                      <a:r>
-                        <a:rPr sz="1100" b="1">
-                          <a:solidFill>
-                            <a:srgbClr val="003BA3"/>
-                          </a:solidFill>
-                          <a:latin typeface="Montserrat"/>
-                        </a:rPr>
-                        <a:t>Sostenibilità</a:t>
-                      </a:r>
-                    </a:p>
-                  </a:txBody>
-                  <a:tcPr marL="128016" marR="91440" marT="27432" marB="27432" anchor="ctr">
-                    <a:solidFill>
-                      <a:srgbClr val="F5F7FA"/>
-                    </a:solidFill>
-                  </a:tcPr>
-                </a:tc>
-                <a:tc>
-                  <a:txBody>
-                    <a:bodyPr wrap="square"/>
-                    <a:lstStyle/>
-                    <a:p>
-                      <a:pPr algn="l"/>
-                      <a:r>
-                        <a:rPr sz="1100" b="0">
-                          <a:solidFill>
-                            <a:srgbClr val="1A1A2E"/>
-                          </a:solidFill>
-                          <a:latin typeface="Montserrat"/>
-                        </a:rPr>
-                        <a:t>SFDR</a:t>
-                      </a:r>
-                    </a:p>
-                  </a:txBody>
-                  <a:tcPr marL="128016" marR="91440" marT="27432" marB="27432" anchor="ctr">
-                    <a:solidFill>
-                      <a:srgbClr val="F5F7FA"/>
-                    </a:solidFill>
-                  </a:tcPr>
-                </a:tc>
-                <a:tc>
-                  <a:txBody>
-                    <a:bodyPr wrap="square"/>
-                    <a:lstStyle/>
-                    <a:p>
-                      <a:pPr algn="l"/>
-                      <a:r>
-                        <a:rPr sz="1100" b="0">
-                          <a:solidFill>
-                            <a:srgbClr val="1A1A2E"/>
-                          </a:solidFill>
-                          <a:latin typeface="Montserrat"/>
-                        </a:rPr>
-                        <a:t>Classificazione art. 6/8/9</a:t>
-                      </a:r>
-                    </a:p>
-                  </a:txBody>
-                  <a:tcPr marL="128016" marR="91440" marT="27432" marB="27432" anchor="ctr">
-                    <a:solidFill>
-                      <a:srgbClr val="F5F7FA"/>
-                    </a:solidFill>
-                  </a:tcPr>
-                </a:tc>
-              </a:tr>
-              <a:tr h="396240">
-                <a:tc>
-                  <a:txBody>
-                    <a:bodyPr wrap="square"/>
-                    <a:lstStyle/>
-                    <a:p>
-                      <a:pPr algn="l"/>
-                      <a:r>
-                        <a:rPr sz="1100" b="1">
-                          <a:solidFill>
-                            <a:srgbClr val="003BA3"/>
-                          </a:solidFill>
-                          <a:latin typeface="Montserrat"/>
-                        </a:rPr>
-                        <a:t>Resilienza</a:t>
-                      </a:r>
-                    </a:p>
-                  </a:txBody>
-                  <a:tcPr marL="128016" marR="91440" marT="27432" marB="27432" anchor="ctr">
-                    <a:solidFill>
-                      <a:srgbClr val="FFFFFF"/>
-                    </a:solidFill>
-                  </a:tcPr>
-                </a:tc>
-                <a:tc>
-                  <a:txBody>
-                    <a:bodyPr wrap="square"/>
-                    <a:lstStyle/>
-                    <a:p>
-                      <a:pPr algn="l"/>
-                      <a:r>
-                        <a:rPr sz="1100" b="0">
-                          <a:solidFill>
-                            <a:srgbClr val="1A1A2E"/>
-                          </a:solidFill>
-                          <a:latin typeface="Montserrat"/>
-                        </a:rPr>
-                        <a:t>DORA</a:t>
-                      </a:r>
-                    </a:p>
-                  </a:txBody>
-                  <a:tcPr marL="128016" marR="91440" marT="27432" marB="27432" anchor="ctr">
-                    <a:solidFill>
-                      <a:srgbClr val="FFFFFF"/>
-                    </a:solidFill>
-                  </a:tcPr>
-                </a:tc>
-                <a:tc>
-                  <a:txBody>
-                    <a:bodyPr wrap="square"/>
-                    <a:lstStyle/>
-                    <a:p>
-                      <a:pPr algn="l"/>
-                      <a:r>
-                        <a:rPr sz="1100" b="0">
-                          <a:solidFill>
-                            <a:srgbClr val="1A1A2E"/>
-                          </a:solidFill>
-                          <a:latin typeface="Montserrat"/>
-                        </a:rPr>
-                        <a:t>Check Reg. UE 2022/2554</a:t>
-                      </a:r>
-                    </a:p>
-                  </a:txBody>
-                  <a:tcPr marL="128016" marR="91440" marT="27432" marB="27432" anchor="ctr">
-                    <a:solidFill>
-                      <a:srgbClr val="FFFFFF"/>
-                    </a:solidFill>
-                  </a:tcPr>
-                </a:tc>
-              </a:tr>
-              <a:tr h="396240">
-                <a:tc>
-                  <a:txBody>
-                    <a:bodyPr wrap="square"/>
-                    <a:lstStyle/>
-                    <a:p>
-                      <a:pPr algn="l"/>
-                      <a:r>
-                        <a:rPr sz="1100" b="1">
-                          <a:solidFill>
-                            <a:srgbClr val="003BA3"/>
-                          </a:solidFill>
-                          <a:latin typeface="Montserrat"/>
-                        </a:rPr>
-                        <a:t>Fiscalità</a:t>
-                      </a:r>
-                    </a:p>
-                  </a:txBody>
-                  <a:tcPr marL="128016" marR="91440" marT="27432" marB="27432" anchor="ctr">
-                    <a:solidFill>
-                      <a:srgbClr val="F5F7FA"/>
-                    </a:solidFill>
-                  </a:tcPr>
-                </a:tc>
-                <a:tc>
-                  <a:txBody>
-                    <a:bodyPr wrap="square"/>
-                    <a:lstStyle/>
-                    <a:p>
-                      <a:pPr algn="l"/>
-                      <a:r>
-                        <a:rPr sz="1100" b="0">
-                          <a:solidFill>
-                            <a:srgbClr val="1A1A2E"/>
-                          </a:solidFill>
-                          <a:latin typeface="Montserrat"/>
-                        </a:rPr>
-                        <a:t>IRES+IRAP</a:t>
-                      </a:r>
-                    </a:p>
-                  </a:txBody>
-                  <a:tcPr marL="128016" marR="91440" marT="27432" marB="27432" anchor="ctr">
-                    <a:solidFill>
-                      <a:srgbClr val="F5F7FA"/>
-                    </a:solidFill>
-                  </a:tcPr>
-                </a:tc>
-                <a:tc>
-                  <a:txBody>
-                    <a:bodyPr wrap="square"/>
-                    <a:lstStyle/>
-                    <a:p>
-                      <a:pPr algn="l"/>
-                      <a:r>
-                        <a:rPr sz="1100" b="0">
-                          <a:solidFill>
-                            <a:srgbClr val="1A1A2E"/>
-                          </a:solidFill>
-                          <a:latin typeface="Montserrat"/>
-                        </a:rPr>
-                        <a:t>Parametri automatici per l'Italia</a:t>
-                      </a:r>
-                    </a:p>
-                  </a:txBody>
-                  <a:tcPr marL="128016" marR="91440" marT="27432" marB="27432" anchor="ctr">
-                    <a:solidFill>
-                      <a:srgbClr val="F5F7FA"/>
-                    </a:solidFill>
-                  </a:tcPr>
-                </a:tc>
-              </a:tr>
-            </a:tbl>
-          </a:graphicData>
-        </a:graphic>
-      </p:graphicFrame>
+      <p:pic>
+        <p:nvPicPr>
+          <p:cNvPr id="5" name="Picture 4" descr="image.png"/>
+          <p:cNvPicPr>
+            <a:picLocks noChangeAspect="1"/>
+          </p:cNvPicPr>
+          <p:nvPr/>
+        </p:nvPicPr>
+        <p:blipFill>
+          <a:blip r:embed="rId2">
+            <a:extLst>
+              <a:ext uri="{96DAC541-7B7A-43D3-8B79-37D633B846F1}">
+                <ns0:svgBlip xmlns:ns0="http://schemas.microsoft.com/office/drawing/2016/SVG/main" r:embed="rId3"/>
+              </a:ext>
+            </a:extLst>
+          </a:blip>
+          <a:stretch>
+            <a:fillRect/>
+          </a:stretch>
+        </p:blipFill>
+        <p:spPr>
+          <a:xfrm>
+            <a:off x="411480" y="1078992"/>
+            <a:ext cx="8321040" cy="3703320"/>
+          </a:xfrm>
+          <a:prstGeom prst="rect">
+            <a:avLst/>
+          </a:prstGeom>
+        </p:spPr>
+      </p:pic>
     </p:spTree>
   </p:cSld>
   <p:clrMapOvr>
@@ -4393,7 +3829,7 @@
                 <a:ea typeface="Montserrat" pitchFamily="34" charset="-122"/>
                 <a:cs typeface="Montserrat" pitchFamily="34" charset="-120"/>
               </a:rPr>
-              <a:t>Arricchire il dominio: dallo strumento alla suite integrata</a:t>
+              <a:t>La compliance come dominio: il porting al framework europeo</a:t>
             </a:r>
             <a:endParaRPr lang="en-US" sz="2800" dirty="0"/>
           </a:p>
@@ -4439,36 +3875,672 @@
           <a:ln/>
         </p:spPr>
       </p:sp>
-      <p:pic>
-        <p:nvPicPr>
-          <p:cNvPr id="5" name="Picture 4" descr="image.png"/>
-          <p:cNvPicPr>
-            <a:picLocks noChangeAspect="1"/>
-          </p:cNvPicPr>
-          <p:nvPr/>
-        </p:nvPicPr>
-        <p:blipFill>
-          <a:blip r:embed="rId2">
-            <a:extLst>
-              <a:ext uri="{96DAC541-7B7A-43D3-8B79-37D633B846F1}">
-                <ns0:svgBlip xmlns:ns0="http://schemas.microsoft.com/office/drawing/2016/SVG/main" r:embed="rId3"/>
-              </a:ext>
-            </a:extLst>
-          </a:blip>
-          <a:stretch>
-            <a:fillRect/>
-          </a:stretch>
-        </p:blipFill>
-        <p:spPr>
-          <a:xfrm>
-            <a:off x="411480" y="1078992"/>
-            <a:ext cx="8321040" cy="3703320"/>
-          </a:xfrm>
-          <a:prstGeom prst="rect">
-            <a:avLst/>
-          </a:prstGeom>
-        </p:spPr>
-      </p:pic>
+      <p:graphicFrame>
+        <p:nvGraphicFramePr>
+          <p:cNvPr id="5" name="Table 4"/>
+          <p:cNvGraphicFramePr>
+            <a:graphicFrameLocks noGrp="1"/>
+          </p:cNvGraphicFramePr>
+          <p:nvPr/>
+        </p:nvGraphicFramePr>
+        <p:xfrm>
+          <a:off x="548640" y="1097280"/>
+          <a:ext cx="8046720" cy="3566160"/>
+        </p:xfrm>
+        <a:graphic>
+          <a:graphicData uri="http://schemas.openxmlformats.org/drawingml/2006/table">
+            <a:tbl>
+              <a:tblPr>
+                <a:tableStyleId>{5C22544A-7EE6-4342-B048-85BDC9FD1C3A}</a:tableStyleId>
+              </a:tblPr>
+              <a:tblGrid>
+                <a:gridCol w="1828800"/>
+                <a:gridCol w="2194560"/>
+                <a:gridCol w="4023360"/>
+              </a:tblGrid>
+              <a:tr h="396240">
+                <a:tc>
+                  <a:txBody>
+                    <a:bodyPr wrap="square"/>
+                    <a:lstStyle/>
+                    <a:p>
+                      <a:pPr algn="l"/>
+                      <a:r>
+                        <a:rPr sz="1200" b="1">
+                          <a:solidFill>
+                            <a:srgbClr val="FFFFFF"/>
+                          </a:solidFill>
+                          <a:latin typeface="Montserrat"/>
+                        </a:rPr>
+                        <a:t>Ambito</a:t>
+                      </a:r>
+                    </a:p>
+                  </a:txBody>
+                  <a:tcPr marL="128016" marR="91440" marT="27432" marB="27432" anchor="ctr">
+                    <a:solidFill>
+                      <a:srgbClr val="003BA3"/>
+                    </a:solidFill>
+                  </a:tcPr>
+                </a:tc>
+                <a:tc>
+                  <a:txBody>
+                    <a:bodyPr wrap="square"/>
+                    <a:lstStyle/>
+                    <a:p>
+                      <a:pPr algn="l"/>
+                      <a:r>
+                        <a:rPr sz="1200" b="1">
+                          <a:solidFill>
+                            <a:srgbClr val="FFFFFF"/>
+                          </a:solidFill>
+                          <a:latin typeface="Montserrat"/>
+                        </a:rPr>
+                        <a:t>Normativa</a:t>
+                      </a:r>
+                    </a:p>
+                  </a:txBody>
+                  <a:tcPr marL="128016" marR="91440" marT="27432" marB="27432" anchor="ctr">
+                    <a:solidFill>
+                      <a:srgbClr val="003BA3"/>
+                    </a:solidFill>
+                  </a:tcPr>
+                </a:tc>
+                <a:tc>
+                  <a:txBody>
+                    <a:bodyPr wrap="square"/>
+                    <a:lstStyle/>
+                    <a:p>
+                      <a:pPr algn="l"/>
+                      <a:r>
+                        <a:rPr sz="1200" b="1">
+                          <a:solidFill>
+                            <a:srgbClr val="FFFFFF"/>
+                          </a:solidFill>
+                          <a:latin typeface="Montserrat"/>
+                        </a:rPr>
+                        <a:t>Cosa fa l'IA</a:t>
+                      </a:r>
+                    </a:p>
+                  </a:txBody>
+                  <a:tcPr marL="128016" marR="91440" marT="27432" marB="27432" anchor="ctr">
+                    <a:solidFill>
+                      <a:srgbClr val="003BA3"/>
+                    </a:solidFill>
+                  </a:tcPr>
+                </a:tc>
+              </a:tr>
+              <a:tr h="396240">
+                <a:tc>
+                  <a:txBody>
+                    <a:bodyPr wrap="square"/>
+                    <a:lstStyle/>
+                    <a:p>
+                      <a:pPr algn="l"/>
+                      <a:r>
+                        <a:rPr sz="1100" b="1">
+                          <a:solidFill>
+                            <a:srgbClr val="003BA3"/>
+                          </a:solidFill>
+                          <a:latin typeface="Montserrat"/>
+                        </a:rPr>
+                        <a:t>Antitrust</a:t>
+                      </a:r>
+                    </a:p>
+                  </a:txBody>
+                  <a:tcPr marL="128016" marR="91440" marT="27432" marB="27432" anchor="ctr">
+                    <a:solidFill>
+                      <a:srgbClr val="FFFFFF"/>
+                    </a:solidFill>
+                  </a:tcPr>
+                </a:tc>
+                <a:tc>
+                  <a:txBody>
+                    <a:bodyPr wrap="square"/>
+                    <a:lstStyle/>
+                    <a:p>
+                      <a:pPr algn="l"/>
+                      <a:r>
+                        <a:rPr sz="1100" b="0">
+                          <a:solidFill>
+                            <a:srgbClr val="1A1A2E"/>
+                          </a:solidFill>
+                          <a:latin typeface="Montserrat"/>
+                        </a:rPr>
+                        <a:t>AGCM</a:t>
+                      </a:r>
+                    </a:p>
+                  </a:txBody>
+                  <a:tcPr marL="128016" marR="91440" marT="27432" marB="27432" anchor="ctr">
+                    <a:solidFill>
+                      <a:srgbClr val="FFFFFF"/>
+                    </a:solidFill>
+                  </a:tcPr>
+                </a:tc>
+                <a:tc>
+                  <a:txBody>
+                    <a:bodyPr wrap="square"/>
+                    <a:lstStyle/>
+                    <a:p>
+                      <a:pPr algn="l"/>
+                      <a:r>
+                        <a:rPr sz="1100" b="0">
+                          <a:solidFill>
+                            <a:srgbClr val="1A1A2E"/>
+                          </a:solidFill>
+                          <a:latin typeface="Montserrat"/>
+                        </a:rPr>
+                        <a:t>Verifica soglie fatturato (532M/32M €)</a:t>
+                      </a:r>
+                    </a:p>
+                  </a:txBody>
+                  <a:tcPr marL="128016" marR="91440" marT="27432" marB="27432" anchor="ctr">
+                    <a:solidFill>
+                      <a:srgbClr val="FFFFFF"/>
+                    </a:solidFill>
+                  </a:tcPr>
+                </a:tc>
+              </a:tr>
+              <a:tr h="396240">
+                <a:tc>
+                  <a:txBody>
+                    <a:bodyPr wrap="square"/>
+                    <a:lstStyle/>
+                    <a:p>
+                      <a:pPr algn="l"/>
+                      <a:r>
+                        <a:rPr sz="1100" b="1">
+                          <a:solidFill>
+                            <a:srgbClr val="003BA3"/>
+                          </a:solidFill>
+                          <a:latin typeface="Montserrat"/>
+                        </a:rPr>
+                        <a:t>Settori strategici</a:t>
+                      </a:r>
+                    </a:p>
+                  </a:txBody>
+                  <a:tcPr marL="128016" marR="91440" marT="27432" marB="27432" anchor="ctr">
+                    <a:solidFill>
+                      <a:srgbClr val="F5F7FA"/>
+                    </a:solidFill>
+                  </a:tcPr>
+                </a:tc>
+                <a:tc>
+                  <a:txBody>
+                    <a:bodyPr wrap="square"/>
+                    <a:lstStyle/>
+                    <a:p>
+                      <a:pPr algn="l"/>
+                      <a:r>
+                        <a:rPr sz="1100" b="0">
+                          <a:solidFill>
+                            <a:srgbClr val="1A1A2E"/>
+                          </a:solidFill>
+                          <a:latin typeface="Montserrat"/>
+                        </a:rPr>
+                        <a:t>Golden Power</a:t>
+                      </a:r>
+                    </a:p>
+                  </a:txBody>
+                  <a:tcPr marL="128016" marR="91440" marT="27432" marB="27432" anchor="ctr">
+                    <a:solidFill>
+                      <a:srgbClr val="F5F7FA"/>
+                    </a:solidFill>
+                  </a:tcPr>
+                </a:tc>
+                <a:tc>
+                  <a:txBody>
+                    <a:bodyPr wrap="square"/>
+                    <a:lstStyle/>
+                    <a:p>
+                      <a:pPr algn="l"/>
+                      <a:r>
+                        <a:rPr sz="1100" b="0">
+                          <a:solidFill>
+                            <a:srgbClr val="1A1A2E"/>
+                          </a:solidFill>
+                          <a:latin typeface="Montserrat"/>
+                        </a:rPr>
+                        <a:t>Flag settori D.L. 21/2012</a:t>
+                      </a:r>
+                    </a:p>
+                  </a:txBody>
+                  <a:tcPr marL="128016" marR="91440" marT="27432" marB="27432" anchor="ctr">
+                    <a:solidFill>
+                      <a:srgbClr val="F5F7FA"/>
+                    </a:solidFill>
+                  </a:tcPr>
+                </a:tc>
+              </a:tr>
+              <a:tr h="396240">
+                <a:tc>
+                  <a:txBody>
+                    <a:bodyPr wrap="square"/>
+                    <a:lstStyle/>
+                    <a:p>
+                      <a:pPr algn="l"/>
+                      <a:r>
+                        <a:rPr sz="1100" b="1">
+                          <a:solidFill>
+                            <a:srgbClr val="003BA3"/>
+                          </a:solidFill>
+                          <a:latin typeface="Montserrat"/>
+                        </a:rPr>
+                        <a:t>Mercati</a:t>
+                      </a:r>
+                    </a:p>
+                  </a:txBody>
+                  <a:tcPr marL="128016" marR="91440" marT="27432" marB="27432" anchor="ctr">
+                    <a:solidFill>
+                      <a:srgbClr val="FFFFFF"/>
+                    </a:solidFill>
+                  </a:tcPr>
+                </a:tc>
+                <a:tc>
+                  <a:txBody>
+                    <a:bodyPr wrap="square"/>
+                    <a:lstStyle/>
+                    <a:p>
+                      <a:pPr algn="l"/>
+                      <a:r>
+                        <a:rPr sz="1100" b="0">
+                          <a:solidFill>
+                            <a:srgbClr val="1A1A2E"/>
+                          </a:solidFill>
+                          <a:latin typeface="Montserrat"/>
+                        </a:rPr>
+                        <a:t>CONSOB</a:t>
+                      </a:r>
+                    </a:p>
+                  </a:txBody>
+                  <a:tcPr marL="128016" marR="91440" marT="27432" marB="27432" anchor="ctr">
+                    <a:solidFill>
+                      <a:srgbClr val="FFFFFF"/>
+                    </a:solidFill>
+                  </a:tcPr>
+                </a:tc>
+                <a:tc>
+                  <a:txBody>
+                    <a:bodyPr wrap="square"/>
+                    <a:lstStyle/>
+                    <a:p>
+                      <a:pPr algn="l"/>
+                      <a:r>
+                        <a:rPr sz="1100" b="0">
+                          <a:solidFill>
+                            <a:srgbClr val="1A1A2E"/>
+                          </a:solidFill>
+                          <a:latin typeface="Montserrat"/>
+                        </a:rPr>
+                        <a:t>Conformità Regolamento Emittenti</a:t>
+                      </a:r>
+                    </a:p>
+                  </a:txBody>
+                  <a:tcPr marL="128016" marR="91440" marT="27432" marB="27432" anchor="ctr">
+                    <a:solidFill>
+                      <a:srgbClr val="FFFFFF"/>
+                    </a:solidFill>
+                  </a:tcPr>
+                </a:tc>
+              </a:tr>
+              <a:tr h="396240">
+                <a:tc>
+                  <a:txBody>
+                    <a:bodyPr wrap="square"/>
+                    <a:lstStyle/>
+                    <a:p>
+                      <a:pPr algn="l"/>
+                      <a:r>
+                        <a:rPr sz="1100" b="1">
+                          <a:solidFill>
+                            <a:srgbClr val="003BA3"/>
+                          </a:solidFill>
+                          <a:latin typeface="Montserrat"/>
+                        </a:rPr>
+                        <a:t>Adeguatezza</a:t>
+                      </a:r>
+                    </a:p>
+                  </a:txBody>
+                  <a:tcPr marL="128016" marR="91440" marT="27432" marB="27432" anchor="ctr">
+                    <a:solidFill>
+                      <a:srgbClr val="F5F7FA"/>
+                    </a:solidFill>
+                  </a:tcPr>
+                </a:tc>
+                <a:tc>
+                  <a:txBody>
+                    <a:bodyPr wrap="square"/>
+                    <a:lstStyle/>
+                    <a:p>
+                      <a:pPr algn="l"/>
+                      <a:r>
+                        <a:rPr sz="1100" b="0">
+                          <a:solidFill>
+                            <a:srgbClr val="1A1A2E"/>
+                          </a:solidFill>
+                          <a:latin typeface="Montserrat"/>
+                        </a:rPr>
+                        <a:t>MiFID II</a:t>
+                      </a:r>
+                    </a:p>
+                  </a:txBody>
+                  <a:tcPr marL="128016" marR="91440" marT="27432" marB="27432" anchor="ctr">
+                    <a:solidFill>
+                      <a:srgbClr val="F5F7FA"/>
+                    </a:solidFill>
+                  </a:tcPr>
+                </a:tc>
+                <a:tc>
+                  <a:txBody>
+                    <a:bodyPr wrap="square"/>
+                    <a:lstStyle/>
+                    <a:p>
+                      <a:pPr algn="l"/>
+                      <a:r>
+                        <a:rPr sz="1100" b="0">
+                          <a:solidFill>
+                            <a:srgbClr val="1A1A2E"/>
+                          </a:solidFill>
+                          <a:latin typeface="Montserrat"/>
+                        </a:rPr>
+                        <a:t>Profiling, target market, ESG</a:t>
+                      </a:r>
+                    </a:p>
+                  </a:txBody>
+                  <a:tcPr marL="128016" marR="91440" marT="27432" marB="27432" anchor="ctr">
+                    <a:solidFill>
+                      <a:srgbClr val="F5F7FA"/>
+                    </a:solidFill>
+                  </a:tcPr>
+                </a:tc>
+              </a:tr>
+              <a:tr h="396240">
+                <a:tc>
+                  <a:txBody>
+                    <a:bodyPr wrap="square"/>
+                    <a:lstStyle/>
+                    <a:p>
+                      <a:pPr algn="l"/>
+                      <a:r>
+                        <a:rPr sz="1100" b="1">
+                          <a:solidFill>
+                            <a:srgbClr val="003BA3"/>
+                          </a:solidFill>
+                          <a:latin typeface="Montserrat"/>
+                        </a:rPr>
+                        <a:t>Antiriciclaggio</a:t>
+                      </a:r>
+                    </a:p>
+                  </a:txBody>
+                  <a:tcPr marL="128016" marR="91440" marT="27432" marB="27432" anchor="ctr">
+                    <a:solidFill>
+                      <a:srgbClr val="FFFFFF"/>
+                    </a:solidFill>
+                  </a:tcPr>
+                </a:tc>
+                <a:tc>
+                  <a:txBody>
+                    <a:bodyPr wrap="square"/>
+                    <a:lstStyle/>
+                    <a:p>
+                      <a:pPr algn="l"/>
+                      <a:r>
+                        <a:rPr sz="1100" b="0">
+                          <a:solidFill>
+                            <a:srgbClr val="1A1A2E"/>
+                          </a:solidFill>
+                          <a:latin typeface="Montserrat"/>
+                        </a:rPr>
+                        <a:t>D.Lgs. 231/2007</a:t>
+                      </a:r>
+                    </a:p>
+                  </a:txBody>
+                  <a:tcPr marL="128016" marR="91440" marT="27432" marB="27432" anchor="ctr">
+                    <a:solidFill>
+                      <a:srgbClr val="FFFFFF"/>
+                    </a:solidFill>
+                  </a:tcPr>
+                </a:tc>
+                <a:tc>
+                  <a:txBody>
+                    <a:bodyPr wrap="square"/>
+                    <a:lstStyle/>
+                    <a:p>
+                      <a:pPr algn="l"/>
+                      <a:r>
+                        <a:rPr sz="1100" b="0">
+                          <a:solidFill>
+                            <a:srgbClr val="1A1A2E"/>
+                          </a:solidFill>
+                          <a:latin typeface="Montserrat"/>
+                        </a:rPr>
+                        <a:t>3 livelli di adeguata verifica</a:t>
+                      </a:r>
+                    </a:p>
+                  </a:txBody>
+                  <a:tcPr marL="128016" marR="91440" marT="27432" marB="27432" anchor="ctr">
+                    <a:solidFill>
+                      <a:srgbClr val="FFFFFF"/>
+                    </a:solidFill>
+                  </a:tcPr>
+                </a:tc>
+              </a:tr>
+              <a:tr h="396240">
+                <a:tc>
+                  <a:txBody>
+                    <a:bodyPr wrap="square"/>
+                    <a:lstStyle/>
+                    <a:p>
+                      <a:pPr algn="l"/>
+                      <a:r>
+                        <a:rPr sz="1100" b="1">
+                          <a:solidFill>
+                            <a:srgbClr val="003BA3"/>
+                          </a:solidFill>
+                          <a:latin typeface="Montserrat"/>
+                        </a:rPr>
+                        <a:t>Sostenibilità</a:t>
+                      </a:r>
+                    </a:p>
+                  </a:txBody>
+                  <a:tcPr marL="128016" marR="91440" marT="27432" marB="27432" anchor="ctr">
+                    <a:solidFill>
+                      <a:srgbClr val="F5F7FA"/>
+                    </a:solidFill>
+                  </a:tcPr>
+                </a:tc>
+                <a:tc>
+                  <a:txBody>
+                    <a:bodyPr wrap="square"/>
+                    <a:lstStyle/>
+                    <a:p>
+                      <a:pPr algn="l"/>
+                      <a:r>
+                        <a:rPr sz="1100" b="0">
+                          <a:solidFill>
+                            <a:srgbClr val="1A1A2E"/>
+                          </a:solidFill>
+                          <a:latin typeface="Montserrat"/>
+                        </a:rPr>
+                        <a:t>SFDR</a:t>
+                      </a:r>
+                    </a:p>
+                  </a:txBody>
+                  <a:tcPr marL="128016" marR="91440" marT="27432" marB="27432" anchor="ctr">
+                    <a:solidFill>
+                      <a:srgbClr val="F5F7FA"/>
+                    </a:solidFill>
+                  </a:tcPr>
+                </a:tc>
+                <a:tc>
+                  <a:txBody>
+                    <a:bodyPr wrap="square"/>
+                    <a:lstStyle/>
+                    <a:p>
+                      <a:pPr algn="l"/>
+                      <a:r>
+                        <a:rPr sz="1100" b="0">
+                          <a:solidFill>
+                            <a:srgbClr val="1A1A2E"/>
+                          </a:solidFill>
+                          <a:latin typeface="Montserrat"/>
+                        </a:rPr>
+                        <a:t>Classificazione art. 6/8/9</a:t>
+                      </a:r>
+                    </a:p>
+                  </a:txBody>
+                  <a:tcPr marL="128016" marR="91440" marT="27432" marB="27432" anchor="ctr">
+                    <a:solidFill>
+                      <a:srgbClr val="F5F7FA"/>
+                    </a:solidFill>
+                  </a:tcPr>
+                </a:tc>
+              </a:tr>
+              <a:tr h="396240">
+                <a:tc>
+                  <a:txBody>
+                    <a:bodyPr wrap="square"/>
+                    <a:lstStyle/>
+                    <a:p>
+                      <a:pPr algn="l"/>
+                      <a:r>
+                        <a:rPr sz="1100" b="1">
+                          <a:solidFill>
+                            <a:srgbClr val="003BA3"/>
+                          </a:solidFill>
+                          <a:latin typeface="Montserrat"/>
+                        </a:rPr>
+                        <a:t>Resilienza</a:t>
+                      </a:r>
+                    </a:p>
+                  </a:txBody>
+                  <a:tcPr marL="128016" marR="91440" marT="27432" marB="27432" anchor="ctr">
+                    <a:solidFill>
+                      <a:srgbClr val="FFFFFF"/>
+                    </a:solidFill>
+                  </a:tcPr>
+                </a:tc>
+                <a:tc>
+                  <a:txBody>
+                    <a:bodyPr wrap="square"/>
+                    <a:lstStyle/>
+                    <a:p>
+                      <a:pPr algn="l"/>
+                      <a:r>
+                        <a:rPr sz="1100" b="0">
+                          <a:solidFill>
+                            <a:srgbClr val="1A1A2E"/>
+                          </a:solidFill>
+                          <a:latin typeface="Montserrat"/>
+                        </a:rPr>
+                        <a:t>DORA</a:t>
+                      </a:r>
+                    </a:p>
+                  </a:txBody>
+                  <a:tcPr marL="128016" marR="91440" marT="27432" marB="27432" anchor="ctr">
+                    <a:solidFill>
+                      <a:srgbClr val="FFFFFF"/>
+                    </a:solidFill>
+                  </a:tcPr>
+                </a:tc>
+                <a:tc>
+                  <a:txBody>
+                    <a:bodyPr wrap="square"/>
+                    <a:lstStyle/>
+                    <a:p>
+                      <a:pPr algn="l"/>
+                      <a:r>
+                        <a:rPr sz="1100" b="0">
+                          <a:solidFill>
+                            <a:srgbClr val="1A1A2E"/>
+                          </a:solidFill>
+                          <a:latin typeface="Montserrat"/>
+                        </a:rPr>
+                        <a:t>Check Reg. UE 2022/2554</a:t>
+                      </a:r>
+                    </a:p>
+                  </a:txBody>
+                  <a:tcPr marL="128016" marR="91440" marT="27432" marB="27432" anchor="ctr">
+                    <a:solidFill>
+                      <a:srgbClr val="FFFFFF"/>
+                    </a:solidFill>
+                  </a:tcPr>
+                </a:tc>
+              </a:tr>
+              <a:tr h="396240">
+                <a:tc>
+                  <a:txBody>
+                    <a:bodyPr wrap="square"/>
+                    <a:lstStyle/>
+                    <a:p>
+                      <a:pPr algn="l"/>
+                      <a:r>
+                        <a:rPr sz="1100" b="1">
+                          <a:solidFill>
+                            <a:srgbClr val="003BA3"/>
+                          </a:solidFill>
+                          <a:latin typeface="Montserrat"/>
+                        </a:rPr>
+                        <a:t>Fiscalità</a:t>
+                      </a:r>
+                    </a:p>
+                  </a:txBody>
+                  <a:tcPr marL="128016" marR="91440" marT="27432" marB="27432" anchor="ctr">
+                    <a:solidFill>
+                      <a:srgbClr val="F5F7FA"/>
+                    </a:solidFill>
+                  </a:tcPr>
+                </a:tc>
+                <a:tc>
+                  <a:txBody>
+                    <a:bodyPr wrap="square"/>
+                    <a:lstStyle/>
+                    <a:p>
+                      <a:pPr algn="l"/>
+                      <a:r>
+                        <a:rPr sz="1100" b="0">
+                          <a:solidFill>
+                            <a:srgbClr val="1A1A2E"/>
+                          </a:solidFill>
+                          <a:latin typeface="Montserrat"/>
+                        </a:rPr>
+                        <a:t>IRES+IRAP</a:t>
+                      </a:r>
+                    </a:p>
+                  </a:txBody>
+                  <a:tcPr marL="128016" marR="91440" marT="27432" marB="27432" anchor="ctr">
+                    <a:solidFill>
+                      <a:srgbClr val="F5F7FA"/>
+                    </a:solidFill>
+                  </a:tcPr>
+                </a:tc>
+                <a:tc>
+                  <a:txBody>
+                    <a:bodyPr wrap="square"/>
+                    <a:lstStyle/>
+                    <a:p>
+                      <a:pPr algn="l"/>
+                      <a:r>
+                        <a:rPr sz="1100" b="0">
+                          <a:solidFill>
+                            <a:srgbClr val="1A1A2E"/>
+                          </a:solidFill>
+                          <a:latin typeface="Montserrat"/>
+                        </a:rPr>
+                        <a:t>Parametri automatici per l'Italia</a:t>
+                      </a:r>
+                    </a:p>
+                  </a:txBody>
+                  <a:tcPr marL="128016" marR="91440" marT="27432" marB="27432" anchor="ctr">
+                    <a:solidFill>
+                      <a:srgbClr val="F5F7FA"/>
+                    </a:solidFill>
+                  </a:tcPr>
+                </a:tc>
+              </a:tr>
+            </a:tbl>
+          </a:graphicData>
+        </a:graphic>
+      </p:graphicFrame>
     </p:spTree>
   </p:cSld>
   <p:clrMapOvr>
@@ -4489,54 +4561,14 @@
       <p:grpSpPr/>
       <p:sp>
         <p:nvSpPr>
-          <p:cNvPr id="2" name="Shape 0"/>
-          <p:cNvSpPr/>
-          <p:nvPr/>
-        </p:nvSpPr>
-        <p:spPr>
-          <a:xfrm>
-            <a:off x="2560320" y="-274320"/>
-            <a:ext cx="1645920" cy="2926080"/>
-          </a:xfrm>
-          <a:prstGeom prst="rect">
-            <a:avLst/>
-          </a:prstGeom>
-          <a:solidFill>
-            <a:srgbClr val="4A8CFF"/>
-          </a:solidFill>
-          <a:ln/>
-        </p:spPr>
-      </p:sp>
-      <p:sp>
-        <p:nvSpPr>
-          <p:cNvPr id="3" name="Shape 1"/>
-          <p:cNvSpPr/>
-          <p:nvPr/>
-        </p:nvSpPr>
-        <p:spPr>
-          <a:xfrm>
-            <a:off x="1371600" y="2377440"/>
-            <a:ext cx="1645920" cy="1828800"/>
-          </a:xfrm>
-          <a:prstGeom prst="rect">
-            <a:avLst/>
-          </a:prstGeom>
-          <a:solidFill>
-            <a:srgbClr val="F5F7FA"/>
-          </a:solidFill>
-          <a:ln/>
-        </p:spPr>
-      </p:sp>
-      <p:sp>
-        <p:nvSpPr>
-          <p:cNvPr id="4" name="Text 2"/>
-          <p:cNvSpPr/>
-          <p:nvPr/>
-        </p:nvSpPr>
-        <p:spPr>
-          <a:xfrm>
-            <a:off x="4572000" y="914400"/>
-            <a:ext cx="4114800" cy="1097280"/>
+          <p:cNvPr id="2" name="Text 0"/>
+          <p:cNvSpPr/>
+          <p:nvPr/>
+        </p:nvSpPr>
+        <p:spPr>
+          <a:xfrm>
+            <a:off x="548640" y="228600"/>
+            <a:ext cx="8046720" cy="594360"/>
           </a:xfrm>
           <a:prstGeom prst="rect">
             <a:avLst/>
@@ -4548,50 +4580,11 @@
           <a:bodyPr wrap="square" lIns="0" tIns="0" rIns="0" bIns="0" rtlCol="0" anchor="ctr"/>
           <a:lstStyle/>
           <a:p>
-            <a:pPr algn="ctr" indent="0" marL="0">
+            <a:pPr indent="0" marL="0">
               <a:buNone/>
             </a:pPr>
             <a:r>
-              <a:rPr lang="en-US" sz="7200" b="1" dirty="0">
-                <a:solidFill>
-                  <a:srgbClr val="4A8CFF"/>
-                </a:solidFill>
-                <a:latin typeface="Montserrat" pitchFamily="34" charset="0"/>
-                <a:ea typeface="Montserrat" pitchFamily="34" charset="-122"/>
-                <a:cs typeface="Montserrat" pitchFamily="34" charset="-120"/>
-              </a:rPr>
-              <a:t>03</a:t>
-            </a:r>
-            <a:endParaRPr lang="en-US" sz="7200" dirty="0"/>
-          </a:p>
-        </p:txBody>
-      </p:sp>
-      <p:sp>
-        <p:nvSpPr>
-          <p:cNvPr id="5" name="Text 3"/>
-          <p:cNvSpPr/>
-          <p:nvPr/>
-        </p:nvSpPr>
-        <p:spPr>
-          <a:xfrm>
-            <a:off x="4572000" y="2011680"/>
-            <a:ext cx="4114800" cy="731520"/>
-          </a:xfrm>
-          <a:prstGeom prst="rect">
-            <a:avLst/>
-          </a:prstGeom>
-          <a:noFill/>
-          <a:ln/>
-        </p:spPr>
-        <p:txBody>
-          <a:bodyPr wrap="square" lIns="0" tIns="0" rIns="0" bIns="0" rtlCol="0" anchor="ctr"/>
-          <a:lstStyle/>
-          <a:p>
-            <a:pPr algn="ctr" indent="0" marL="0">
-              <a:buNone/>
-            </a:pPr>
-            <a:r>
-              <a:rPr lang="en-US" sz="3600" b="1" dirty="0">
+              <a:rPr lang="en-US" sz="2100" b="1" dirty="0">
                 <a:solidFill>
                   <a:srgbClr val="003BA3"/>
                 </a:solidFill>
@@ -4599,51 +4592,82 @@
                 <a:ea typeface="Montserrat" pitchFamily="34" charset="-122"/>
                 <a:cs typeface="Montserrat" pitchFamily="34" charset="-120"/>
               </a:rPr>
-              <a:t>Strategia</a:t>
+              <a:t>Arricchire il dominio: dallo strumento alla suite integrata</a:t>
             </a:r>
-            <a:endParaRPr lang="en-US" sz="3600" dirty="0"/>
+            <a:endParaRPr lang="en-US" sz="2800" dirty="0"/>
           </a:p>
         </p:txBody>
       </p:sp>
       <p:sp>
         <p:nvSpPr>
-          <p:cNvPr id="6" name="Text 4"/>
-          <p:cNvSpPr/>
-          <p:nvPr/>
-        </p:nvSpPr>
-        <p:spPr>
-          <a:xfrm>
-            <a:off x="4572000" y="2743200"/>
-            <a:ext cx="4114800" cy="457200"/>
-          </a:xfrm>
-          <a:prstGeom prst="rect">
-            <a:avLst/>
-          </a:prstGeom>
-          <a:noFill/>
-          <a:ln/>
-        </p:spPr>
-        <p:txBody>
-          <a:bodyPr wrap="square" lIns="0" tIns="0" rIns="0" bIns="0" rtlCol="0" anchor="ctr"/>
-          <a:lstStyle/>
-          <a:p>
-            <a:pPr algn="ctr" indent="0" marL="0">
-              <a:buNone/>
-            </a:pPr>
-            <a:r>
-              <a:rPr lang="en-US" sz="1400" dirty="0">
-                <a:solidFill>
-                  <a:srgbClr val="4A4A5A"/>
-                </a:solidFill>
-                <a:latin typeface="Montserrat" pitchFamily="34" charset="0"/>
-                <a:ea typeface="Montserrat" pitchFamily="34" charset="-122"/>
-                <a:cs typeface="Montserrat" pitchFamily="34" charset="-120"/>
-              </a:rPr>
-              <a:t>Il percorso di adozione progressiva</a:t>
-            </a:r>
-            <a:endParaRPr lang="en-US" sz="1400" dirty="0"/>
-          </a:p>
-        </p:txBody>
-      </p:sp>
+          <p:cNvPr id="3" name="Shape 1"/>
+          <p:cNvSpPr/>
+          <p:nvPr/>
+        </p:nvSpPr>
+        <p:spPr>
+          <a:xfrm>
+            <a:off x="0" y="4942332"/>
+            <a:ext cx="5029200" cy="201168"/>
+          </a:xfrm>
+          <a:prstGeom prst="rect">
+            <a:avLst/>
+          </a:prstGeom>
+          <a:solidFill>
+            <a:srgbClr val="003BA3"/>
+          </a:solidFill>
+          <a:ln/>
+        </p:spPr>
+      </p:sp>
+      <p:sp>
+        <p:nvSpPr>
+          <p:cNvPr id="4" name="Shape 2"/>
+          <p:cNvSpPr/>
+          <p:nvPr/>
+        </p:nvSpPr>
+        <p:spPr>
+          <a:xfrm>
+            <a:off x="5029200" y="4942332"/>
+            <a:ext cx="4114800" cy="201168"/>
+          </a:xfrm>
+          <a:prstGeom prst="rect">
+            <a:avLst/>
+          </a:prstGeom>
+          <a:solidFill>
+            <a:srgbClr val="4A8CFF"/>
+          </a:solidFill>
+          <a:ln/>
+        </p:spPr>
+      </p:sp>
+      <p:pic>
+        <p:nvPicPr>
+          <p:cNvPr id="5" name="Picture 4" descr="image.png"/>
+          <p:cNvPicPr>
+            <a:picLocks noChangeAspect="1"/>
+          </p:cNvPicPr>
+          <p:nvPr/>
+        </p:nvPicPr>
+        <p:blipFill>
+          <a:blip r:embed="rId2">
+            <a:extLst>
+              <a:ext uri="{96DAC541-7B7A-43D3-8B79-37D633B846F1}">
+                <ns0:svgBlip xmlns:ns0="http://schemas.microsoft.com/office/drawing/2016/SVG/main" r:embed="rId3"/>
+              </a:ext>
+            </a:extLst>
+          </a:blip>
+          <a:stretch>
+            <a:fillRect/>
+          </a:stretch>
+        </p:blipFill>
+        <p:spPr>
+          <a:xfrm>
+            <a:off x="411480" y="1078992"/>
+            <a:ext cx="8321040" cy="3703320"/>
+          </a:xfrm>
+          <a:prstGeom prst="rect">
+            <a:avLst/>
+          </a:prstGeom>
+        </p:spPr>
+      </p:pic>
     </p:spTree>
   </p:cSld>
   <p:clrMapOvr>
@@ -4664,14 +4688,54 @@
       <p:grpSpPr/>
       <p:sp>
         <p:nvSpPr>
-          <p:cNvPr id="2" name="Text 0"/>
-          <p:cNvSpPr/>
-          <p:nvPr/>
-        </p:nvSpPr>
-        <p:spPr>
-          <a:xfrm>
-            <a:off x="548640" y="228600"/>
-            <a:ext cx="8046720" cy="594360"/>
+          <p:cNvPr id="2" name="Shape 0"/>
+          <p:cNvSpPr/>
+          <p:nvPr/>
+        </p:nvSpPr>
+        <p:spPr>
+          <a:xfrm>
+            <a:off x="2560320" y="-274320"/>
+            <a:ext cx="1645920" cy="2926080"/>
+          </a:xfrm>
+          <a:prstGeom prst="rect">
+            <a:avLst/>
+          </a:prstGeom>
+          <a:solidFill>
+            <a:srgbClr val="4A8CFF"/>
+          </a:solidFill>
+          <a:ln/>
+        </p:spPr>
+      </p:sp>
+      <p:sp>
+        <p:nvSpPr>
+          <p:cNvPr id="3" name="Shape 1"/>
+          <p:cNvSpPr/>
+          <p:nvPr/>
+        </p:nvSpPr>
+        <p:spPr>
+          <a:xfrm>
+            <a:off x="1371600" y="2377440"/>
+            <a:ext cx="1645920" cy="1828800"/>
+          </a:xfrm>
+          <a:prstGeom prst="rect">
+            <a:avLst/>
+          </a:prstGeom>
+          <a:solidFill>
+            <a:srgbClr val="F5F7FA"/>
+          </a:solidFill>
+          <a:ln/>
+        </p:spPr>
+      </p:sp>
+      <p:sp>
+        <p:nvSpPr>
+          <p:cNvPr id="4" name="Text 2"/>
+          <p:cNvSpPr/>
+          <p:nvPr/>
+        </p:nvSpPr>
+        <p:spPr>
+          <a:xfrm>
+            <a:off x="4572000" y="914400"/>
+            <a:ext cx="4114800" cy="1097280"/>
           </a:xfrm>
           <a:prstGeom prst="rect">
             <a:avLst/>
@@ -4683,11 +4747,50 @@
           <a:bodyPr wrap="square" lIns="0" tIns="0" rIns="0" bIns="0" rtlCol="0" anchor="ctr"/>
           <a:lstStyle/>
           <a:p>
-            <a:pPr indent="0" marL="0">
+            <a:pPr algn="ctr" indent="0" marL="0">
               <a:buNone/>
             </a:pPr>
             <a:r>
-              <a:rPr lang="en-US" sz="2400" b="1" dirty="0">
+              <a:rPr lang="en-US" sz="7200" b="1" dirty="0">
+                <a:solidFill>
+                  <a:srgbClr val="4A8CFF"/>
+                </a:solidFill>
+                <a:latin typeface="Montserrat" pitchFamily="34" charset="0"/>
+                <a:ea typeface="Montserrat" pitchFamily="34" charset="-122"/>
+                <a:cs typeface="Montserrat" pitchFamily="34" charset="-120"/>
+              </a:rPr>
+              <a:t>03</a:t>
+            </a:r>
+            <a:endParaRPr lang="en-US" sz="7200" dirty="0"/>
+          </a:p>
+        </p:txBody>
+      </p:sp>
+      <p:sp>
+        <p:nvSpPr>
+          <p:cNvPr id="5" name="Text 3"/>
+          <p:cNvSpPr/>
+          <p:nvPr/>
+        </p:nvSpPr>
+        <p:spPr>
+          <a:xfrm>
+            <a:off x="4572000" y="2011680"/>
+            <a:ext cx="4114800" cy="731520"/>
+          </a:xfrm>
+          <a:prstGeom prst="rect">
+            <a:avLst/>
+          </a:prstGeom>
+          <a:noFill/>
+          <a:ln/>
+        </p:spPr>
+        <p:txBody>
+          <a:bodyPr wrap="square" lIns="0" tIns="0" rIns="0" bIns="0" rtlCol="0" anchor="ctr"/>
+          <a:lstStyle/>
+          <a:p>
+            <a:pPr algn="ctr" indent="0" marL="0">
+              <a:buNone/>
+            </a:pPr>
+            <a:r>
+              <a:rPr lang="en-US" sz="3600" b="1" dirty="0">
                 <a:solidFill>
                   <a:srgbClr val="003BA3"/>
                 </a:solidFill>
@@ -4695,82 +4798,51 @@
                 <a:ea typeface="Montserrat" pitchFamily="34" charset="-122"/>
                 <a:cs typeface="Montserrat" pitchFamily="34" charset="-120"/>
               </a:rPr>
-              <a:t>Non serve un big bang: adozione progressiva</a:t>
+              <a:t>Strategia</a:t>
             </a:r>
-            <a:endParaRPr lang="en-US" sz="2800" dirty="0"/>
+            <a:endParaRPr lang="en-US" sz="3600" dirty="0"/>
           </a:p>
         </p:txBody>
       </p:sp>
       <p:sp>
         <p:nvSpPr>
-          <p:cNvPr id="3" name="Shape 1"/>
-          <p:cNvSpPr/>
-          <p:nvPr/>
-        </p:nvSpPr>
-        <p:spPr>
-          <a:xfrm>
-            <a:off x="0" y="4942332"/>
-            <a:ext cx="5029200" cy="201168"/>
-          </a:xfrm>
-          <a:prstGeom prst="rect">
-            <a:avLst/>
-          </a:prstGeom>
-          <a:solidFill>
-            <a:srgbClr val="003BA3"/>
-          </a:solidFill>
-          <a:ln/>
-        </p:spPr>
-      </p:sp>
-      <p:sp>
-        <p:nvSpPr>
-          <p:cNvPr id="4" name="Shape 2"/>
-          <p:cNvSpPr/>
-          <p:nvPr/>
-        </p:nvSpPr>
-        <p:spPr>
-          <a:xfrm>
-            <a:off x="5029200" y="4942332"/>
-            <a:ext cx="4114800" cy="201168"/>
-          </a:xfrm>
-          <a:prstGeom prst="rect">
-            <a:avLst/>
-          </a:prstGeom>
-          <a:solidFill>
-            <a:srgbClr val="4A8CFF"/>
-          </a:solidFill>
-          <a:ln/>
-        </p:spPr>
-      </p:sp>
-      <p:pic>
-        <p:nvPicPr>
-          <p:cNvPr id="5" name="Picture 4" descr="image.png"/>
-          <p:cNvPicPr>
-            <a:picLocks noChangeAspect="1"/>
-          </p:cNvPicPr>
-          <p:nvPr/>
-        </p:nvPicPr>
-        <p:blipFill>
-          <a:blip r:embed="rId2">
-            <a:extLst>
-              <a:ext uri="{96DAC541-7B7A-43D3-8B79-37D633B846F1}">
-                <ns0:svgBlip xmlns:ns0="http://schemas.microsoft.com/office/drawing/2016/SVG/main" r:embed="rId3"/>
-              </a:ext>
-            </a:extLst>
-          </a:blip>
-          <a:stretch>
-            <a:fillRect/>
-          </a:stretch>
-        </p:blipFill>
-        <p:spPr>
-          <a:xfrm>
-            <a:off x="411480" y="1078992"/>
-            <a:ext cx="8321040" cy="3703320"/>
-          </a:xfrm>
-          <a:prstGeom prst="rect">
-            <a:avLst/>
-          </a:prstGeom>
-        </p:spPr>
-      </p:pic>
+          <p:cNvPr id="6" name="Text 4"/>
+          <p:cNvSpPr/>
+          <p:nvPr/>
+        </p:nvSpPr>
+        <p:spPr>
+          <a:xfrm>
+            <a:off x="4572000" y="2743200"/>
+            <a:ext cx="4114800" cy="457200"/>
+          </a:xfrm>
+          <a:prstGeom prst="rect">
+            <a:avLst/>
+          </a:prstGeom>
+          <a:noFill/>
+          <a:ln/>
+        </p:spPr>
+        <p:txBody>
+          <a:bodyPr wrap="square" lIns="0" tIns="0" rIns="0" bIns="0" rtlCol="0" anchor="ctr"/>
+          <a:lstStyle/>
+          <a:p>
+            <a:pPr algn="ctr" indent="0" marL="0">
+              <a:buNone/>
+            </a:pPr>
+            <a:r>
+              <a:rPr lang="en-US" sz="1400" dirty="0">
+                <a:solidFill>
+                  <a:srgbClr val="4A4A5A"/>
+                </a:solidFill>
+                <a:latin typeface="Montserrat" pitchFamily="34" charset="0"/>
+                <a:ea typeface="Montserrat" pitchFamily="34" charset="-122"/>
+                <a:cs typeface="Montserrat" pitchFamily="34" charset="-120"/>
+              </a:rPr>
+              <a:t>Il percorso di adozione progressiva</a:t>
+            </a:r>
+            <a:endParaRPr lang="en-US" sz="1400" dirty="0"/>
+          </a:p>
+        </p:txBody>
+      </p:sp>
     </p:spTree>
   </p:cSld>
   <p:clrMapOvr>
@@ -4822,7 +4894,7 @@
                 <a:ea typeface="Montserrat" pitchFamily="34" charset="-122"/>
                 <a:cs typeface="Montserrat" pitchFamily="34" charset="-120"/>
               </a:rPr>
-              <a:t>L'uomo nel loop: dove metterlo e dove toglierlo</a:t>
+              <a:t>Non serve un big bang: adozione progressiva</a:t>
             </a:r>
             <a:endParaRPr lang="en-US" sz="2800" dirty="0"/>
           </a:p>
@@ -4941,7 +5013,7 @@
               <a:buNone/>
             </a:pPr>
             <a:r>
-              <a:rPr lang="en-US" sz="2800" b="1" dirty="0">
+              <a:rPr lang="en-US" sz="2400" b="1" dirty="0">
                 <a:solidFill>
                   <a:srgbClr val="003BA3"/>
                 </a:solidFill>
@@ -4949,7 +5021,7 @@
                 <a:ea typeface="Montserrat" pitchFamily="34" charset="-122"/>
                 <a:cs typeface="Montserrat" pitchFamily="34" charset="-120"/>
               </a:rPr>
-              <a:t>Misurare il valore: metriche che contano</a:t>
+              <a:t>L'uomo nel loop: dove metterlo e dove toglierlo</a:t>
             </a:r>
             <a:endParaRPr lang="en-US" sz="2800" dirty="0"/>
           </a:p>
@@ -4995,320 +5067,36 @@
           <a:ln/>
         </p:spPr>
       </p:sp>
-      <p:graphicFrame>
-        <p:nvGraphicFramePr>
-          <p:cNvPr id="5" name="Table 4"/>
-          <p:cNvGraphicFramePr>
-            <a:graphicFrameLocks noGrp="1"/>
-          </p:cNvGraphicFramePr>
-          <p:nvPr/>
-        </p:nvGraphicFramePr>
-        <p:xfrm>
-          <a:off x="548640" y="1097280"/>
-          <a:ext cx="8046720" cy="3401568"/>
-        </p:xfrm>
-        <a:graphic>
-          <a:graphicData uri="http://schemas.openxmlformats.org/drawingml/2006/table">
-            <a:tbl>
-              <a:tblPr>
-                <a:tableStyleId>{5C22544A-7EE6-4342-B048-85BDC9FD1C3A}</a:tableStyleId>
-              </a:tblPr>
-              <a:tblGrid>
-                <a:gridCol w="4023360"/>
-                <a:gridCol w="4023360"/>
-              </a:tblGrid>
-              <a:tr h="566928">
-                <a:tc>
-                  <a:txBody>
-                    <a:bodyPr wrap="square"/>
-                    <a:lstStyle/>
-                    <a:p>
-                      <a:pPr algn="l"/>
-                      <a:r>
-                        <a:rPr sz="1200" b="1">
-                          <a:solidFill>
-                            <a:srgbClr val="FFFFFF"/>
-                          </a:solidFill>
-                          <a:latin typeface="Montserrat"/>
-                        </a:rPr>
-                        <a:t>Metriche vanity (inutili)</a:t>
-                      </a:r>
-                    </a:p>
-                  </a:txBody>
-                  <a:tcPr marL="128016" marR="91440" marT="27432" marB="27432" anchor="ctr">
-                    <a:solidFill>
-                      <a:srgbClr val="003BA3"/>
-                    </a:solidFill>
-                  </a:tcPr>
-                </a:tc>
-                <a:tc>
-                  <a:txBody>
-                    <a:bodyPr wrap="square"/>
-                    <a:lstStyle/>
-                    <a:p>
-                      <a:pPr algn="l"/>
-                      <a:r>
-                        <a:rPr sz="1200" b="1">
-                          <a:solidFill>
-                            <a:srgbClr val="FFFFFF"/>
-                          </a:solidFill>
-                          <a:latin typeface="Montserrat"/>
-                        </a:rPr>
-                        <a:t>Metriche di valore (utili)</a:t>
-                      </a:r>
-                    </a:p>
-                  </a:txBody>
-                  <a:tcPr marL="128016" marR="91440" marT="27432" marB="27432" anchor="ctr">
-                    <a:solidFill>
-                      <a:srgbClr val="003BA3"/>
-                    </a:solidFill>
-                  </a:tcPr>
-                </a:tc>
-              </a:tr>
-              <a:tr h="566928">
-                <a:tc>
-                  <a:txBody>
-                    <a:bodyPr wrap="square"/>
-                    <a:lstStyle/>
-                    <a:p>
-                      <a:pPr algn="l"/>
-                      <a:r>
-                        <a:rPr sz="1200" b="1">
-                          <a:solidFill>
-                            <a:srgbClr val="003BA3"/>
-                          </a:solidFill>
-                          <a:latin typeface="Montserrat"/>
-                        </a:rPr>
-                        <a:t>Numero di prompt al giorno</a:t>
-                      </a:r>
-                    </a:p>
-                  </a:txBody>
-                  <a:tcPr marL="128016" marR="91440" marT="27432" marB="27432" anchor="ctr">
-                    <a:solidFill>
-                      <a:srgbClr val="FFFFFF"/>
-                    </a:solidFill>
-                  </a:tcPr>
-                </a:tc>
-                <a:tc>
-                  <a:txBody>
-                    <a:bodyPr wrap="square"/>
-                    <a:lstStyle/>
-                    <a:p>
-                      <a:pPr algn="l"/>
-                      <a:r>
-                        <a:rPr sz="1200" b="0">
-                          <a:solidFill>
-                            <a:srgbClr val="1A1A2E"/>
-                          </a:solidFill>
-                          <a:latin typeface="Montserrat"/>
-                        </a:rPr>
-                        <a:t>Tempo da richiesta a output utilizzabile</a:t>
-                      </a:r>
-                    </a:p>
-                  </a:txBody>
-                  <a:tcPr marL="128016" marR="91440" marT="27432" marB="27432" anchor="ctr">
-                    <a:solidFill>
-                      <a:srgbClr val="FFFFFF"/>
-                    </a:solidFill>
-                  </a:tcPr>
-                </a:tc>
-              </a:tr>
-              <a:tr h="566928">
-                <a:tc>
-                  <a:txBody>
-                    <a:bodyPr wrap="square"/>
-                    <a:lstStyle/>
-                    <a:p>
-                      <a:pPr algn="l"/>
-                      <a:r>
-                        <a:rPr sz="1200" b="1">
-                          <a:solidFill>
-                            <a:srgbClr val="003BA3"/>
-                          </a:solidFill>
-                          <a:latin typeface="Montserrat"/>
-                        </a:rPr>
-                        <a:t>Token consumati</a:t>
-                      </a:r>
-                    </a:p>
-                  </a:txBody>
-                  <a:tcPr marL="128016" marR="91440" marT="27432" marB="27432" anchor="ctr">
-                    <a:solidFill>
-                      <a:srgbClr val="F5F7FA"/>
-                    </a:solidFill>
-                  </a:tcPr>
-                </a:tc>
-                <a:tc>
-                  <a:txBody>
-                    <a:bodyPr wrap="square"/>
-                    <a:lstStyle/>
-                    <a:p>
-                      <a:pPr algn="l"/>
-                      <a:r>
-                        <a:rPr sz="1200" b="0">
-                          <a:solidFill>
-                            <a:srgbClr val="1A1A2E"/>
-                          </a:solidFill>
-                          <a:latin typeface="Montserrat"/>
-                        </a:rPr>
-                        <a:t>Tasso di rework (output accettati al 1º giro)</a:t>
-                      </a:r>
-                    </a:p>
-                  </a:txBody>
-                  <a:tcPr marL="128016" marR="91440" marT="27432" marB="27432" anchor="ctr">
-                    <a:solidFill>
-                      <a:srgbClr val="F5F7FA"/>
-                    </a:solidFill>
-                  </a:tcPr>
-                </a:tc>
-              </a:tr>
-              <a:tr h="566928">
-                <a:tc>
-                  <a:txBody>
-                    <a:bodyPr wrap="square"/>
-                    <a:lstStyle/>
-                    <a:p>
-                      <a:pPr algn="l"/>
-                      <a:r>
-                        <a:rPr sz="1200" b="1">
-                          <a:solidFill>
-                            <a:srgbClr val="003BA3"/>
-                          </a:solidFill>
-                          <a:latin typeface="Montserrat"/>
-                        </a:rPr>
-                        <a:t>Utenti attivi</a:t>
-                      </a:r>
-                    </a:p>
-                  </a:txBody>
-                  <a:tcPr marL="128016" marR="91440" marT="27432" marB="27432" anchor="ctr">
-                    <a:solidFill>
-                      <a:srgbClr val="FFFFFF"/>
-                    </a:solidFill>
-                  </a:tcPr>
-                </a:tc>
-                <a:tc>
-                  <a:txBody>
-                    <a:bodyPr wrap="square"/>
-                    <a:lstStyle/>
-                    <a:p>
-                      <a:pPr algn="l"/>
-                      <a:r>
-                        <a:rPr sz="1200" b="0">
-                          <a:solidFill>
-                            <a:srgbClr val="1A1A2E"/>
-                          </a:solidFill>
-                          <a:latin typeface="Montserrat"/>
-                        </a:rPr>
-                        <a:t>Copertura dei controlli (check eseguiti)</a:t>
-                      </a:r>
-                    </a:p>
-                  </a:txBody>
-                  <a:tcPr marL="128016" marR="91440" marT="27432" marB="27432" anchor="ctr">
-                    <a:solidFill>
-                      <a:srgbClr val="FFFFFF"/>
-                    </a:solidFill>
-                  </a:tcPr>
-                </a:tc>
-              </a:tr>
-              <a:tr h="566928">
-                <a:tc>
-                  <a:txBody>
-                    <a:bodyPr wrap="square"/>
-                    <a:lstStyle/>
-                    <a:p>
-                      <a:pPr algn="l"/>
-                      <a:r>
-                        <a:rPr sz="1200" b="1">
-                          <a:solidFill>
-                            <a:srgbClr val="003BA3"/>
-                          </a:solidFill>
-                          <a:latin typeface="Montserrat"/>
-                        </a:rPr>
-                        <a:t>Soddisfazione generica</a:t>
-                      </a:r>
-                    </a:p>
-                  </a:txBody>
-                  <a:tcPr marL="128016" marR="91440" marT="27432" marB="27432" anchor="ctr">
-                    <a:solidFill>
-                      <a:srgbClr val="F5F7FA"/>
-                    </a:solidFill>
-                  </a:tcPr>
-                </a:tc>
-                <a:tc>
-                  <a:txBody>
-                    <a:bodyPr wrap="square"/>
-                    <a:lstStyle/>
-                    <a:p>
-                      <a:pPr algn="l"/>
-                      <a:r>
-                        <a:rPr sz="1200" b="0">
-                          <a:solidFill>
-                            <a:srgbClr val="1A1A2E"/>
-                          </a:solidFill>
-                          <a:latin typeface="Montserrat"/>
-                        </a:rPr>
-                        <a:t>Riproducibilità (stesso input = stesso output)</a:t>
-                      </a:r>
-                    </a:p>
-                  </a:txBody>
-                  <a:tcPr marL="128016" marR="91440" marT="27432" marB="27432" anchor="ctr">
-                    <a:solidFill>
-                      <a:srgbClr val="F5F7FA"/>
-                    </a:solidFill>
-                  </a:tcPr>
-                </a:tc>
-              </a:tr>
-              <a:tr h="566928">
-                <a:tc>
-                  <a:txBody>
-                    <a:bodyPr wrap="square"/>
-                    <a:lstStyle/>
-                    <a:p>
-                      <a:pPr algn="l"/>
-                      <a:r>
-                        <a:rPr sz="1200" b="1">
-                          <a:solidFill>
-                            <a:srgbClr val="003BA3"/>
-                          </a:solidFill>
-                          <a:latin typeface="Montserrat"/>
-                        </a:rPr>
-                        <a:t>Costo per query</a:t>
-                      </a:r>
-                    </a:p>
-                  </a:txBody>
-                  <a:tcPr marL="128016" marR="91440" marT="27432" marB="27432" anchor="ctr">
-                    <a:solidFill>
-                      <a:srgbClr val="FFFFFF"/>
-                    </a:solidFill>
-                  </a:tcPr>
-                </a:tc>
-                <a:tc>
-                  <a:txBody>
-                    <a:bodyPr wrap="square"/>
-                    <a:lstStyle/>
-                    <a:p>
-                      <a:pPr algn="l"/>
-                      <a:r>
-                        <a:rPr sz="1200" b="0">
-                          <a:solidFill>
-                            <a:srgbClr val="1A1A2E"/>
-                          </a:solidFill>
-                          <a:latin typeface="Montserrat"/>
-                        </a:rPr>
-                        <a:t>Audit trail (tracciabilità delle decisioni)</a:t>
-                      </a:r>
-                    </a:p>
-                  </a:txBody>
-                  <a:tcPr marL="128016" marR="91440" marT="27432" marB="27432" anchor="ctr">
-                    <a:solidFill>
-                      <a:srgbClr val="FFFFFF"/>
-                    </a:solidFill>
-                  </a:tcPr>
-                </a:tc>
-              </a:tr>
-            </a:tbl>
-          </a:graphicData>
-        </a:graphic>
-      </p:graphicFrame>
+      <p:pic>
+        <p:nvPicPr>
+          <p:cNvPr id="5" name="Picture 4" descr="image.png"/>
+          <p:cNvPicPr>
+            <a:picLocks noChangeAspect="1"/>
+          </p:cNvPicPr>
+          <p:nvPr/>
+        </p:nvPicPr>
+        <p:blipFill>
+          <a:blip r:embed="rId2">
+            <a:extLst>
+              <a:ext uri="{96DAC541-7B7A-43D3-8B79-37D633B846F1}">
+                <ns0:svgBlip xmlns:ns0="http://schemas.microsoft.com/office/drawing/2016/SVG/main" r:embed="rId3"/>
+              </a:ext>
+            </a:extLst>
+          </a:blip>
+          <a:stretch>
+            <a:fillRect/>
+          </a:stretch>
+        </p:blipFill>
+        <p:spPr>
+          <a:xfrm>
+            <a:off x="411480" y="1078992"/>
+            <a:ext cx="8321040" cy="3703320"/>
+          </a:xfrm>
+          <a:prstGeom prst="rect">
+            <a:avLst/>
+          </a:prstGeom>
+        </p:spPr>
+      </p:pic>
     </p:spTree>
   </p:cSld>
   <p:clrMapOvr>
@@ -5329,54 +5117,14 @@
       <p:grpSpPr/>
       <p:sp>
         <p:nvSpPr>
-          <p:cNvPr id="2" name="Shape 0"/>
-          <p:cNvSpPr/>
-          <p:nvPr/>
-        </p:nvSpPr>
-        <p:spPr>
-          <a:xfrm>
-            <a:off x="2560320" y="-274320"/>
-            <a:ext cx="1645920" cy="2926080"/>
-          </a:xfrm>
-          <a:prstGeom prst="rect">
-            <a:avLst/>
-          </a:prstGeom>
-          <a:solidFill>
-            <a:srgbClr val="4A8CFF"/>
-          </a:solidFill>
-          <a:ln/>
-        </p:spPr>
-      </p:sp>
-      <p:sp>
-        <p:nvSpPr>
-          <p:cNvPr id="3" name="Shape 1"/>
-          <p:cNvSpPr/>
-          <p:nvPr/>
-        </p:nvSpPr>
-        <p:spPr>
-          <a:xfrm>
-            <a:off x="1371600" y="2377440"/>
-            <a:ext cx="1645920" cy="1828800"/>
-          </a:xfrm>
-          <a:prstGeom prst="rect">
-            <a:avLst/>
-          </a:prstGeom>
-          <a:solidFill>
-            <a:srgbClr val="F5F7FA"/>
-          </a:solidFill>
-          <a:ln/>
-        </p:spPr>
-      </p:sp>
-      <p:sp>
-        <p:nvSpPr>
-          <p:cNvPr id="4" name="Text 2"/>
-          <p:cNvSpPr/>
-          <p:nvPr/>
-        </p:nvSpPr>
-        <p:spPr>
-          <a:xfrm>
-            <a:off x="4572000" y="914400"/>
-            <a:ext cx="4114800" cy="1097280"/>
+          <p:cNvPr id="2" name="Text 0"/>
+          <p:cNvSpPr/>
+          <p:nvPr/>
+        </p:nvSpPr>
+        <p:spPr>
+          <a:xfrm>
+            <a:off x="548640" y="228600"/>
+            <a:ext cx="8046720" cy="594360"/>
           </a:xfrm>
           <a:prstGeom prst="rect">
             <a:avLst/>
@@ -5388,50 +5136,11 @@
           <a:bodyPr wrap="square" lIns="0" tIns="0" rIns="0" bIns="0" rtlCol="0" anchor="ctr"/>
           <a:lstStyle/>
           <a:p>
-            <a:pPr algn="ctr" indent="0" marL="0">
+            <a:pPr indent="0" marL="0">
               <a:buNone/>
             </a:pPr>
             <a:r>
-              <a:rPr lang="en-US" sz="7200" b="1" dirty="0">
-                <a:solidFill>
-                  <a:srgbClr val="4A8CFF"/>
-                </a:solidFill>
-                <a:latin typeface="Montserrat" pitchFamily="34" charset="0"/>
-                <a:ea typeface="Montserrat" pitchFamily="34" charset="-122"/>
-                <a:cs typeface="Montserrat" pitchFamily="34" charset="-120"/>
-              </a:rPr>
-              <a:t>★</a:t>
-            </a:r>
-            <a:endParaRPr lang="en-US" sz="7200" dirty="0"/>
-          </a:p>
-        </p:txBody>
-      </p:sp>
-      <p:sp>
-        <p:nvSpPr>
-          <p:cNvPr id="5" name="Text 3"/>
-          <p:cNvSpPr/>
-          <p:nvPr/>
-        </p:nvSpPr>
-        <p:spPr>
-          <a:xfrm>
-            <a:off x="4572000" y="2011680"/>
-            <a:ext cx="4114800" cy="731520"/>
-          </a:xfrm>
-          <a:prstGeom prst="rect">
-            <a:avLst/>
-          </a:prstGeom>
-          <a:noFill/>
-          <a:ln/>
-        </p:spPr>
-        <p:txBody>
-          <a:bodyPr wrap="square" lIns="0" tIns="0" rIns="0" bIns="0" rtlCol="0" anchor="ctr"/>
-          <a:lstStyle/>
-          <a:p>
-            <a:pPr algn="ctr" indent="0" marL="0">
-              <a:buNone/>
-            </a:pPr>
-            <a:r>
-              <a:rPr lang="en-US" sz="3600" b="1" dirty="0">
+              <a:rPr lang="en-US" sz="2800" b="1" dirty="0">
                 <a:solidFill>
                   <a:srgbClr val="003BA3"/>
                 </a:solidFill>
@@ -5439,51 +5148,366 @@
                 <a:ea typeface="Montserrat" pitchFamily="34" charset="-122"/>
                 <a:cs typeface="Montserrat" pitchFamily="34" charset="-120"/>
               </a:rPr>
-              <a:t>Chiusura</a:t>
+              <a:t>Misurare il valore: metriche che contano</a:t>
             </a:r>
-            <a:endParaRPr lang="en-US" sz="3600" dirty="0"/>
+            <a:endParaRPr lang="en-US" sz="2800" dirty="0"/>
           </a:p>
         </p:txBody>
       </p:sp>
       <p:sp>
         <p:nvSpPr>
-          <p:cNvPr id="6" name="Text 4"/>
-          <p:cNvSpPr/>
-          <p:nvPr/>
-        </p:nvSpPr>
-        <p:spPr>
-          <a:xfrm>
-            <a:off x="4572000" y="2743200"/>
-            <a:ext cx="4114800" cy="457200"/>
-          </a:xfrm>
-          <a:prstGeom prst="rect">
-            <a:avLst/>
-          </a:prstGeom>
-          <a:noFill/>
-          <a:ln/>
-        </p:spPr>
-        <p:txBody>
-          <a:bodyPr wrap="square" lIns="0" tIns="0" rIns="0" bIns="0" rtlCol="0" anchor="ctr"/>
-          <a:lstStyle/>
-          <a:p>
-            <a:pPr algn="ctr" indent="0" marL="0">
-              <a:buNone/>
-            </a:pPr>
-            <a:r>
-              <a:rPr lang="en-US" sz="1400" dirty="0">
-                <a:solidFill>
-                  <a:srgbClr val="4A4A5A"/>
-                </a:solidFill>
-                <a:latin typeface="Montserrat" pitchFamily="34" charset="0"/>
-                <a:ea typeface="Montserrat" pitchFamily="34" charset="-122"/>
-                <a:cs typeface="Montserrat" pitchFamily="34" charset="-120"/>
-              </a:rPr>
-              <a:t>I tre cardini e le azioni concrete</a:t>
-            </a:r>
-            <a:endParaRPr lang="en-US" sz="1400" dirty="0"/>
-          </a:p>
-        </p:txBody>
-      </p:sp>
+          <p:cNvPr id="3" name="Shape 1"/>
+          <p:cNvSpPr/>
+          <p:nvPr/>
+        </p:nvSpPr>
+        <p:spPr>
+          <a:xfrm>
+            <a:off x="0" y="4942332"/>
+            <a:ext cx="5029200" cy="201168"/>
+          </a:xfrm>
+          <a:prstGeom prst="rect">
+            <a:avLst/>
+          </a:prstGeom>
+          <a:solidFill>
+            <a:srgbClr val="003BA3"/>
+          </a:solidFill>
+          <a:ln/>
+        </p:spPr>
+      </p:sp>
+      <p:sp>
+        <p:nvSpPr>
+          <p:cNvPr id="4" name="Shape 2"/>
+          <p:cNvSpPr/>
+          <p:nvPr/>
+        </p:nvSpPr>
+        <p:spPr>
+          <a:xfrm>
+            <a:off x="5029200" y="4942332"/>
+            <a:ext cx="4114800" cy="201168"/>
+          </a:xfrm>
+          <a:prstGeom prst="rect">
+            <a:avLst/>
+          </a:prstGeom>
+          <a:solidFill>
+            <a:srgbClr val="4A8CFF"/>
+          </a:solidFill>
+          <a:ln/>
+        </p:spPr>
+      </p:sp>
+      <p:graphicFrame>
+        <p:nvGraphicFramePr>
+          <p:cNvPr id="5" name="Table 4"/>
+          <p:cNvGraphicFramePr>
+            <a:graphicFrameLocks noGrp="1"/>
+          </p:cNvGraphicFramePr>
+          <p:nvPr/>
+        </p:nvGraphicFramePr>
+        <p:xfrm>
+          <a:off x="548640" y="1097280"/>
+          <a:ext cx="8046720" cy="3401568"/>
+        </p:xfrm>
+        <a:graphic>
+          <a:graphicData uri="http://schemas.openxmlformats.org/drawingml/2006/table">
+            <a:tbl>
+              <a:tblPr>
+                <a:tableStyleId>{5C22544A-7EE6-4342-B048-85BDC9FD1C3A}</a:tableStyleId>
+              </a:tblPr>
+              <a:tblGrid>
+                <a:gridCol w="4023360"/>
+                <a:gridCol w="4023360"/>
+              </a:tblGrid>
+              <a:tr h="566928">
+                <a:tc>
+                  <a:txBody>
+                    <a:bodyPr wrap="square"/>
+                    <a:lstStyle/>
+                    <a:p>
+                      <a:pPr algn="l"/>
+                      <a:r>
+                        <a:rPr sz="1200" b="1">
+                          <a:solidFill>
+                            <a:srgbClr val="FFFFFF"/>
+                          </a:solidFill>
+                          <a:latin typeface="Montserrat"/>
+                        </a:rPr>
+                        <a:t>Metriche vanity (inutili)</a:t>
+                      </a:r>
+                    </a:p>
+                  </a:txBody>
+                  <a:tcPr marL="128016" marR="91440" marT="27432" marB="27432" anchor="ctr">
+                    <a:solidFill>
+                      <a:srgbClr val="003BA3"/>
+                    </a:solidFill>
+                  </a:tcPr>
+                </a:tc>
+                <a:tc>
+                  <a:txBody>
+                    <a:bodyPr wrap="square"/>
+                    <a:lstStyle/>
+                    <a:p>
+                      <a:pPr algn="l"/>
+                      <a:r>
+                        <a:rPr sz="1200" b="1">
+                          <a:solidFill>
+                            <a:srgbClr val="FFFFFF"/>
+                          </a:solidFill>
+                          <a:latin typeface="Montserrat"/>
+                        </a:rPr>
+                        <a:t>Metriche di valore (utili)</a:t>
+                      </a:r>
+                    </a:p>
+                  </a:txBody>
+                  <a:tcPr marL="128016" marR="91440" marT="27432" marB="27432" anchor="ctr">
+                    <a:solidFill>
+                      <a:srgbClr val="003BA3"/>
+                    </a:solidFill>
+                  </a:tcPr>
+                </a:tc>
+              </a:tr>
+              <a:tr h="566928">
+                <a:tc>
+                  <a:txBody>
+                    <a:bodyPr wrap="square"/>
+                    <a:lstStyle/>
+                    <a:p>
+                      <a:pPr algn="l"/>
+                      <a:r>
+                        <a:rPr sz="1200" b="1">
+                          <a:solidFill>
+                            <a:srgbClr val="003BA3"/>
+                          </a:solidFill>
+                          <a:latin typeface="Montserrat"/>
+                        </a:rPr>
+                        <a:t>Numero di prompt al giorno</a:t>
+                      </a:r>
+                    </a:p>
+                  </a:txBody>
+                  <a:tcPr marL="128016" marR="91440" marT="27432" marB="27432" anchor="ctr">
+                    <a:solidFill>
+                      <a:srgbClr val="FFFFFF"/>
+                    </a:solidFill>
+                  </a:tcPr>
+                </a:tc>
+                <a:tc>
+                  <a:txBody>
+                    <a:bodyPr wrap="square"/>
+                    <a:lstStyle/>
+                    <a:p>
+                      <a:pPr algn="l"/>
+                      <a:r>
+                        <a:rPr sz="1200" b="0">
+                          <a:solidFill>
+                            <a:srgbClr val="1A1A2E"/>
+                          </a:solidFill>
+                          <a:latin typeface="Montserrat"/>
+                        </a:rPr>
+                        <a:t>Tempo da richiesta a output utilizzabile</a:t>
+                      </a:r>
+                    </a:p>
+                  </a:txBody>
+                  <a:tcPr marL="128016" marR="91440" marT="27432" marB="27432" anchor="ctr">
+                    <a:solidFill>
+                      <a:srgbClr val="FFFFFF"/>
+                    </a:solidFill>
+                  </a:tcPr>
+                </a:tc>
+              </a:tr>
+              <a:tr h="566928">
+                <a:tc>
+                  <a:txBody>
+                    <a:bodyPr wrap="square"/>
+                    <a:lstStyle/>
+                    <a:p>
+                      <a:pPr algn="l"/>
+                      <a:r>
+                        <a:rPr sz="1200" b="1">
+                          <a:solidFill>
+                            <a:srgbClr val="003BA3"/>
+                          </a:solidFill>
+                          <a:latin typeface="Montserrat"/>
+                        </a:rPr>
+                        <a:t>Token consumati</a:t>
+                      </a:r>
+                    </a:p>
+                  </a:txBody>
+                  <a:tcPr marL="128016" marR="91440" marT="27432" marB="27432" anchor="ctr">
+                    <a:solidFill>
+                      <a:srgbClr val="F5F7FA"/>
+                    </a:solidFill>
+                  </a:tcPr>
+                </a:tc>
+                <a:tc>
+                  <a:txBody>
+                    <a:bodyPr wrap="square"/>
+                    <a:lstStyle/>
+                    <a:p>
+                      <a:pPr algn="l"/>
+                      <a:r>
+                        <a:rPr sz="1200" b="0">
+                          <a:solidFill>
+                            <a:srgbClr val="1A1A2E"/>
+                          </a:solidFill>
+                          <a:latin typeface="Montserrat"/>
+                        </a:rPr>
+                        <a:t>Tasso di rework (output accettati al 1º giro)</a:t>
+                      </a:r>
+                    </a:p>
+                  </a:txBody>
+                  <a:tcPr marL="128016" marR="91440" marT="27432" marB="27432" anchor="ctr">
+                    <a:solidFill>
+                      <a:srgbClr val="F5F7FA"/>
+                    </a:solidFill>
+                  </a:tcPr>
+                </a:tc>
+              </a:tr>
+              <a:tr h="566928">
+                <a:tc>
+                  <a:txBody>
+                    <a:bodyPr wrap="square"/>
+                    <a:lstStyle/>
+                    <a:p>
+                      <a:pPr algn="l"/>
+                      <a:r>
+                        <a:rPr sz="1200" b="1">
+                          <a:solidFill>
+                            <a:srgbClr val="003BA3"/>
+                          </a:solidFill>
+                          <a:latin typeface="Montserrat"/>
+                        </a:rPr>
+                        <a:t>Utenti attivi</a:t>
+                      </a:r>
+                    </a:p>
+                  </a:txBody>
+                  <a:tcPr marL="128016" marR="91440" marT="27432" marB="27432" anchor="ctr">
+                    <a:solidFill>
+                      <a:srgbClr val="FFFFFF"/>
+                    </a:solidFill>
+                  </a:tcPr>
+                </a:tc>
+                <a:tc>
+                  <a:txBody>
+                    <a:bodyPr wrap="square"/>
+                    <a:lstStyle/>
+                    <a:p>
+                      <a:pPr algn="l"/>
+                      <a:r>
+                        <a:rPr sz="1200" b="0">
+                          <a:solidFill>
+                            <a:srgbClr val="1A1A2E"/>
+                          </a:solidFill>
+                          <a:latin typeface="Montserrat"/>
+                        </a:rPr>
+                        <a:t>Copertura dei controlli (check eseguiti)</a:t>
+                      </a:r>
+                    </a:p>
+                  </a:txBody>
+                  <a:tcPr marL="128016" marR="91440" marT="27432" marB="27432" anchor="ctr">
+                    <a:solidFill>
+                      <a:srgbClr val="FFFFFF"/>
+                    </a:solidFill>
+                  </a:tcPr>
+                </a:tc>
+              </a:tr>
+              <a:tr h="566928">
+                <a:tc>
+                  <a:txBody>
+                    <a:bodyPr wrap="square"/>
+                    <a:lstStyle/>
+                    <a:p>
+                      <a:pPr algn="l"/>
+                      <a:r>
+                        <a:rPr sz="1200" b="1">
+                          <a:solidFill>
+                            <a:srgbClr val="003BA3"/>
+                          </a:solidFill>
+                          <a:latin typeface="Montserrat"/>
+                        </a:rPr>
+                        <a:t>Soddisfazione generica</a:t>
+                      </a:r>
+                    </a:p>
+                  </a:txBody>
+                  <a:tcPr marL="128016" marR="91440" marT="27432" marB="27432" anchor="ctr">
+                    <a:solidFill>
+                      <a:srgbClr val="F5F7FA"/>
+                    </a:solidFill>
+                  </a:tcPr>
+                </a:tc>
+                <a:tc>
+                  <a:txBody>
+                    <a:bodyPr wrap="square"/>
+                    <a:lstStyle/>
+                    <a:p>
+                      <a:pPr algn="l"/>
+                      <a:r>
+                        <a:rPr sz="1200" b="0">
+                          <a:solidFill>
+                            <a:srgbClr val="1A1A2E"/>
+                          </a:solidFill>
+                          <a:latin typeface="Montserrat"/>
+                        </a:rPr>
+                        <a:t>Riproducibilità (stesso input = stesso output)</a:t>
+                      </a:r>
+                    </a:p>
+                  </a:txBody>
+                  <a:tcPr marL="128016" marR="91440" marT="27432" marB="27432" anchor="ctr">
+                    <a:solidFill>
+                      <a:srgbClr val="F5F7FA"/>
+                    </a:solidFill>
+                  </a:tcPr>
+                </a:tc>
+              </a:tr>
+              <a:tr h="566928">
+                <a:tc>
+                  <a:txBody>
+                    <a:bodyPr wrap="square"/>
+                    <a:lstStyle/>
+                    <a:p>
+                      <a:pPr algn="l"/>
+                      <a:r>
+                        <a:rPr sz="1200" b="1">
+                          <a:solidFill>
+                            <a:srgbClr val="003BA3"/>
+                          </a:solidFill>
+                          <a:latin typeface="Montserrat"/>
+                        </a:rPr>
+                        <a:t>Costo per query</a:t>
+                      </a:r>
+                    </a:p>
+                  </a:txBody>
+                  <a:tcPr marL="128016" marR="91440" marT="27432" marB="27432" anchor="ctr">
+                    <a:solidFill>
+                      <a:srgbClr val="FFFFFF"/>
+                    </a:solidFill>
+                  </a:tcPr>
+                </a:tc>
+                <a:tc>
+                  <a:txBody>
+                    <a:bodyPr wrap="square"/>
+                    <a:lstStyle/>
+                    <a:p>
+                      <a:pPr algn="l"/>
+                      <a:r>
+                        <a:rPr sz="1200" b="0">
+                          <a:solidFill>
+                            <a:srgbClr val="1A1A2E"/>
+                          </a:solidFill>
+                          <a:latin typeface="Montserrat"/>
+                        </a:rPr>
+                        <a:t>Audit trail (tracciabilità delle decisioni)</a:t>
+                      </a:r>
+                    </a:p>
+                  </a:txBody>
+                  <a:tcPr marL="128016" marR="91440" marT="27432" marB="27432" anchor="ctr">
+                    <a:solidFill>
+                      <a:srgbClr val="FFFFFF"/>
+                    </a:solidFill>
+                  </a:tcPr>
+                </a:tc>
+              </a:tr>
+            </a:tbl>
+          </a:graphicData>
+        </a:graphic>
+      </p:graphicFrame>
     </p:spTree>
   </p:cSld>
   <p:clrMapOvr>
@@ -5504,6 +5528,181 @@
       <p:grpSpPr/>
       <p:sp>
         <p:nvSpPr>
+          <p:cNvPr id="2" name="Shape 0"/>
+          <p:cNvSpPr/>
+          <p:nvPr/>
+        </p:nvSpPr>
+        <p:spPr>
+          <a:xfrm>
+            <a:off x="2560320" y="-274320"/>
+            <a:ext cx="1645920" cy="2926080"/>
+          </a:xfrm>
+          <a:prstGeom prst="rect">
+            <a:avLst/>
+          </a:prstGeom>
+          <a:solidFill>
+            <a:srgbClr val="4A8CFF"/>
+          </a:solidFill>
+          <a:ln/>
+        </p:spPr>
+      </p:sp>
+      <p:sp>
+        <p:nvSpPr>
+          <p:cNvPr id="3" name="Shape 1"/>
+          <p:cNvSpPr/>
+          <p:nvPr/>
+        </p:nvSpPr>
+        <p:spPr>
+          <a:xfrm>
+            <a:off x="1371600" y="2377440"/>
+            <a:ext cx="1645920" cy="1828800"/>
+          </a:xfrm>
+          <a:prstGeom prst="rect">
+            <a:avLst/>
+          </a:prstGeom>
+          <a:solidFill>
+            <a:srgbClr val="F5F7FA"/>
+          </a:solidFill>
+          <a:ln/>
+        </p:spPr>
+      </p:sp>
+      <p:sp>
+        <p:nvSpPr>
+          <p:cNvPr id="4" name="Text 2"/>
+          <p:cNvSpPr/>
+          <p:nvPr/>
+        </p:nvSpPr>
+        <p:spPr>
+          <a:xfrm>
+            <a:off x="4572000" y="914400"/>
+            <a:ext cx="4114800" cy="1097280"/>
+          </a:xfrm>
+          <a:prstGeom prst="rect">
+            <a:avLst/>
+          </a:prstGeom>
+          <a:noFill/>
+          <a:ln/>
+        </p:spPr>
+        <p:txBody>
+          <a:bodyPr wrap="square" lIns="0" tIns="0" rIns="0" bIns="0" rtlCol="0" anchor="ctr"/>
+          <a:lstStyle/>
+          <a:p>
+            <a:pPr algn="ctr" indent="0" marL="0">
+              <a:buNone/>
+            </a:pPr>
+            <a:r>
+              <a:rPr lang="en-US" sz="7200" b="1" dirty="0">
+                <a:solidFill>
+                  <a:srgbClr val="4A8CFF"/>
+                </a:solidFill>
+                <a:latin typeface="Montserrat" pitchFamily="34" charset="0"/>
+                <a:ea typeface="Montserrat" pitchFamily="34" charset="-122"/>
+                <a:cs typeface="Montserrat" pitchFamily="34" charset="-120"/>
+              </a:rPr>
+              <a:t>★</a:t>
+            </a:r>
+            <a:endParaRPr lang="en-US" sz="7200" dirty="0"/>
+          </a:p>
+        </p:txBody>
+      </p:sp>
+      <p:sp>
+        <p:nvSpPr>
+          <p:cNvPr id="5" name="Text 3"/>
+          <p:cNvSpPr/>
+          <p:nvPr/>
+        </p:nvSpPr>
+        <p:spPr>
+          <a:xfrm>
+            <a:off x="4572000" y="2011680"/>
+            <a:ext cx="4114800" cy="731520"/>
+          </a:xfrm>
+          <a:prstGeom prst="rect">
+            <a:avLst/>
+          </a:prstGeom>
+          <a:noFill/>
+          <a:ln/>
+        </p:spPr>
+        <p:txBody>
+          <a:bodyPr wrap="square" lIns="0" tIns="0" rIns="0" bIns="0" rtlCol="0" anchor="ctr"/>
+          <a:lstStyle/>
+          <a:p>
+            <a:pPr algn="ctr" indent="0" marL="0">
+              <a:buNone/>
+            </a:pPr>
+            <a:r>
+              <a:rPr lang="en-US" sz="3600" b="1" dirty="0">
+                <a:solidFill>
+                  <a:srgbClr val="003BA3"/>
+                </a:solidFill>
+                <a:latin typeface="Montserrat" pitchFamily="34" charset="0"/>
+                <a:ea typeface="Montserrat" pitchFamily="34" charset="-122"/>
+                <a:cs typeface="Montserrat" pitchFamily="34" charset="-120"/>
+              </a:rPr>
+              <a:t>Chiusura</a:t>
+            </a:r>
+            <a:endParaRPr lang="en-US" sz="3600" dirty="0"/>
+          </a:p>
+        </p:txBody>
+      </p:sp>
+      <p:sp>
+        <p:nvSpPr>
+          <p:cNvPr id="6" name="Text 4"/>
+          <p:cNvSpPr/>
+          <p:nvPr/>
+        </p:nvSpPr>
+        <p:spPr>
+          <a:xfrm>
+            <a:off x="4572000" y="2743200"/>
+            <a:ext cx="4114800" cy="457200"/>
+          </a:xfrm>
+          <a:prstGeom prst="rect">
+            <a:avLst/>
+          </a:prstGeom>
+          <a:noFill/>
+          <a:ln/>
+        </p:spPr>
+        <p:txBody>
+          <a:bodyPr wrap="square" lIns="0" tIns="0" rIns="0" bIns="0" rtlCol="0" anchor="ctr"/>
+          <a:lstStyle/>
+          <a:p>
+            <a:pPr algn="ctr" indent="0" marL="0">
+              <a:buNone/>
+            </a:pPr>
+            <a:r>
+              <a:rPr lang="en-US" sz="1400" dirty="0">
+                <a:solidFill>
+                  <a:srgbClr val="4A4A5A"/>
+                </a:solidFill>
+                <a:latin typeface="Montserrat" pitchFamily="34" charset="0"/>
+                <a:ea typeface="Montserrat" pitchFamily="34" charset="-122"/>
+                <a:cs typeface="Montserrat" pitchFamily="34" charset="-120"/>
+              </a:rPr>
+              <a:t>I tre cardini e le azioni concrete</a:t>
+            </a:r>
+            <a:endParaRPr lang="en-US" sz="1400" dirty="0"/>
+          </a:p>
+        </p:txBody>
+      </p:sp>
+    </p:spTree>
+  </p:cSld>
+  <p:clrMapOvr>
+    <a:masterClrMapping/>
+  </p:clrMapOvr>
+</p:sld>
+</file>
+
+<file path=ppt/slides/slide34.xml><?xml version="1.0" encoding="utf-8"?>
+<p:sld xmlns:a="http://schemas.openxmlformats.org/drawingml/2006/main" xmlns:p="http://schemas.openxmlformats.org/presentationml/2006/main" xmlns:r="http://schemas.openxmlformats.org/officeDocument/2006/relationships">
+  <p:cSld>
+    <p:spTree>
+      <p:nvGrpSpPr>
+        <p:cNvPr id="1" name=""/>
+        <p:cNvGrpSpPr/>
+        <p:nvPr/>
+      </p:nvGrpSpPr>
+      <p:grpSpPr/>
+      <p:sp>
+        <p:nvSpPr>
           <p:cNvPr id="2" name="Text 0"/>
           <p:cNvSpPr/>
           <p:nvPr/>
@@ -6072,7 +6271,7 @@
 </p:sld>
 </file>
 
-<file path=ppt/slides/slide34.xml><?xml version="1.0" encoding="utf-8"?>
+<file path=ppt/slides/slide35.xml><?xml version="1.0" encoding="utf-8"?>
 <p:sld xmlns:a="http://schemas.openxmlformats.org/drawingml/2006/main" xmlns:p="http://schemas.openxmlformats.org/presentationml/2006/main" xmlns:r="http://schemas.openxmlformats.org/officeDocument/2006/relationships">
   <p:cSld>
     <p:spTree>
@@ -6547,7 +6746,7 @@
 </p:sld>
 </file>
 
-<file path=ppt/slides/slide35.xml><?xml version="1.0" encoding="utf-8"?>
+<file path=ppt/slides/slide36.xml><?xml version="1.0" encoding="utf-8"?>
 <p:sld xmlns:a="http://schemas.openxmlformats.org/drawingml/2006/main" xmlns:p="http://schemas.openxmlformats.org/presentationml/2006/main" xmlns:r="http://schemas.openxmlformats.org/officeDocument/2006/relationships">
   <p:cSld>
     <p:spTree>
@@ -6765,181 +6964,6 @@
                 <a:cs typeface="Montserrat" pitchFamily="34" charset="-120"/>
               </a:rPr>
               <a:t>VALUATION ANALYST</a:t>
-            </a:r>
-            <a:endParaRPr lang="en-US" sz="1400" dirty="0"/>
-          </a:p>
-        </p:txBody>
-      </p:sp>
-    </p:spTree>
-  </p:cSld>
-  <p:clrMapOvr>
-    <a:masterClrMapping/>
-  </p:clrMapOvr>
-</p:sld>
-</file>
-
-<file path=ppt/slides/slide36.xml><?xml version="1.0" encoding="utf-8"?>
-<p:sld xmlns:a="http://schemas.openxmlformats.org/drawingml/2006/main" xmlns:p="http://schemas.openxmlformats.org/presentationml/2006/main" xmlns:r="http://schemas.openxmlformats.org/officeDocument/2006/relationships">
-  <p:cSld>
-    <p:spTree>
-      <p:nvGrpSpPr>
-        <p:cNvPr id="1" name=""/>
-        <p:cNvGrpSpPr/>
-        <p:nvPr/>
-      </p:nvGrpSpPr>
-      <p:grpSpPr/>
-      <p:sp>
-        <p:nvSpPr>
-          <p:cNvPr id="2" name="Shape 0"/>
-          <p:cNvSpPr/>
-          <p:nvPr/>
-        </p:nvSpPr>
-        <p:spPr>
-          <a:xfrm>
-            <a:off x="2560320" y="-274320"/>
-            <a:ext cx="1645920" cy="2926080"/>
-          </a:xfrm>
-          <a:prstGeom prst="rect">
-            <a:avLst/>
-          </a:prstGeom>
-          <a:solidFill>
-            <a:srgbClr val="4A8CFF"/>
-          </a:solidFill>
-          <a:ln/>
-        </p:spPr>
-      </p:sp>
-      <p:sp>
-        <p:nvSpPr>
-          <p:cNvPr id="3" name="Shape 1"/>
-          <p:cNvSpPr/>
-          <p:nvPr/>
-        </p:nvSpPr>
-        <p:spPr>
-          <a:xfrm>
-            <a:off x="1371600" y="2377440"/>
-            <a:ext cx="1645920" cy="1828800"/>
-          </a:xfrm>
-          <a:prstGeom prst="rect">
-            <a:avLst/>
-          </a:prstGeom>
-          <a:solidFill>
-            <a:srgbClr val="F5F7FA"/>
-          </a:solidFill>
-          <a:ln/>
-        </p:spPr>
-      </p:sp>
-      <p:sp>
-        <p:nvSpPr>
-          <p:cNvPr id="4" name="Text 2"/>
-          <p:cNvSpPr/>
-          <p:nvPr/>
-        </p:nvSpPr>
-        <p:spPr>
-          <a:xfrm>
-            <a:off x="4572000" y="914400"/>
-            <a:ext cx="4114800" cy="1097280"/>
-          </a:xfrm>
-          <a:prstGeom prst="rect">
-            <a:avLst/>
-          </a:prstGeom>
-          <a:noFill/>
-          <a:ln/>
-        </p:spPr>
-        <p:txBody>
-          <a:bodyPr wrap="square" lIns="0" tIns="0" rIns="0" bIns="0" rtlCol="0" anchor="ctr"/>
-          <a:lstStyle/>
-          <a:p>
-            <a:pPr algn="ctr" indent="0" marL="0">
-              <a:buNone/>
-            </a:pPr>
-            <a:r>
-              <a:rPr lang="en-US" sz="7200" b="1" dirty="0">
-                <a:solidFill>
-                  <a:srgbClr val="4A8CFF"/>
-                </a:solidFill>
-                <a:latin typeface="Montserrat" pitchFamily="34" charset="0"/>
-                <a:ea typeface="Montserrat" pitchFamily="34" charset="-122"/>
-                <a:cs typeface="Montserrat" pitchFamily="34" charset="-120"/>
-              </a:rPr>
-              <a:t>+</a:t>
-            </a:r>
-            <a:endParaRPr lang="en-US" sz="7200" dirty="0"/>
-          </a:p>
-        </p:txBody>
-      </p:sp>
-      <p:sp>
-        <p:nvSpPr>
-          <p:cNvPr id="5" name="Text 3"/>
-          <p:cNvSpPr/>
-          <p:nvPr/>
-        </p:nvSpPr>
-        <p:spPr>
-          <a:xfrm>
-            <a:off x="4572000" y="2011680"/>
-            <a:ext cx="4114800" cy="731520"/>
-          </a:xfrm>
-          <a:prstGeom prst="rect">
-            <a:avLst/>
-          </a:prstGeom>
-          <a:noFill/>
-          <a:ln/>
-        </p:spPr>
-        <p:txBody>
-          <a:bodyPr wrap="square" lIns="0" tIns="0" rIns="0" bIns="0" rtlCol="0" anchor="ctr"/>
-          <a:lstStyle/>
-          <a:p>
-            <a:pPr algn="ctr" indent="0" marL="0">
-              <a:buNone/>
-            </a:pPr>
-            <a:r>
-              <a:rPr lang="en-US" sz="3600" b="1" dirty="0">
-                <a:solidFill>
-                  <a:srgbClr val="003BA3"/>
-                </a:solidFill>
-                <a:latin typeface="Montserrat" pitchFamily="34" charset="0"/>
-                <a:ea typeface="Montserrat" pitchFamily="34" charset="-122"/>
-                <a:cs typeface="Montserrat" pitchFamily="34" charset="-120"/>
-              </a:rPr>
-              <a:t>Backup</a:t>
-            </a:r>
-            <a:endParaRPr lang="en-US" sz="3600" dirty="0"/>
-          </a:p>
-        </p:txBody>
-      </p:sp>
-      <p:sp>
-        <p:nvSpPr>
-          <p:cNvPr id="6" name="Text 4"/>
-          <p:cNvSpPr/>
-          <p:nvPr/>
-        </p:nvSpPr>
-        <p:spPr>
-          <a:xfrm>
-            <a:off x="4572000" y="2743200"/>
-            <a:ext cx="4114800" cy="457200"/>
-          </a:xfrm>
-          <a:prstGeom prst="rect">
-            <a:avLst/>
-          </a:prstGeom>
-          <a:noFill/>
-          <a:ln/>
-        </p:spPr>
-        <p:txBody>
-          <a:bodyPr wrap="square" lIns="0" tIns="0" rIns="0" bIns="0" rtlCol="0" anchor="ctr"/>
-          <a:lstStyle/>
-          <a:p>
-            <a:pPr algn="ctr" indent="0" marL="0">
-              <a:buNone/>
-            </a:pPr>
-            <a:r>
-              <a:rPr lang="en-US" sz="1400" dirty="0">
-                <a:solidFill>
-                  <a:srgbClr val="4A4A5A"/>
-                </a:solidFill>
-                <a:latin typeface="Montserrat" pitchFamily="34" charset="0"/>
-                <a:ea typeface="Montserrat" pitchFamily="34" charset="-122"/>
-                <a:cs typeface="Montserrat" pitchFamily="34" charset="-120"/>
-              </a:rPr>
-              <a:t>Approfondimenti per le domande</a:t>
             </a:r>
             <a:endParaRPr lang="en-US" sz="1400" dirty="0"/>
           </a:p>
@@ -6965,6 +6989,181 @@
       <p:grpSpPr/>
       <p:sp>
         <p:nvSpPr>
+          <p:cNvPr id="2" name="Shape 0"/>
+          <p:cNvSpPr/>
+          <p:nvPr/>
+        </p:nvSpPr>
+        <p:spPr>
+          <a:xfrm>
+            <a:off x="2560320" y="-274320"/>
+            <a:ext cx="1645920" cy="2926080"/>
+          </a:xfrm>
+          <a:prstGeom prst="rect">
+            <a:avLst/>
+          </a:prstGeom>
+          <a:solidFill>
+            <a:srgbClr val="4A8CFF"/>
+          </a:solidFill>
+          <a:ln/>
+        </p:spPr>
+      </p:sp>
+      <p:sp>
+        <p:nvSpPr>
+          <p:cNvPr id="3" name="Shape 1"/>
+          <p:cNvSpPr/>
+          <p:nvPr/>
+        </p:nvSpPr>
+        <p:spPr>
+          <a:xfrm>
+            <a:off x="1371600" y="2377440"/>
+            <a:ext cx="1645920" cy="1828800"/>
+          </a:xfrm>
+          <a:prstGeom prst="rect">
+            <a:avLst/>
+          </a:prstGeom>
+          <a:solidFill>
+            <a:srgbClr val="F5F7FA"/>
+          </a:solidFill>
+          <a:ln/>
+        </p:spPr>
+      </p:sp>
+      <p:sp>
+        <p:nvSpPr>
+          <p:cNvPr id="4" name="Text 2"/>
+          <p:cNvSpPr/>
+          <p:nvPr/>
+        </p:nvSpPr>
+        <p:spPr>
+          <a:xfrm>
+            <a:off x="4572000" y="914400"/>
+            <a:ext cx="4114800" cy="1097280"/>
+          </a:xfrm>
+          <a:prstGeom prst="rect">
+            <a:avLst/>
+          </a:prstGeom>
+          <a:noFill/>
+          <a:ln/>
+        </p:spPr>
+        <p:txBody>
+          <a:bodyPr wrap="square" lIns="0" tIns="0" rIns="0" bIns="0" rtlCol="0" anchor="ctr"/>
+          <a:lstStyle/>
+          <a:p>
+            <a:pPr algn="ctr" indent="0" marL="0">
+              <a:buNone/>
+            </a:pPr>
+            <a:r>
+              <a:rPr lang="en-US" sz="7200" b="1" dirty="0">
+                <a:solidFill>
+                  <a:srgbClr val="4A8CFF"/>
+                </a:solidFill>
+                <a:latin typeface="Montserrat" pitchFamily="34" charset="0"/>
+                <a:ea typeface="Montserrat" pitchFamily="34" charset="-122"/>
+                <a:cs typeface="Montserrat" pitchFamily="34" charset="-120"/>
+              </a:rPr>
+              <a:t>+</a:t>
+            </a:r>
+            <a:endParaRPr lang="en-US" sz="7200" dirty="0"/>
+          </a:p>
+        </p:txBody>
+      </p:sp>
+      <p:sp>
+        <p:nvSpPr>
+          <p:cNvPr id="5" name="Text 3"/>
+          <p:cNvSpPr/>
+          <p:nvPr/>
+        </p:nvSpPr>
+        <p:spPr>
+          <a:xfrm>
+            <a:off x="4572000" y="2011680"/>
+            <a:ext cx="4114800" cy="731520"/>
+          </a:xfrm>
+          <a:prstGeom prst="rect">
+            <a:avLst/>
+          </a:prstGeom>
+          <a:noFill/>
+          <a:ln/>
+        </p:spPr>
+        <p:txBody>
+          <a:bodyPr wrap="square" lIns="0" tIns="0" rIns="0" bIns="0" rtlCol="0" anchor="ctr"/>
+          <a:lstStyle/>
+          <a:p>
+            <a:pPr algn="ctr" indent="0" marL="0">
+              <a:buNone/>
+            </a:pPr>
+            <a:r>
+              <a:rPr lang="en-US" sz="3600" b="1" dirty="0">
+                <a:solidFill>
+                  <a:srgbClr val="003BA3"/>
+                </a:solidFill>
+                <a:latin typeface="Montserrat" pitchFamily="34" charset="0"/>
+                <a:ea typeface="Montserrat" pitchFamily="34" charset="-122"/>
+                <a:cs typeface="Montserrat" pitchFamily="34" charset="-120"/>
+              </a:rPr>
+              <a:t>Backup</a:t>
+            </a:r>
+            <a:endParaRPr lang="en-US" sz="3600" dirty="0"/>
+          </a:p>
+        </p:txBody>
+      </p:sp>
+      <p:sp>
+        <p:nvSpPr>
+          <p:cNvPr id="6" name="Text 4"/>
+          <p:cNvSpPr/>
+          <p:nvPr/>
+        </p:nvSpPr>
+        <p:spPr>
+          <a:xfrm>
+            <a:off x="4572000" y="2743200"/>
+            <a:ext cx="4114800" cy="457200"/>
+          </a:xfrm>
+          <a:prstGeom prst="rect">
+            <a:avLst/>
+          </a:prstGeom>
+          <a:noFill/>
+          <a:ln/>
+        </p:spPr>
+        <p:txBody>
+          <a:bodyPr wrap="square" lIns="0" tIns="0" rIns="0" bIns="0" rtlCol="0" anchor="ctr"/>
+          <a:lstStyle/>
+          <a:p>
+            <a:pPr algn="ctr" indent="0" marL="0">
+              <a:buNone/>
+            </a:pPr>
+            <a:r>
+              <a:rPr lang="en-US" sz="1400" dirty="0">
+                <a:solidFill>
+                  <a:srgbClr val="4A4A5A"/>
+                </a:solidFill>
+                <a:latin typeface="Montserrat" pitchFamily="34" charset="0"/>
+                <a:ea typeface="Montserrat" pitchFamily="34" charset="-122"/>
+                <a:cs typeface="Montserrat" pitchFamily="34" charset="-120"/>
+              </a:rPr>
+              <a:t>Approfondimenti per le domande</a:t>
+            </a:r>
+            <a:endParaRPr lang="en-US" sz="1400" dirty="0"/>
+          </a:p>
+        </p:txBody>
+      </p:sp>
+    </p:spTree>
+  </p:cSld>
+  <p:clrMapOvr>
+    <a:masterClrMapping/>
+  </p:clrMapOvr>
+</p:sld>
+</file>
+
+<file path=ppt/slides/slide38.xml><?xml version="1.0" encoding="utf-8"?>
+<p:sld xmlns:a="http://schemas.openxmlformats.org/drawingml/2006/main" xmlns:p="http://schemas.openxmlformats.org/presentationml/2006/main" xmlns:r="http://schemas.openxmlformats.org/officeDocument/2006/relationships">
+  <p:cSld>
+    <p:spTree>
+      <p:nvGrpSpPr>
+        <p:cNvPr id="1" name=""/>
+        <p:cNvGrpSpPr/>
+        <p:nvPr/>
+      </p:nvGrpSpPr>
+      <p:grpSpPr/>
+      <p:sp>
+        <p:nvSpPr>
           <p:cNvPr id="2" name="Text 0"/>
           <p:cNvSpPr/>
           <p:nvPr/>
@@ -7696,7 +7895,7 @@
 </p:sld>
 </file>
 
-<file path=ppt/slides/slide38.xml><?xml version="1.0" encoding="utf-8"?>
+<file path=ppt/slides/slide39.xml><?xml version="1.0" encoding="utf-8"?>
 <p:sld xmlns:a="http://schemas.openxmlformats.org/drawingml/2006/main" xmlns:p="http://schemas.openxmlformats.org/presentationml/2006/main" xmlns:r="http://schemas.openxmlformats.org/officeDocument/2006/relationships">
   <p:cSld>
     <p:spTree>

</xml_diff>

<commit_message>
Aggiunge slide 'Il volto della tecnica' con epigrafe e tesi finale
Nuova slide di chiusura Pilastro che chiude l'arco aperto dall'epigrafe
in copertina (Magnifica Humanitas, Leone XIV). Le due citazioni (§9 e §5)
sono nel box di sinistra; il banner inferiore porta solo la tesi:
'Solo con il controllo dell'architettura, la conoscenza del dominio e
una strategia consapevole la si orienta verso la persona'.

Co-Authored-By: Claude Opus 4.8 <noreply@anthropic.com>
</commit_message>
<xml_diff>
--- a/output/presentazione_ia_produttiva.pptx
+++ b/output/presentazione_ia_produttiva.pptx
@@ -32,6 +32,7 @@
     <p:sldId id="292" r:id="rId43"/>
     <p:sldId id="293" r:id="rId44"/>
     <p:sldId id="294" r:id="rId45"/>
+    <p:sldId id="295" r:id="rId46"/>
   </p:sldIdLst>
   <p:notesMasterIdLst>
     <p:notesMasterId r:id="rId14"/>
@@ -992,6 +993,62 @@
           </a:p>
         </p:txBody>
       </p:sp>
+      <p:sp>
+        <p:nvSpPr>
+          <p:cNvPr id="7" name="TextBox 6"/>
+          <p:cNvSpPr txBox="1"/>
+          <p:nvPr/>
+        </p:nvSpPr>
+        <p:spPr>
+          <a:xfrm>
+            <a:off x="2011680" y="3675887"/>
+            <a:ext cx="3749039" cy="1097280"/>
+          </a:xfrm>
+          <a:prstGeom prst="rect">
+            <a:avLst/>
+          </a:prstGeom>
+          <a:noFill/>
+        </p:spPr>
+        <p:txBody>
+          <a:bodyPr wrap="square">
+            <a:spAutoFit/>
+          </a:bodyPr>
+          <a:lstStyle/>
+          <a:p>
+            <a:r>
+              <a:rPr i="1" sz="1050">
+                <a:solidFill>
+                  <a:srgbClr val="4A4A5A"/>
+                </a:solidFill>
+                <a:latin typeface="Montserrat"/>
+              </a:rPr>
+              <a:t>«La tecnica non è neutrale: assume il volto</a:t>
+            </a:r>
+          </a:p>
+          <a:p>
+            <a:r>
+              <a:rPr i="1" sz="1050">
+                <a:solidFill>
+                  <a:srgbClr val="4A4A5A"/>
+                </a:solidFill>
+                <a:latin typeface="Montserrat"/>
+              </a:rPr>
+              <a:t>di chi la pensa, la finanzia, la regola, la usa.»</a:t>
+            </a:r>
+          </a:p>
+          <a:p>
+            <a:r>
+              <a:rPr i="0" sz="950">
+                <a:solidFill>
+                  <a:srgbClr val="003BA3"/>
+                </a:solidFill>
+                <a:latin typeface="Montserrat"/>
+              </a:rPr>
+              <a:t>— Leone XIV, Magnifica Humanitas (2026), §9</a:t>
+            </a:r>
+          </a:p>
+        </p:txBody>
+      </p:sp>
     </p:spTree>
   </p:cSld>
   <p:clrMapOvr>
@@ -6306,7 +6363,7 @@
               <a:buNone/>
             </a:pPr>
             <a:r>
-              <a:rPr lang="en-US" sz="2400" b="1" dirty="0">
+              <a:rPr lang="en-US" sz="2100" b="1" dirty="0">
                 <a:solidFill>
                   <a:srgbClr val="003BA3"/>
                 </a:solidFill>
@@ -6314,7 +6371,7 @@
                 <a:ea typeface="Montserrat" pitchFamily="34" charset="-122"/>
                 <a:cs typeface="Montserrat" pitchFamily="34" charset="-120"/>
               </a:rPr>
-              <a:t>Call to action: 3 mosse per lunedì mattina</a:t>
+              <a:t>Il volto della tecnica: l'architettura orienta verso la persona</a:t>
             </a:r>
             <a:endParaRPr lang="en-US" sz="2800" dirty="0"/>
           </a:p>
@@ -6360,384 +6417,36 @@
           <a:ln/>
         </p:spPr>
       </p:sp>
-      <p:sp>
-        <p:nvSpPr>
-          <p:cNvPr id="5" name="Shape 3"/>
-          <p:cNvSpPr/>
-          <p:nvPr/>
-        </p:nvSpPr>
-        <p:spPr>
-          <a:xfrm>
-            <a:off x="548640" y="1005840"/>
-            <a:ext cx="3291840" cy="3657600"/>
-          </a:xfrm>
-          <a:prstGeom prst="rect">
-            <a:avLst/>
-          </a:prstGeom>
-          <a:solidFill>
-            <a:srgbClr val="F5F7FA"/>
-          </a:solidFill>
-          <a:ln/>
-        </p:spPr>
-      </p:sp>
-      <p:sp>
-        <p:nvSpPr>
-          <p:cNvPr id="6" name="Text 4"/>
-          <p:cNvSpPr/>
-          <p:nvPr/>
-        </p:nvSpPr>
-        <p:spPr>
-          <a:xfrm>
-            <a:off x="731520" y="1188720"/>
-            <a:ext cx="2926080" cy="914400"/>
-          </a:xfrm>
-          <a:prstGeom prst="rect">
-            <a:avLst/>
-          </a:prstGeom>
-          <a:noFill/>
-          <a:ln/>
-        </p:spPr>
-        <p:txBody>
-          <a:bodyPr wrap="square" lIns="0" tIns="0" rIns="0" bIns="0" rtlCol="0" anchor="ctr"/>
-          <a:lstStyle/>
-          <a:p>
-            <a:pPr indent="0" marL="0">
-              <a:buNone/>
-            </a:pPr>
-            <a:r>
-              <a:rPr lang="en-US" sz="2000" b="1" dirty="0">
-                <a:solidFill>
-                  <a:srgbClr val="003BA3"/>
-                </a:solidFill>
-                <a:latin typeface="Montserrat" pitchFamily="34" charset="0"/>
-                <a:ea typeface="Montserrat" pitchFamily="34" charset="-122"/>
-                <a:cs typeface="Montserrat" pitchFamily="34" charset="-120"/>
-              </a:rPr>
-              <a:t>Costruite</a:t>
-            </a:r>
-            <a:endParaRPr lang="en-US" sz="2000" dirty="0"/>
-          </a:p>
-          <a:p>
-            <a:pPr indent="0" marL="0">
-              <a:buNone/>
-            </a:pPr>
-            <a:r>
-              <a:rPr lang="en-US" sz="2000" b="1" dirty="0">
-                <a:solidFill>
-                  <a:srgbClr val="003BA3"/>
-                </a:solidFill>
-                <a:latin typeface="Montserrat" pitchFamily="34" charset="0"/>
-                <a:ea typeface="Montserrat" pitchFamily="34" charset="-122"/>
-                <a:cs typeface="Montserrat" pitchFamily="34" charset="-120"/>
-              </a:rPr>
-              <a:t>sistemi,</a:t>
-            </a:r>
-            <a:endParaRPr lang="en-US" sz="2000" dirty="0"/>
-          </a:p>
-          <a:p>
-            <a:pPr indent="0" marL="0">
-              <a:buNone/>
-            </a:pPr>
-            <a:r>
-              <a:rPr lang="en-US" sz="2000" b="1" dirty="0">
-                <a:solidFill>
-                  <a:srgbClr val="003BA3"/>
-                </a:solidFill>
-                <a:latin typeface="Montserrat" pitchFamily="34" charset="0"/>
-                <a:ea typeface="Montserrat" pitchFamily="34" charset="-122"/>
-                <a:cs typeface="Montserrat" pitchFamily="34" charset="-120"/>
-              </a:rPr>
-              <a:t>non prompt</a:t>
-            </a:r>
-            <a:endParaRPr lang="en-US" sz="2000" dirty="0"/>
-          </a:p>
-        </p:txBody>
-      </p:sp>
-      <p:sp>
-        <p:nvSpPr>
-          <p:cNvPr id="7" name="Text 5"/>
-          <p:cNvSpPr/>
-          <p:nvPr/>
-        </p:nvSpPr>
-        <p:spPr>
-          <a:xfrm>
-            <a:off x="731520" y="2194560"/>
-            <a:ext cx="2926080" cy="2194560"/>
-          </a:xfrm>
-          <a:prstGeom prst="rect">
-            <a:avLst/>
-          </a:prstGeom>
-          <a:noFill/>
-          <a:ln/>
-        </p:spPr>
-        <p:txBody>
-          <a:bodyPr wrap="square" lIns="0" tIns="0" rIns="0" bIns="0" rtlCol="0" anchor="t"/>
-          <a:lstStyle/>
-          <a:p>
-            <a:pPr indent="0" marL="0">
-              <a:lnSpc>
-                <a:spcPct val="140000"/>
-              </a:lnSpc>
-              <a:buNone/>
-            </a:pPr>
-            <a:r>
-              <a:rPr lang="en-US" sz="1200" dirty="0">
-                <a:solidFill>
-                  <a:srgbClr val="4A4A5A"/>
-                </a:solidFill>
-                <a:latin typeface="Montserrat" pitchFamily="34" charset="0"/>
-                <a:ea typeface="Montserrat" pitchFamily="34" charset="-122"/>
-                <a:cs typeface="Montserrat" pitchFamily="34" charset="-120"/>
-              </a:rPr>
-              <a:t>Smettete di chiedere all'IA di fare cose. Iniziate a costruire sistemi che sanno farle.</a:t>
-            </a:r>
-            <a:endParaRPr lang="en-US" sz="1200" dirty="0"/>
-          </a:p>
-        </p:txBody>
-      </p:sp>
-      <p:sp>
-        <p:nvSpPr>
-          <p:cNvPr id="8" name="Text 6"/>
-          <p:cNvSpPr/>
-          <p:nvPr/>
-        </p:nvSpPr>
-        <p:spPr>
-          <a:xfrm>
-            <a:off x="4206240" y="1097280"/>
-            <a:ext cx="4572000" cy="320040"/>
-          </a:xfrm>
-          <a:prstGeom prst="rect">
-            <a:avLst/>
-          </a:prstGeom>
-          <a:noFill/>
-          <a:ln/>
-        </p:spPr>
-        <p:txBody>
-          <a:bodyPr wrap="square" lIns="0" tIns="0" rIns="0" bIns="0" rtlCol="0" anchor="ctr"/>
-          <a:lstStyle/>
-          <a:p>
-            <a:pPr indent="0" marL="0">
-              <a:buNone/>
-            </a:pPr>
-            <a:r>
-              <a:rPr lang="en-US" sz="1400" b="1" dirty="0">
-                <a:solidFill>
-                  <a:srgbClr val="003BA3"/>
-                </a:solidFill>
-                <a:latin typeface="Montserrat" pitchFamily="34" charset="0"/>
-                <a:ea typeface="Montserrat" pitchFamily="34" charset="-122"/>
-                <a:cs typeface="Montserrat" pitchFamily="34" charset="-120"/>
-              </a:rPr>
-              <a:t>1 · Scrivete un workflow come skill</a:t>
-            </a:r>
-            <a:endParaRPr lang="en-US" sz="1400" dirty="0"/>
-          </a:p>
-        </p:txBody>
-      </p:sp>
-      <p:sp>
-        <p:nvSpPr>
-          <p:cNvPr id="9" name="Text 7"/>
-          <p:cNvSpPr/>
-          <p:nvPr/>
-        </p:nvSpPr>
-        <p:spPr>
-          <a:xfrm>
-            <a:off x="4206240" y="1417320"/>
-            <a:ext cx="4572000" cy="640080"/>
-          </a:xfrm>
-          <a:prstGeom prst="rect">
-            <a:avLst/>
-          </a:prstGeom>
-          <a:noFill/>
-          <a:ln/>
-        </p:spPr>
-        <p:txBody>
-          <a:bodyPr wrap="square" lIns="0" tIns="0" rIns="0" bIns="0" rtlCol="0" anchor="ctr"/>
-          <a:lstStyle/>
-          <a:p>
-            <a:pPr indent="0" marL="0">
-              <a:lnSpc>
-                <a:spcPct val="130000"/>
-              </a:lnSpc>
-              <a:buNone/>
-            </a:pPr>
-            <a:r>
-              <a:rPr lang="en-US" sz="1100" dirty="0">
-                <a:solidFill>
-                  <a:srgbClr val="4A4A5A"/>
-                </a:solidFill>
-                <a:latin typeface="Montserrat" pitchFamily="34" charset="0"/>
-                <a:ea typeface="Montserrat" pitchFamily="34" charset="-122"/>
-                <a:cs typeface="Montserrat" pitchFamily="34" charset="-120"/>
-              </a:rPr>
-              <a:t>Vincoli, step, checkpoint, errori comuni. Non serve codice: basta un documento.</a:t>
-            </a:r>
-            <a:endParaRPr lang="en-US" sz="1100" dirty="0"/>
-          </a:p>
-        </p:txBody>
-      </p:sp>
-      <p:sp>
-        <p:nvSpPr>
-          <p:cNvPr id="10" name="Text 8"/>
-          <p:cNvSpPr/>
-          <p:nvPr/>
-        </p:nvSpPr>
-        <p:spPr>
-          <a:xfrm>
-            <a:off x="4206240" y="2240280"/>
-            <a:ext cx="4572000" cy="320040"/>
-          </a:xfrm>
-          <a:prstGeom prst="rect">
-            <a:avLst/>
-          </a:prstGeom>
-          <a:noFill/>
-          <a:ln/>
-        </p:spPr>
-        <p:txBody>
-          <a:bodyPr wrap="square" lIns="0" tIns="0" rIns="0" bIns="0" rtlCol="0" anchor="ctr"/>
-          <a:lstStyle/>
-          <a:p>
-            <a:pPr indent="0" marL="0">
-              <a:buNone/>
-            </a:pPr>
-            <a:r>
-              <a:rPr lang="en-US" sz="1400" b="1" dirty="0">
-                <a:solidFill>
-                  <a:srgbClr val="003BA3"/>
-                </a:solidFill>
-                <a:latin typeface="Montserrat" pitchFamily="34" charset="0"/>
-                <a:ea typeface="Montserrat" pitchFamily="34" charset="-122"/>
-                <a:cs typeface="Montserrat" pitchFamily="34" charset="-120"/>
-              </a:rPr>
-              <a:t>2 · Mappate i decision gate</a:t>
-            </a:r>
-            <a:endParaRPr lang="en-US" sz="1400" dirty="0"/>
-          </a:p>
-        </p:txBody>
-      </p:sp>
-      <p:sp>
-        <p:nvSpPr>
-          <p:cNvPr id="11" name="Text 9"/>
-          <p:cNvSpPr/>
-          <p:nvPr/>
-        </p:nvSpPr>
-        <p:spPr>
-          <a:xfrm>
-            <a:off x="4206240" y="2560320"/>
-            <a:ext cx="4572000" cy="640080"/>
-          </a:xfrm>
-          <a:prstGeom prst="rect">
-            <a:avLst/>
-          </a:prstGeom>
-          <a:noFill/>
-          <a:ln/>
-        </p:spPr>
-        <p:txBody>
-          <a:bodyPr wrap="square" lIns="0" tIns="0" rIns="0" bIns="0" rtlCol="0" anchor="ctr"/>
-          <a:lstStyle/>
-          <a:p>
-            <a:pPr indent="0" marL="0">
-              <a:lnSpc>
-                <a:spcPct val="130000"/>
-              </a:lnSpc>
-              <a:buNone/>
-            </a:pPr>
-            <a:r>
-              <a:rPr lang="en-US" sz="1100" dirty="0">
-                <a:solidFill>
-                  <a:srgbClr val="4A4A5A"/>
-                </a:solidFill>
-                <a:latin typeface="Montserrat" pitchFamily="34" charset="0"/>
-                <a:ea typeface="Montserrat" pitchFamily="34" charset="-122"/>
-                <a:cs typeface="Montserrat" pitchFamily="34" charset="-120"/>
-              </a:rPr>
-              <a:t>Dove l'IA procede da sola e dove si ferma. Usate la matrice rischio/reversibilità.</a:t>
-            </a:r>
-            <a:endParaRPr lang="en-US" sz="1100" dirty="0"/>
-          </a:p>
-        </p:txBody>
-      </p:sp>
-      <p:sp>
-        <p:nvSpPr>
-          <p:cNvPr id="12" name="Text 10"/>
-          <p:cNvSpPr/>
-          <p:nvPr/>
-        </p:nvSpPr>
-        <p:spPr>
-          <a:xfrm>
-            <a:off x="4206240" y="3383280"/>
-            <a:ext cx="4572000" cy="320040"/>
-          </a:xfrm>
-          <a:prstGeom prst="rect">
-            <a:avLst/>
-          </a:prstGeom>
-          <a:noFill/>
-          <a:ln/>
-        </p:spPr>
-        <p:txBody>
-          <a:bodyPr wrap="square" lIns="0" tIns="0" rIns="0" bIns="0" rtlCol="0" anchor="ctr"/>
-          <a:lstStyle/>
-          <a:p>
-            <a:pPr indent="0" marL="0">
-              <a:buNone/>
-            </a:pPr>
-            <a:r>
-              <a:rPr lang="en-US" sz="1400" b="1" dirty="0">
-                <a:solidFill>
-                  <a:srgbClr val="003BA3"/>
-                </a:solidFill>
-                <a:latin typeface="Montserrat" pitchFamily="34" charset="0"/>
-                <a:ea typeface="Montserrat" pitchFamily="34" charset="-122"/>
-                <a:cs typeface="Montserrat" pitchFamily="34" charset="-120"/>
-              </a:rPr>
-              <a:t>3 · Partite piccoli e misurate</a:t>
-            </a:r>
-            <a:endParaRPr lang="en-US" sz="1400" dirty="0"/>
-          </a:p>
-        </p:txBody>
-      </p:sp>
-      <p:sp>
-        <p:nvSpPr>
-          <p:cNvPr id="13" name="Text 11"/>
-          <p:cNvSpPr/>
-          <p:nvPr/>
-        </p:nvSpPr>
-        <p:spPr>
-          <a:xfrm>
-            <a:off x="4206240" y="3703320"/>
-            <a:ext cx="4572000" cy="640080"/>
-          </a:xfrm>
-          <a:prstGeom prst="rect">
-            <a:avLst/>
-          </a:prstGeom>
-          <a:noFill/>
-          <a:ln/>
-        </p:spPr>
-        <p:txBody>
-          <a:bodyPr wrap="square" lIns="0" tIns="0" rIns="0" bIns="0" rtlCol="0" anchor="ctr"/>
-          <a:lstStyle/>
-          <a:p>
-            <a:pPr indent="0" marL="0">
-              <a:lnSpc>
-                <a:spcPct val="130000"/>
-              </a:lnSpc>
-              <a:buNone/>
-            </a:pPr>
-            <a:r>
-              <a:rPr lang="en-US" sz="1100" dirty="0">
-                <a:solidFill>
-                  <a:srgbClr val="4A4A5A"/>
-                </a:solidFill>
-                <a:latin typeface="Montserrat" pitchFamily="34" charset="0"/>
-                <a:ea typeface="Montserrat" pitchFamily="34" charset="-122"/>
-                <a:cs typeface="Montserrat" pitchFamily="34" charset="-120"/>
-              </a:rPr>
-              <a:t>Un agente, una skill, un workflow. Misurate gli output utilizzabili, non i prompt.</a:t>
-            </a:r>
-            <a:endParaRPr lang="en-US" sz="1100" dirty="0"/>
-          </a:p>
-        </p:txBody>
-      </p:sp>
+      <p:pic>
+        <p:nvPicPr>
+          <p:cNvPr id="5" name="Picture 4" descr="image.png"/>
+          <p:cNvPicPr>
+            <a:picLocks noChangeAspect="1"/>
+          </p:cNvPicPr>
+          <p:nvPr/>
+        </p:nvPicPr>
+        <p:blipFill>
+          <a:blip r:embed="rId2">
+            <a:extLst>
+              <a:ext uri="{96DAC541-7B7A-43D3-8B79-37D633B846F1}">
+                <ns0:svgBlip xmlns:ns0="http://schemas.microsoft.com/office/drawing/2016/SVG/main" r:embed="rId3"/>
+              </a:ext>
+            </a:extLst>
+          </a:blip>
+          <a:stretch>
+            <a:fillRect/>
+          </a:stretch>
+        </p:blipFill>
+        <p:spPr>
+          <a:xfrm>
+            <a:off x="411480" y="1078992"/>
+            <a:ext cx="8321040" cy="3703320"/>
+          </a:xfrm>
+          <a:prstGeom prst="rect">
+            <a:avLst/>
+          </a:prstGeom>
+        </p:spPr>
+      </p:pic>
     </p:spTree>
   </p:cSld>
   <p:clrMapOvr>
@@ -6758,54 +6467,14 @@
       <p:grpSpPr/>
       <p:sp>
         <p:nvSpPr>
-          <p:cNvPr id="2" name="Shape 0"/>
-          <p:cNvSpPr/>
-          <p:nvPr/>
-        </p:nvSpPr>
-        <p:spPr>
-          <a:xfrm>
-            <a:off x="7498080" y="0"/>
-            <a:ext cx="1645920" cy="3200400"/>
-          </a:xfrm>
-          <a:prstGeom prst="rect">
-            <a:avLst/>
-          </a:prstGeom>
-          <a:solidFill>
-            <a:srgbClr val="4A8CFF"/>
-          </a:solidFill>
-          <a:ln/>
-        </p:spPr>
-      </p:sp>
-      <p:sp>
-        <p:nvSpPr>
-          <p:cNvPr id="3" name="Shape 1"/>
-          <p:cNvSpPr/>
-          <p:nvPr/>
-        </p:nvSpPr>
-        <p:spPr>
-          <a:xfrm>
-            <a:off x="6217920" y="2926080"/>
-            <a:ext cx="1645920" cy="2217420"/>
-          </a:xfrm>
-          <a:prstGeom prst="rect">
-            <a:avLst/>
-          </a:prstGeom>
-          <a:solidFill>
-            <a:srgbClr val="F5F7FA"/>
-          </a:solidFill>
-          <a:ln/>
-        </p:spPr>
-      </p:sp>
-      <p:sp>
-        <p:nvSpPr>
-          <p:cNvPr id="4" name="Text 2"/>
-          <p:cNvSpPr/>
-          <p:nvPr/>
-        </p:nvSpPr>
-        <p:spPr>
-          <a:xfrm>
-            <a:off x="731520" y="731520"/>
-            <a:ext cx="5486400" cy="1371600"/>
+          <p:cNvPr id="2" name="Text 0"/>
+          <p:cNvSpPr/>
+          <p:nvPr/>
+        </p:nvSpPr>
+        <p:spPr>
+          <a:xfrm>
+            <a:off x="548640" y="228600"/>
+            <a:ext cx="8046720" cy="594360"/>
           </a:xfrm>
           <a:prstGeom prst="rect">
             <a:avLst/>
@@ -6821,7 +6490,7 @@
               <a:buNone/>
             </a:pPr>
             <a:r>
-              <a:rPr lang="en-US" sz="4800" b="1" dirty="0">
+              <a:rPr lang="en-US" sz="2400" b="1" dirty="0">
                 <a:solidFill>
                   <a:srgbClr val="003BA3"/>
                 </a:solidFill>
@@ -6829,22 +6498,82 @@
                 <a:ea typeface="Montserrat" pitchFamily="34" charset="-122"/>
                 <a:cs typeface="Montserrat" pitchFamily="34" charset="-120"/>
               </a:rPr>
-              <a:t>Grazie</a:t>
-            </a:r>
-            <a:endParaRPr lang="en-US" sz="4800" dirty="0"/>
+              <a:t>Call to action: 3 mosse per lunedì mattina</a:t>
+            </a:r>
+            <a:endParaRPr lang="en-US" sz="2800" dirty="0"/>
           </a:p>
         </p:txBody>
       </p:sp>
       <p:sp>
         <p:nvSpPr>
-          <p:cNvPr id="5" name="Text 3"/>
-          <p:cNvSpPr/>
-          <p:nvPr/>
-        </p:nvSpPr>
-        <p:spPr>
-          <a:xfrm>
-            <a:off x="731520" y="2011680"/>
-            <a:ext cx="3657600" cy="457200"/>
+          <p:cNvPr id="3" name="Shape 1"/>
+          <p:cNvSpPr/>
+          <p:nvPr/>
+        </p:nvSpPr>
+        <p:spPr>
+          <a:xfrm>
+            <a:off x="0" y="4942332"/>
+            <a:ext cx="5029200" cy="201168"/>
+          </a:xfrm>
+          <a:prstGeom prst="rect">
+            <a:avLst/>
+          </a:prstGeom>
+          <a:solidFill>
+            <a:srgbClr val="003BA3"/>
+          </a:solidFill>
+          <a:ln/>
+        </p:spPr>
+      </p:sp>
+      <p:sp>
+        <p:nvSpPr>
+          <p:cNvPr id="4" name="Shape 2"/>
+          <p:cNvSpPr/>
+          <p:nvPr/>
+        </p:nvSpPr>
+        <p:spPr>
+          <a:xfrm>
+            <a:off x="5029200" y="4942332"/>
+            <a:ext cx="4114800" cy="201168"/>
+          </a:xfrm>
+          <a:prstGeom prst="rect">
+            <a:avLst/>
+          </a:prstGeom>
+          <a:solidFill>
+            <a:srgbClr val="4A8CFF"/>
+          </a:solidFill>
+          <a:ln/>
+        </p:spPr>
+      </p:sp>
+      <p:sp>
+        <p:nvSpPr>
+          <p:cNvPr id="5" name="Shape 3"/>
+          <p:cNvSpPr/>
+          <p:nvPr/>
+        </p:nvSpPr>
+        <p:spPr>
+          <a:xfrm>
+            <a:off x="548640" y="1005840"/>
+            <a:ext cx="3291840" cy="3657600"/>
+          </a:xfrm>
+          <a:prstGeom prst="rect">
+            <a:avLst/>
+          </a:prstGeom>
+          <a:solidFill>
+            <a:srgbClr val="F5F7FA"/>
+          </a:solidFill>
+          <a:ln/>
+        </p:spPr>
+      </p:sp>
+      <p:sp>
+        <p:nvSpPr>
+          <p:cNvPr id="6" name="Text 4"/>
+          <p:cNvSpPr/>
+          <p:nvPr/>
+        </p:nvSpPr>
+        <p:spPr>
+          <a:xfrm>
+            <a:off x="731520" y="1188720"/>
+            <a:ext cx="2926080" cy="914400"/>
           </a:xfrm>
           <a:prstGeom prst="rect">
             <a:avLst/>
@@ -6860,30 +6589,64 @@
               <a:buNone/>
             </a:pPr>
             <a:r>
-              <a:rPr lang="en-US" sz="1600" dirty="0">
+              <a:rPr lang="en-US" sz="2000" b="1" dirty="0">
                 <a:solidFill>
-                  <a:srgbClr val="4A4A5A"/>
+                  <a:srgbClr val="003BA3"/>
                 </a:solidFill>
                 <a:latin typeface="Montserrat" pitchFamily="34" charset="0"/>
                 <a:ea typeface="Montserrat" pitchFamily="34" charset="-122"/>
                 <a:cs typeface="Montserrat" pitchFamily="34" charset="-120"/>
               </a:rPr>
-              <a:t>Domande?</a:t>
-            </a:r>
-            <a:endParaRPr lang="en-US" sz="1600" dirty="0"/>
+              <a:t>Costruite</a:t>
+            </a:r>
+            <a:endParaRPr lang="en-US" sz="2000" dirty="0"/>
+          </a:p>
+          <a:p>
+            <a:pPr indent="0" marL="0">
+              <a:buNone/>
+            </a:pPr>
+            <a:r>
+              <a:rPr lang="en-US" sz="2000" b="1" dirty="0">
+                <a:solidFill>
+                  <a:srgbClr val="003BA3"/>
+                </a:solidFill>
+                <a:latin typeface="Montserrat" pitchFamily="34" charset="0"/>
+                <a:ea typeface="Montserrat" pitchFamily="34" charset="-122"/>
+                <a:cs typeface="Montserrat" pitchFamily="34" charset="-120"/>
+              </a:rPr>
+              <a:t>sistemi,</a:t>
+            </a:r>
+            <a:endParaRPr lang="en-US" sz="2000" dirty="0"/>
+          </a:p>
+          <a:p>
+            <a:pPr indent="0" marL="0">
+              <a:buNone/>
+            </a:pPr>
+            <a:r>
+              <a:rPr lang="en-US" sz="2000" b="1" dirty="0">
+                <a:solidFill>
+                  <a:srgbClr val="003BA3"/>
+                </a:solidFill>
+                <a:latin typeface="Montserrat" pitchFamily="34" charset="0"/>
+                <a:ea typeface="Montserrat" pitchFamily="34" charset="-122"/>
+                <a:cs typeface="Montserrat" pitchFamily="34" charset="-120"/>
+              </a:rPr>
+              <a:t>non prompt</a:t>
+            </a:r>
+            <a:endParaRPr lang="en-US" sz="2000" dirty="0"/>
           </a:p>
         </p:txBody>
       </p:sp>
       <p:sp>
         <p:nvSpPr>
-          <p:cNvPr id="6" name="Text 4"/>
-          <p:cNvSpPr/>
-          <p:nvPr/>
-        </p:nvSpPr>
-        <p:spPr>
-          <a:xfrm>
-            <a:off x="731520" y="2743200"/>
-            <a:ext cx="4572000" cy="2011680"/>
+          <p:cNvPr id="7" name="Text 5"/>
+          <p:cNvSpPr/>
+          <p:nvPr/>
+        </p:nvSpPr>
+        <p:spPr>
+          <a:xfrm>
+            <a:off x="731520" y="2194560"/>
+            <a:ext cx="2926080" cy="2194560"/>
           </a:xfrm>
           <a:prstGeom prst="rect">
             <a:avLst/>
@@ -6892,10 +6655,13 @@
           <a:ln/>
         </p:spPr>
         <p:txBody>
-          <a:bodyPr wrap="square" lIns="0" tIns="0" rIns="0" bIns="0" rtlCol="0" anchor="ctr"/>
+          <a:bodyPr wrap="square" lIns="0" tIns="0" rIns="0" bIns="0" rtlCol="0" anchor="t"/>
           <a:lstStyle/>
           <a:p>
             <a:pPr indent="0" marL="0">
+              <a:lnSpc>
+                <a:spcPct val="140000"/>
+              </a:lnSpc>
               <a:buNone/>
             </a:pPr>
             <a:r>
@@ -6907,39 +6673,22 @@
                 <a:ea typeface="Montserrat" pitchFamily="34" charset="-122"/>
                 <a:cs typeface="Montserrat" pitchFamily="34" charset="-120"/>
               </a:rPr>
-              <a:t>Il futuro non è l'IA che sostituisce le persone.</a:t>
+              <a:t>Smettete di chiedere all'IA di fare cose. Iniziate a costruire sistemi che sanno farle.</a:t>
             </a:r>
             <a:endParaRPr lang="en-US" sz="1200" dirty="0"/>
           </a:p>
-          <a:p>
-            <a:pPr indent="0" marL="0">
-              <a:buNone/>
-            </a:pPr>
-            <a:r>
-              <a:rPr lang="en-US" sz="1200" dirty="0">
-                <a:solidFill>
-                  <a:srgbClr val="4A4A5A"/>
-                </a:solidFill>
-                <a:latin typeface="Montserrat" pitchFamily="34" charset="0"/>
-                <a:ea typeface="Montserrat" pitchFamily="34" charset="-122"/>
-                <a:cs typeface="Montserrat" pitchFamily="34" charset="-120"/>
-              </a:rPr>
-              <a:t>È l'IA che le rende più brave nel loro mestiere.</a:t>
-            </a:r>
-            <a:endParaRPr lang="en-US" sz="1200" dirty="0"/>
-          </a:p>
         </p:txBody>
       </p:sp>
       <p:sp>
         <p:nvSpPr>
-          <p:cNvPr id="7" name="Text 5"/>
-          <p:cNvSpPr/>
-          <p:nvPr/>
-        </p:nvSpPr>
-        <p:spPr>
-          <a:xfrm>
-            <a:off x="731520" y="4389120"/>
-            <a:ext cx="3657600" cy="365760"/>
+          <p:cNvPr id="8" name="Text 6"/>
+          <p:cNvSpPr/>
+          <p:nvPr/>
+        </p:nvSpPr>
+        <p:spPr>
+          <a:xfrm>
+            <a:off x="4206240" y="1097280"/>
+            <a:ext cx="4572000" cy="320040"/>
           </a:xfrm>
           <a:prstGeom prst="rect">
             <a:avLst/>
@@ -6963,9 +6712,213 @@
                 <a:ea typeface="Montserrat" pitchFamily="34" charset="-122"/>
                 <a:cs typeface="Montserrat" pitchFamily="34" charset="-120"/>
               </a:rPr>
-              <a:t>VALUATION ANALYST</a:t>
+              <a:t>1 · Scrivete un workflow come skill</a:t>
             </a:r>
             <a:endParaRPr lang="en-US" sz="1400" dirty="0"/>
+          </a:p>
+        </p:txBody>
+      </p:sp>
+      <p:sp>
+        <p:nvSpPr>
+          <p:cNvPr id="9" name="Text 7"/>
+          <p:cNvSpPr/>
+          <p:nvPr/>
+        </p:nvSpPr>
+        <p:spPr>
+          <a:xfrm>
+            <a:off x="4206240" y="1417320"/>
+            <a:ext cx="4572000" cy="640080"/>
+          </a:xfrm>
+          <a:prstGeom prst="rect">
+            <a:avLst/>
+          </a:prstGeom>
+          <a:noFill/>
+          <a:ln/>
+        </p:spPr>
+        <p:txBody>
+          <a:bodyPr wrap="square" lIns="0" tIns="0" rIns="0" bIns="0" rtlCol="0" anchor="ctr"/>
+          <a:lstStyle/>
+          <a:p>
+            <a:pPr indent="0" marL="0">
+              <a:lnSpc>
+                <a:spcPct val="130000"/>
+              </a:lnSpc>
+              <a:buNone/>
+            </a:pPr>
+            <a:r>
+              <a:rPr lang="en-US" sz="1100" dirty="0">
+                <a:solidFill>
+                  <a:srgbClr val="4A4A5A"/>
+                </a:solidFill>
+                <a:latin typeface="Montserrat" pitchFamily="34" charset="0"/>
+                <a:ea typeface="Montserrat" pitchFamily="34" charset="-122"/>
+                <a:cs typeface="Montserrat" pitchFamily="34" charset="-120"/>
+              </a:rPr>
+              <a:t>Vincoli, step, checkpoint, errori comuni. Non serve codice: basta un documento.</a:t>
+            </a:r>
+            <a:endParaRPr lang="en-US" sz="1100" dirty="0"/>
+          </a:p>
+        </p:txBody>
+      </p:sp>
+      <p:sp>
+        <p:nvSpPr>
+          <p:cNvPr id="10" name="Text 8"/>
+          <p:cNvSpPr/>
+          <p:nvPr/>
+        </p:nvSpPr>
+        <p:spPr>
+          <a:xfrm>
+            <a:off x="4206240" y="2240280"/>
+            <a:ext cx="4572000" cy="320040"/>
+          </a:xfrm>
+          <a:prstGeom prst="rect">
+            <a:avLst/>
+          </a:prstGeom>
+          <a:noFill/>
+          <a:ln/>
+        </p:spPr>
+        <p:txBody>
+          <a:bodyPr wrap="square" lIns="0" tIns="0" rIns="0" bIns="0" rtlCol="0" anchor="ctr"/>
+          <a:lstStyle/>
+          <a:p>
+            <a:pPr indent="0" marL="0">
+              <a:buNone/>
+            </a:pPr>
+            <a:r>
+              <a:rPr lang="en-US" sz="1400" b="1" dirty="0">
+                <a:solidFill>
+                  <a:srgbClr val="003BA3"/>
+                </a:solidFill>
+                <a:latin typeface="Montserrat" pitchFamily="34" charset="0"/>
+                <a:ea typeface="Montserrat" pitchFamily="34" charset="-122"/>
+                <a:cs typeface="Montserrat" pitchFamily="34" charset="-120"/>
+              </a:rPr>
+              <a:t>2 · Mappate i decision gate</a:t>
+            </a:r>
+            <a:endParaRPr lang="en-US" sz="1400" dirty="0"/>
+          </a:p>
+        </p:txBody>
+      </p:sp>
+      <p:sp>
+        <p:nvSpPr>
+          <p:cNvPr id="11" name="Text 9"/>
+          <p:cNvSpPr/>
+          <p:nvPr/>
+        </p:nvSpPr>
+        <p:spPr>
+          <a:xfrm>
+            <a:off x="4206240" y="2560320"/>
+            <a:ext cx="4572000" cy="640080"/>
+          </a:xfrm>
+          <a:prstGeom prst="rect">
+            <a:avLst/>
+          </a:prstGeom>
+          <a:noFill/>
+          <a:ln/>
+        </p:spPr>
+        <p:txBody>
+          <a:bodyPr wrap="square" lIns="0" tIns="0" rIns="0" bIns="0" rtlCol="0" anchor="ctr"/>
+          <a:lstStyle/>
+          <a:p>
+            <a:pPr indent="0" marL="0">
+              <a:lnSpc>
+                <a:spcPct val="130000"/>
+              </a:lnSpc>
+              <a:buNone/>
+            </a:pPr>
+            <a:r>
+              <a:rPr lang="en-US" sz="1100" dirty="0">
+                <a:solidFill>
+                  <a:srgbClr val="4A4A5A"/>
+                </a:solidFill>
+                <a:latin typeface="Montserrat" pitchFamily="34" charset="0"/>
+                <a:ea typeface="Montserrat" pitchFamily="34" charset="-122"/>
+                <a:cs typeface="Montserrat" pitchFamily="34" charset="-120"/>
+              </a:rPr>
+              <a:t>Dove l'IA procede da sola e dove si ferma. Usate la matrice rischio/reversibilità.</a:t>
+            </a:r>
+            <a:endParaRPr lang="en-US" sz="1100" dirty="0"/>
+          </a:p>
+        </p:txBody>
+      </p:sp>
+      <p:sp>
+        <p:nvSpPr>
+          <p:cNvPr id="12" name="Text 10"/>
+          <p:cNvSpPr/>
+          <p:nvPr/>
+        </p:nvSpPr>
+        <p:spPr>
+          <a:xfrm>
+            <a:off x="4206240" y="3383280"/>
+            <a:ext cx="4572000" cy="320040"/>
+          </a:xfrm>
+          <a:prstGeom prst="rect">
+            <a:avLst/>
+          </a:prstGeom>
+          <a:noFill/>
+          <a:ln/>
+        </p:spPr>
+        <p:txBody>
+          <a:bodyPr wrap="square" lIns="0" tIns="0" rIns="0" bIns="0" rtlCol="0" anchor="ctr"/>
+          <a:lstStyle/>
+          <a:p>
+            <a:pPr indent="0" marL="0">
+              <a:buNone/>
+            </a:pPr>
+            <a:r>
+              <a:rPr lang="en-US" sz="1400" b="1" dirty="0">
+                <a:solidFill>
+                  <a:srgbClr val="003BA3"/>
+                </a:solidFill>
+                <a:latin typeface="Montserrat" pitchFamily="34" charset="0"/>
+                <a:ea typeface="Montserrat" pitchFamily="34" charset="-122"/>
+                <a:cs typeface="Montserrat" pitchFamily="34" charset="-120"/>
+              </a:rPr>
+              <a:t>3 · Partite piccoli e misurate</a:t>
+            </a:r>
+            <a:endParaRPr lang="en-US" sz="1400" dirty="0"/>
+          </a:p>
+        </p:txBody>
+      </p:sp>
+      <p:sp>
+        <p:nvSpPr>
+          <p:cNvPr id="13" name="Text 11"/>
+          <p:cNvSpPr/>
+          <p:nvPr/>
+        </p:nvSpPr>
+        <p:spPr>
+          <a:xfrm>
+            <a:off x="4206240" y="3703320"/>
+            <a:ext cx="4572000" cy="640080"/>
+          </a:xfrm>
+          <a:prstGeom prst="rect">
+            <a:avLst/>
+          </a:prstGeom>
+          <a:noFill/>
+          <a:ln/>
+        </p:spPr>
+        <p:txBody>
+          <a:bodyPr wrap="square" lIns="0" tIns="0" rIns="0" bIns="0" rtlCol="0" anchor="ctr"/>
+          <a:lstStyle/>
+          <a:p>
+            <a:pPr indent="0" marL="0">
+              <a:lnSpc>
+                <a:spcPct val="130000"/>
+              </a:lnSpc>
+              <a:buNone/>
+            </a:pPr>
+            <a:r>
+              <a:rPr lang="en-US" sz="1100" dirty="0">
+                <a:solidFill>
+                  <a:srgbClr val="4A4A5A"/>
+                </a:solidFill>
+                <a:latin typeface="Montserrat" pitchFamily="34" charset="0"/>
+                <a:ea typeface="Montserrat" pitchFamily="34" charset="-122"/>
+                <a:cs typeface="Montserrat" pitchFamily="34" charset="-120"/>
+              </a:rPr>
+              <a:t>Un agente, una skill, un workflow. Misurate gli output utilizzabili, non i prompt.</a:t>
+            </a:r>
+            <a:endParaRPr lang="en-US" sz="1100" dirty="0"/>
           </a:p>
         </p:txBody>
       </p:sp>
@@ -6995,8 +6948,8 @@
         </p:nvSpPr>
         <p:spPr>
           <a:xfrm>
-            <a:off x="2560320" y="-274320"/>
-            <a:ext cx="1645920" cy="2926080"/>
+            <a:off x="7498080" y="0"/>
+            <a:ext cx="1645920" cy="3200400"/>
           </a:xfrm>
           <a:prstGeom prst="rect">
             <a:avLst/>
@@ -7015,8 +6968,8 @@
         </p:nvSpPr>
         <p:spPr>
           <a:xfrm>
-            <a:off x="1371600" y="2377440"/>
-            <a:ext cx="1645920" cy="1828800"/>
+            <a:off x="6217920" y="2926080"/>
+            <a:ext cx="1645920" cy="2217420"/>
           </a:xfrm>
           <a:prstGeom prst="rect">
             <a:avLst/>
@@ -7035,8 +6988,8 @@
         </p:nvSpPr>
         <p:spPr>
           <a:xfrm>
-            <a:off x="4572000" y="914400"/>
-            <a:ext cx="4114800" cy="1097280"/>
+            <a:off x="731520" y="731520"/>
+            <a:ext cx="5486400" cy="1371600"/>
           </a:xfrm>
           <a:prstGeom prst="rect">
             <a:avLst/>
@@ -7048,50 +7001,11 @@
           <a:bodyPr wrap="square" lIns="0" tIns="0" rIns="0" bIns="0" rtlCol="0" anchor="ctr"/>
           <a:lstStyle/>
           <a:p>
-            <a:pPr algn="ctr" indent="0" marL="0">
+            <a:pPr indent="0" marL="0">
               <a:buNone/>
             </a:pPr>
             <a:r>
-              <a:rPr lang="en-US" sz="7200" b="1" dirty="0">
-                <a:solidFill>
-                  <a:srgbClr val="4A8CFF"/>
-                </a:solidFill>
-                <a:latin typeface="Montserrat" pitchFamily="34" charset="0"/>
-                <a:ea typeface="Montserrat" pitchFamily="34" charset="-122"/>
-                <a:cs typeface="Montserrat" pitchFamily="34" charset="-120"/>
-              </a:rPr>
-              <a:t>+</a:t>
-            </a:r>
-            <a:endParaRPr lang="en-US" sz="7200" dirty="0"/>
-          </a:p>
-        </p:txBody>
-      </p:sp>
-      <p:sp>
-        <p:nvSpPr>
-          <p:cNvPr id="5" name="Text 3"/>
-          <p:cNvSpPr/>
-          <p:nvPr/>
-        </p:nvSpPr>
-        <p:spPr>
-          <a:xfrm>
-            <a:off x="4572000" y="2011680"/>
-            <a:ext cx="4114800" cy="731520"/>
-          </a:xfrm>
-          <a:prstGeom prst="rect">
-            <a:avLst/>
-          </a:prstGeom>
-          <a:noFill/>
-          <a:ln/>
-        </p:spPr>
-        <p:txBody>
-          <a:bodyPr wrap="square" lIns="0" tIns="0" rIns="0" bIns="0" rtlCol="0" anchor="ctr"/>
-          <a:lstStyle/>
-          <a:p>
-            <a:pPr algn="ctr" indent="0" marL="0">
-              <a:buNone/>
-            </a:pPr>
-            <a:r>
-              <a:rPr lang="en-US" sz="3600" b="1" dirty="0">
+              <a:rPr lang="en-US" sz="4800" b="1" dirty="0">
                 <a:solidFill>
                   <a:srgbClr val="003BA3"/>
                 </a:solidFill>
@@ -7099,22 +7013,22 @@
                 <a:ea typeface="Montserrat" pitchFamily="34" charset="-122"/>
                 <a:cs typeface="Montserrat" pitchFamily="34" charset="-120"/>
               </a:rPr>
-              <a:t>Backup</a:t>
-            </a:r>
-            <a:endParaRPr lang="en-US" sz="3600" dirty="0"/>
+              <a:t>Grazie</a:t>
+            </a:r>
+            <a:endParaRPr lang="en-US" sz="4800" dirty="0"/>
           </a:p>
         </p:txBody>
       </p:sp>
       <p:sp>
         <p:nvSpPr>
-          <p:cNvPr id="6" name="Text 4"/>
-          <p:cNvSpPr/>
-          <p:nvPr/>
-        </p:nvSpPr>
-        <p:spPr>
-          <a:xfrm>
-            <a:off x="4572000" y="2743200"/>
-            <a:ext cx="4114800" cy="457200"/>
+          <p:cNvPr id="5" name="Text 3"/>
+          <p:cNvSpPr/>
+          <p:nvPr/>
+        </p:nvSpPr>
+        <p:spPr>
+          <a:xfrm>
+            <a:off x="731520" y="2011680"/>
+            <a:ext cx="3657600" cy="457200"/>
           </a:xfrm>
           <a:prstGeom prst="rect">
             <a:avLst/>
@@ -7126,11 +7040,11 @@
           <a:bodyPr wrap="square" lIns="0" tIns="0" rIns="0" bIns="0" rtlCol="0" anchor="ctr"/>
           <a:lstStyle/>
           <a:p>
-            <a:pPr algn="ctr" indent="0" marL="0">
+            <a:pPr indent="0" marL="0">
               <a:buNone/>
             </a:pPr>
             <a:r>
-              <a:rPr lang="en-US" sz="1400" dirty="0">
+              <a:rPr lang="en-US" sz="1600" dirty="0">
                 <a:solidFill>
                   <a:srgbClr val="4A4A5A"/>
                 </a:solidFill>
@@ -7138,7 +7052,102 @@
                 <a:ea typeface="Montserrat" pitchFamily="34" charset="-122"/>
                 <a:cs typeface="Montserrat" pitchFamily="34" charset="-120"/>
               </a:rPr>
-              <a:t>Approfondimenti per le domande</a:t>
+              <a:t>Domande?</a:t>
+            </a:r>
+            <a:endParaRPr lang="en-US" sz="1600" dirty="0"/>
+          </a:p>
+        </p:txBody>
+      </p:sp>
+      <p:sp>
+        <p:nvSpPr>
+          <p:cNvPr id="6" name="Text 4"/>
+          <p:cNvSpPr/>
+          <p:nvPr/>
+        </p:nvSpPr>
+        <p:spPr>
+          <a:xfrm>
+            <a:off x="731520" y="2743200"/>
+            <a:ext cx="4572000" cy="2011680"/>
+          </a:xfrm>
+          <a:prstGeom prst="rect">
+            <a:avLst/>
+          </a:prstGeom>
+          <a:noFill/>
+          <a:ln/>
+        </p:spPr>
+        <p:txBody>
+          <a:bodyPr wrap="square" lIns="0" tIns="0" rIns="0" bIns="0" rtlCol="0" anchor="ctr"/>
+          <a:lstStyle/>
+          <a:p>
+            <a:pPr indent="0" marL="0">
+              <a:buNone/>
+            </a:pPr>
+            <a:r>
+              <a:rPr lang="en-US" sz="1200" dirty="0">
+                <a:solidFill>
+                  <a:srgbClr val="4A4A5A"/>
+                </a:solidFill>
+                <a:latin typeface="Montserrat" pitchFamily="34" charset="0"/>
+                <a:ea typeface="Montserrat" pitchFamily="34" charset="-122"/>
+                <a:cs typeface="Montserrat" pitchFamily="34" charset="-120"/>
+              </a:rPr>
+              <a:t>Il futuro non è l'IA che sostituisce le persone.</a:t>
+            </a:r>
+            <a:endParaRPr lang="en-US" sz="1200" dirty="0"/>
+          </a:p>
+          <a:p>
+            <a:pPr indent="0" marL="0">
+              <a:buNone/>
+            </a:pPr>
+            <a:r>
+              <a:rPr lang="en-US" sz="1200" dirty="0">
+                <a:solidFill>
+                  <a:srgbClr val="4A4A5A"/>
+                </a:solidFill>
+                <a:latin typeface="Montserrat" pitchFamily="34" charset="0"/>
+                <a:ea typeface="Montserrat" pitchFamily="34" charset="-122"/>
+                <a:cs typeface="Montserrat" pitchFamily="34" charset="-120"/>
+              </a:rPr>
+              <a:t>È l'IA che le rende più brave nel loro mestiere.</a:t>
+            </a:r>
+            <a:endParaRPr lang="en-US" sz="1200" dirty="0"/>
+          </a:p>
+        </p:txBody>
+      </p:sp>
+      <p:sp>
+        <p:nvSpPr>
+          <p:cNvPr id="7" name="Text 5"/>
+          <p:cNvSpPr/>
+          <p:nvPr/>
+        </p:nvSpPr>
+        <p:spPr>
+          <a:xfrm>
+            <a:off x="731520" y="4389120"/>
+            <a:ext cx="3657600" cy="365760"/>
+          </a:xfrm>
+          <a:prstGeom prst="rect">
+            <a:avLst/>
+          </a:prstGeom>
+          <a:noFill/>
+          <a:ln/>
+        </p:spPr>
+        <p:txBody>
+          <a:bodyPr wrap="square" lIns="0" tIns="0" rIns="0" bIns="0" rtlCol="0" anchor="ctr"/>
+          <a:lstStyle/>
+          <a:p>
+            <a:pPr indent="0" marL="0">
+              <a:buNone/>
+            </a:pPr>
+            <a:r>
+              <a:rPr lang="en-US" sz="1400" b="1" dirty="0">
+                <a:solidFill>
+                  <a:srgbClr val="003BA3"/>
+                </a:solidFill>
+                <a:latin typeface="Montserrat" pitchFamily="34" charset="0"/>
+                <a:ea typeface="Montserrat" pitchFamily="34" charset="-122"/>
+                <a:cs typeface="Montserrat" pitchFamily="34" charset="-120"/>
+              </a:rPr>
+              <a:t>VALUATION ANALYST</a:t>
             </a:r>
             <a:endParaRPr lang="en-US" sz="1400" dirty="0"/>
           </a:p>
@@ -7164,6 +7173,181 @@
       <p:grpSpPr/>
       <p:sp>
         <p:nvSpPr>
+          <p:cNvPr id="2" name="Shape 0"/>
+          <p:cNvSpPr/>
+          <p:nvPr/>
+        </p:nvSpPr>
+        <p:spPr>
+          <a:xfrm>
+            <a:off x="2560320" y="-274320"/>
+            <a:ext cx="1645920" cy="2926080"/>
+          </a:xfrm>
+          <a:prstGeom prst="rect">
+            <a:avLst/>
+          </a:prstGeom>
+          <a:solidFill>
+            <a:srgbClr val="4A8CFF"/>
+          </a:solidFill>
+          <a:ln/>
+        </p:spPr>
+      </p:sp>
+      <p:sp>
+        <p:nvSpPr>
+          <p:cNvPr id="3" name="Shape 1"/>
+          <p:cNvSpPr/>
+          <p:nvPr/>
+        </p:nvSpPr>
+        <p:spPr>
+          <a:xfrm>
+            <a:off x="1371600" y="2377440"/>
+            <a:ext cx="1645920" cy="1828800"/>
+          </a:xfrm>
+          <a:prstGeom prst="rect">
+            <a:avLst/>
+          </a:prstGeom>
+          <a:solidFill>
+            <a:srgbClr val="F5F7FA"/>
+          </a:solidFill>
+          <a:ln/>
+        </p:spPr>
+      </p:sp>
+      <p:sp>
+        <p:nvSpPr>
+          <p:cNvPr id="4" name="Text 2"/>
+          <p:cNvSpPr/>
+          <p:nvPr/>
+        </p:nvSpPr>
+        <p:spPr>
+          <a:xfrm>
+            <a:off x="4572000" y="914400"/>
+            <a:ext cx="4114800" cy="1097280"/>
+          </a:xfrm>
+          <a:prstGeom prst="rect">
+            <a:avLst/>
+          </a:prstGeom>
+          <a:noFill/>
+          <a:ln/>
+        </p:spPr>
+        <p:txBody>
+          <a:bodyPr wrap="square" lIns="0" tIns="0" rIns="0" bIns="0" rtlCol="0" anchor="ctr"/>
+          <a:lstStyle/>
+          <a:p>
+            <a:pPr algn="ctr" indent="0" marL="0">
+              <a:buNone/>
+            </a:pPr>
+            <a:r>
+              <a:rPr lang="en-US" sz="7200" b="1" dirty="0">
+                <a:solidFill>
+                  <a:srgbClr val="4A8CFF"/>
+                </a:solidFill>
+                <a:latin typeface="Montserrat" pitchFamily="34" charset="0"/>
+                <a:ea typeface="Montserrat" pitchFamily="34" charset="-122"/>
+                <a:cs typeface="Montserrat" pitchFamily="34" charset="-120"/>
+              </a:rPr>
+              <a:t>+</a:t>
+            </a:r>
+            <a:endParaRPr lang="en-US" sz="7200" dirty="0"/>
+          </a:p>
+        </p:txBody>
+      </p:sp>
+      <p:sp>
+        <p:nvSpPr>
+          <p:cNvPr id="5" name="Text 3"/>
+          <p:cNvSpPr/>
+          <p:nvPr/>
+        </p:nvSpPr>
+        <p:spPr>
+          <a:xfrm>
+            <a:off x="4572000" y="2011680"/>
+            <a:ext cx="4114800" cy="731520"/>
+          </a:xfrm>
+          <a:prstGeom prst="rect">
+            <a:avLst/>
+          </a:prstGeom>
+          <a:noFill/>
+          <a:ln/>
+        </p:spPr>
+        <p:txBody>
+          <a:bodyPr wrap="square" lIns="0" tIns="0" rIns="0" bIns="0" rtlCol="0" anchor="ctr"/>
+          <a:lstStyle/>
+          <a:p>
+            <a:pPr algn="ctr" indent="0" marL="0">
+              <a:buNone/>
+            </a:pPr>
+            <a:r>
+              <a:rPr lang="en-US" sz="3600" b="1" dirty="0">
+                <a:solidFill>
+                  <a:srgbClr val="003BA3"/>
+                </a:solidFill>
+                <a:latin typeface="Montserrat" pitchFamily="34" charset="0"/>
+                <a:ea typeface="Montserrat" pitchFamily="34" charset="-122"/>
+                <a:cs typeface="Montserrat" pitchFamily="34" charset="-120"/>
+              </a:rPr>
+              <a:t>Backup</a:t>
+            </a:r>
+            <a:endParaRPr lang="en-US" sz="3600" dirty="0"/>
+          </a:p>
+        </p:txBody>
+      </p:sp>
+      <p:sp>
+        <p:nvSpPr>
+          <p:cNvPr id="6" name="Text 4"/>
+          <p:cNvSpPr/>
+          <p:nvPr/>
+        </p:nvSpPr>
+        <p:spPr>
+          <a:xfrm>
+            <a:off x="4572000" y="2743200"/>
+            <a:ext cx="4114800" cy="457200"/>
+          </a:xfrm>
+          <a:prstGeom prst="rect">
+            <a:avLst/>
+          </a:prstGeom>
+          <a:noFill/>
+          <a:ln/>
+        </p:spPr>
+        <p:txBody>
+          <a:bodyPr wrap="square" lIns="0" tIns="0" rIns="0" bIns="0" rtlCol="0" anchor="ctr"/>
+          <a:lstStyle/>
+          <a:p>
+            <a:pPr algn="ctr" indent="0" marL="0">
+              <a:buNone/>
+            </a:pPr>
+            <a:r>
+              <a:rPr lang="en-US" sz="1400" dirty="0">
+                <a:solidFill>
+                  <a:srgbClr val="4A4A5A"/>
+                </a:solidFill>
+                <a:latin typeface="Montserrat" pitchFamily="34" charset="0"/>
+                <a:ea typeface="Montserrat" pitchFamily="34" charset="-122"/>
+                <a:cs typeface="Montserrat" pitchFamily="34" charset="-120"/>
+              </a:rPr>
+              <a:t>Approfondimenti per le domande</a:t>
+            </a:r>
+            <a:endParaRPr lang="en-US" sz="1400" dirty="0"/>
+          </a:p>
+        </p:txBody>
+      </p:sp>
+    </p:spTree>
+  </p:cSld>
+  <p:clrMapOvr>
+    <a:masterClrMapping/>
+  </p:clrMapOvr>
+</p:sld>
+</file>
+
+<file path=ppt/slides/slide39.xml><?xml version="1.0" encoding="utf-8"?>
+<p:sld xmlns:a="http://schemas.openxmlformats.org/drawingml/2006/main" xmlns:p="http://schemas.openxmlformats.org/presentationml/2006/main" xmlns:r="http://schemas.openxmlformats.org/officeDocument/2006/relationships">
+  <p:cSld>
+    <p:spTree>
+      <p:nvGrpSpPr>
+        <p:cNvPr id="1" name=""/>
+        <p:cNvGrpSpPr/>
+        <p:nvPr/>
+      </p:nvGrpSpPr>
+      <p:grpSpPr/>
+      <p:sp>
+        <p:nvSpPr>
           <p:cNvPr id="2" name="Text 0"/>
           <p:cNvSpPr/>
           <p:nvPr/>
@@ -7895,7 +8079,7 @@
 </p:sld>
 </file>
 
-<file path=ppt/slides/slide39.xml><?xml version="1.0" encoding="utf-8"?>
+<file path=ppt/slides/slide40.xml><?xml version="1.0" encoding="utf-8"?>
 <p:sld xmlns:a="http://schemas.openxmlformats.org/drawingml/2006/main" xmlns:p="http://schemas.openxmlformats.org/presentationml/2006/main" xmlns:r="http://schemas.openxmlformats.org/officeDocument/2006/relationships">
   <p:cSld>
     <p:spTree>

</xml_diff>